<commit_message>
UTI-deck: inhoudelijke aanvullingen op slides 4, 5, 7 en 15
Slide 4 krijgt een derde kostenpost erbij: geen tijd voor bijles en remedial
support. Drie kolommen nu, bewust ongelijk verdeeld zodat 2-4 uur per dag zijn
overwicht houdt.

Slide 5 vervangt de twee groeicijfers door het North Star-doel van twee nieuwe
campussen per jaar.

Slide 7 benoemt overwerk als variabele kostenpost bij de tijdwinst, en hogere
doorstroom als opbrengst bij het schalen.

Slide 15 gaat van vier naar vijf stappen, met legal en IT bij de validatie,
trainingsondersteuning bij de pilot en december 2026 als streefdatum. De as
kantelt daarvoor naar verticaal: liggend werd een kolom 298 pixels breed en
liep de langste stap door de voetlijn, en onder de 32 pixels zakken mag niet.

Co-Authored-By: Claude Opus 5 <noreply@anthropic.com>
Claude-Session: https://claude.ai/code/session_01NLHJ2Mm4EhXvCdoUv8TcEZ
</commit_message>
<xml_diff>
--- a/projects/uti/deck/UTI-Eduface-deck.pptx
+++ b/projects/uti/deck/UTI-Eduface-deck.pptx
@@ -9244,8 +9244,8 @@
         </p:nvSpPr>
         <p:spPr>
           <a:xfrm>
-            <a:off x="1981200" y="2717800"/>
-            <a:ext cx="8229600" cy="12700"/>
+            <a:off x="1466850" y="2070100"/>
+            <a:ext cx="12700" cy="3251200"/>
           </a:xfrm>
           <a:prstGeom prst="rect">
             <a:avLst/>
@@ -9288,12 +9288,12 @@
         </p:nvSpPr>
         <p:spPr>
           <a:xfrm>
-            <a:off x="1625600" y="2362200"/>
-            <a:ext cx="711200" cy="711200"/>
+            <a:off x="1219200" y="1816100"/>
+            <a:ext cx="508000" cy="508000"/>
           </a:xfrm>
           <a:prstGeom prst="roundRect">
             <a:avLst>
-              <a:gd name="adj" fmla="val 19642"/>
+              <a:gd name="adj" fmla="val 22500"/>
             </a:avLst>
           </a:prstGeom>
           <a:solidFill>
@@ -9342,8 +9342,8 @@
         </p:blipFill>
         <p:spPr>
           <a:xfrm>
-            <a:off x="1803400" y="2540000"/>
-            <a:ext cx="355600" cy="355600"/>
+            <a:off x="1346200" y="1943100"/>
+            <a:ext cx="254000" cy="254000"/>
           </a:xfrm>
           <a:prstGeom prst="rect">
             <a:avLst/>
@@ -9358,21 +9358,21 @@
         </p:nvSpPr>
         <p:spPr>
           <a:xfrm>
-            <a:off x="762000" y="2032000"/>
-            <a:ext cx="2438400" cy="228600"/>
-          </a:xfrm>
-          <a:prstGeom prst="rect">
-            <a:avLst/>
-          </a:prstGeom>
-          <a:noFill/>
-        </p:spPr>
-        <p:txBody>
-          <a:bodyPr wrap="square" lIns="0" rIns="0" tIns="0" bIns="0">
-            <a:spAutoFit/>
-          </a:bodyPr>
-          <a:lstStyle/>
-          <a:p>
-            <a:pPr algn="ctr">
+            <a:off x="762000" y="1955800"/>
+            <a:ext cx="355600" cy="228600"/>
+          </a:xfrm>
+          <a:prstGeom prst="rect">
+            <a:avLst/>
+          </a:prstGeom>
+          <a:noFill/>
+        </p:spPr>
+        <p:txBody>
+          <a:bodyPr wrap="square" lIns="0" rIns="0" tIns="0" bIns="0">
+            <a:spAutoFit/>
+          </a:bodyPr>
+          <a:lstStyle/>
+          <a:p>
+            <a:pPr algn="l">
               <a:lnSpc>
                 <a:spcPct val="100000"/>
               </a:lnSpc>
@@ -9397,27 +9397,27 @@
         </p:nvSpPr>
         <p:spPr>
           <a:xfrm>
-            <a:off x="762000" y="3403600"/>
-            <a:ext cx="2438400" cy="736600"/>
-          </a:xfrm>
-          <a:prstGeom prst="rect">
-            <a:avLst/>
-          </a:prstGeom>
-          <a:noFill/>
-        </p:spPr>
-        <p:txBody>
-          <a:bodyPr wrap="square" lIns="0" rIns="0" tIns="0" bIns="0">
-            <a:spAutoFit/>
-          </a:bodyPr>
-          <a:lstStyle/>
-          <a:p>
-            <a:pPr algn="ctr">
-              <a:lnSpc>
-                <a:spcPct val="118000"/>
-              </a:lnSpc>
-            </a:pPr>
-            <a:r>
-              <a:rPr sz="2200" b="1">
+            <a:off x="1981200" y="1765300"/>
+            <a:ext cx="2159000" cy="528320"/>
+          </a:xfrm>
+          <a:prstGeom prst="rect">
+            <a:avLst/>
+          </a:prstGeom>
+          <a:noFill/>
+        </p:spPr>
+        <p:txBody>
+          <a:bodyPr wrap="square" lIns="0" rIns="0" tIns="0" bIns="0">
+            <a:spAutoFit/>
+          </a:bodyPr>
+          <a:lstStyle/>
+          <a:p>
+            <a:pPr algn="l">
+              <a:lnSpc>
+                <a:spcPct val="120000"/>
+              </a:lnSpc>
+            </a:pPr>
+            <a:r>
+              <a:rPr sz="1600" b="1">
                 <a:solidFill>
                   <a:srgbClr val="FFFFFF"/>
                 </a:solidFill>
@@ -9427,13 +9427,13 @@
             </a:r>
           </a:p>
           <a:p>
-            <a:pPr algn="ctr">
-              <a:lnSpc>
-                <a:spcPct val="118000"/>
-              </a:lnSpc>
-            </a:pPr>
-            <a:r>
-              <a:rPr sz="2200" b="1">
+            <a:pPr algn="l">
+              <a:lnSpc>
+                <a:spcPct val="120000"/>
+              </a:lnSpc>
+            </a:pPr>
+            <a:r>
+              <a:rPr sz="1600" b="1">
                 <a:solidFill>
                   <a:srgbClr val="FFFFFF"/>
                 </a:solidFill>
@@ -9452,23 +9452,23 @@
         </p:nvSpPr>
         <p:spPr>
           <a:xfrm>
-            <a:off x="762000" y="4267200"/>
-            <a:ext cx="2438400" cy="952500"/>
-          </a:xfrm>
-          <a:prstGeom prst="rect">
-            <a:avLst/>
-          </a:prstGeom>
-          <a:noFill/>
-        </p:spPr>
-        <p:txBody>
-          <a:bodyPr wrap="square" lIns="0" rIns="0" tIns="0" bIns="0">
-            <a:spAutoFit/>
-          </a:bodyPr>
-          <a:lstStyle/>
-          <a:p>
-            <a:pPr algn="ctr">
-              <a:lnSpc>
-                <a:spcPct val="140000"/>
+            <a:off x="4445000" y="1765300"/>
+            <a:ext cx="6985000" cy="528320"/>
+          </a:xfrm>
+          <a:prstGeom prst="rect">
+            <a:avLst/>
+          </a:prstGeom>
+          <a:noFill/>
+        </p:spPr>
+        <p:txBody>
+          <a:bodyPr wrap="square" lIns="0" rIns="0" tIns="0" bIns="0">
+            <a:spAutoFit/>
+          </a:bodyPr>
+          <a:lstStyle/>
+          <a:p>
+            <a:pPr algn="l">
+              <a:lnSpc>
+                <a:spcPct val="145000"/>
               </a:lnSpc>
             </a:pPr>
             <a:r>
@@ -9478,39 +9478,7 @@
                 </a:solidFill>
                 <a:latin typeface="Inter"/>
               </a:rPr>
-              <a:t>Gauge with the Executive</a:t>
-            </a:r>
-          </a:p>
-          <a:p>
-            <a:pPr algn="ctr">
-              <a:lnSpc>
-                <a:spcPct val="140000"/>
-              </a:lnSpc>
-            </a:pPr>
-            <a:r>
-              <a:rPr sz="1600" b="0">
-                <a:solidFill>
-                  <a:srgbClr val="9EABB1"/>
-                </a:solidFill>
-                <a:latin typeface="Inter"/>
-              </a:rPr>
-              <a:t>Board whether this is</a:t>
-            </a:r>
-          </a:p>
-          <a:p>
-            <a:pPr algn="ctr">
-              <a:lnSpc>
-                <a:spcPct val="140000"/>
-              </a:lnSpc>
-            </a:pPr>
-            <a:r>
-              <a:rPr sz="1600" b="0">
-                <a:solidFill>
-                  <a:srgbClr val="9EABB1"/>
-                </a:solidFill>
-                <a:latin typeface="Inter"/>
-              </a:rPr>
-              <a:t>a priority now.</a:t>
+              <a:t>Gauge with the Executive Board whether this is a priority now.</a:t>
             </a:r>
           </a:p>
         </p:txBody>
@@ -9523,12 +9491,12 @@
         </p:nvSpPr>
         <p:spPr>
           <a:xfrm>
-            <a:off x="4368800" y="2362200"/>
-            <a:ext cx="711200" cy="711200"/>
+            <a:off x="1219200" y="2628900"/>
+            <a:ext cx="508000" cy="508000"/>
           </a:xfrm>
           <a:prstGeom prst="roundRect">
             <a:avLst>
-              <a:gd name="adj" fmla="val 19642"/>
+              <a:gd name="adj" fmla="val 22500"/>
             </a:avLst>
           </a:prstGeom>
           <a:solidFill>
@@ -9577,8 +9545,8 @@
         </p:blipFill>
         <p:spPr>
           <a:xfrm>
-            <a:off x="4546600" y="2540000"/>
-            <a:ext cx="355600" cy="355600"/>
+            <a:off x="1346200" y="2755900"/>
+            <a:ext cx="254000" cy="254000"/>
           </a:xfrm>
           <a:prstGeom prst="rect">
             <a:avLst/>
@@ -9593,21 +9561,21 @@
         </p:nvSpPr>
         <p:spPr>
           <a:xfrm>
-            <a:off x="3505200" y="2032000"/>
-            <a:ext cx="2438400" cy="228600"/>
-          </a:xfrm>
-          <a:prstGeom prst="rect">
-            <a:avLst/>
-          </a:prstGeom>
-          <a:noFill/>
-        </p:spPr>
-        <p:txBody>
-          <a:bodyPr wrap="square" lIns="0" rIns="0" tIns="0" bIns="0">
-            <a:spAutoFit/>
-          </a:bodyPr>
-          <a:lstStyle/>
-          <a:p>
-            <a:pPr algn="ctr">
+            <a:off x="762000" y="2768600"/>
+            <a:ext cx="355600" cy="228600"/>
+          </a:xfrm>
+          <a:prstGeom prst="rect">
+            <a:avLst/>
+          </a:prstGeom>
+          <a:noFill/>
+        </p:spPr>
+        <p:txBody>
+          <a:bodyPr wrap="square" lIns="0" rIns="0" tIns="0" bIns="0">
+            <a:spAutoFit/>
+          </a:bodyPr>
+          <a:lstStyle/>
+          <a:p>
+            <a:pPr algn="l">
               <a:lnSpc>
                 <a:spcPct val="100000"/>
               </a:lnSpc>
@@ -9632,27 +9600,27 @@
         </p:nvSpPr>
         <p:spPr>
           <a:xfrm>
-            <a:off x="3505200" y="3403600"/>
-            <a:ext cx="2438400" cy="736600"/>
-          </a:xfrm>
-          <a:prstGeom prst="rect">
-            <a:avLst/>
-          </a:prstGeom>
-          <a:noFill/>
-        </p:spPr>
-        <p:txBody>
-          <a:bodyPr wrap="square" lIns="0" rIns="0" tIns="0" bIns="0">
-            <a:spAutoFit/>
-          </a:bodyPr>
-          <a:lstStyle/>
-          <a:p>
-            <a:pPr algn="ctr">
-              <a:lnSpc>
-                <a:spcPct val="118000"/>
-              </a:lnSpc>
-            </a:pPr>
-            <a:r>
-              <a:rPr sz="2200" b="1">
+            <a:off x="1981200" y="2578100"/>
+            <a:ext cx="2159000" cy="528320"/>
+          </a:xfrm>
+          <a:prstGeom prst="rect">
+            <a:avLst/>
+          </a:prstGeom>
+          <a:noFill/>
+        </p:spPr>
+        <p:txBody>
+          <a:bodyPr wrap="square" lIns="0" rIns="0" tIns="0" bIns="0">
+            <a:spAutoFit/>
+          </a:bodyPr>
+          <a:lstStyle/>
+          <a:p>
+            <a:pPr algn="l">
+              <a:lnSpc>
+                <a:spcPct val="120000"/>
+              </a:lnSpc>
+            </a:pPr>
+            <a:r>
+              <a:rPr sz="1600" b="1">
                 <a:solidFill>
                   <a:srgbClr val="FFFFFF"/>
                 </a:solidFill>
@@ -9662,13 +9630,13 @@
             </a:r>
           </a:p>
           <a:p>
-            <a:pPr algn="ctr">
-              <a:lnSpc>
-                <a:spcPct val="118000"/>
-              </a:lnSpc>
-            </a:pPr>
-            <a:r>
-              <a:rPr sz="2200" b="1">
+            <a:pPr algn="l">
+              <a:lnSpc>
+                <a:spcPct val="120000"/>
+              </a:lnSpc>
+            </a:pPr>
+            <a:r>
+              <a:rPr sz="1600" b="1">
                 <a:solidFill>
                   <a:srgbClr val="FFFFFF"/>
                 </a:solidFill>
@@ -9687,23 +9655,23 @@
         </p:nvSpPr>
         <p:spPr>
           <a:xfrm>
-            <a:off x="3505200" y="4267200"/>
-            <a:ext cx="2438400" cy="952500"/>
-          </a:xfrm>
-          <a:prstGeom prst="rect">
-            <a:avLst/>
-          </a:prstGeom>
-          <a:noFill/>
-        </p:spPr>
-        <p:txBody>
-          <a:bodyPr wrap="square" lIns="0" rIns="0" tIns="0" bIns="0">
-            <a:spAutoFit/>
-          </a:bodyPr>
-          <a:lstStyle/>
-          <a:p>
-            <a:pPr algn="ctr">
-              <a:lnSpc>
-                <a:spcPct val="140000"/>
+            <a:off x="4445000" y="2578100"/>
+            <a:ext cx="6985000" cy="528320"/>
+          </a:xfrm>
+          <a:prstGeom prst="rect">
+            <a:avLst/>
+          </a:prstGeom>
+          <a:noFill/>
+        </p:spPr>
+        <p:txBody>
+          <a:bodyPr wrap="square" lIns="0" rIns="0" tIns="0" bIns="0">
+            <a:spAutoFit/>
+          </a:bodyPr>
+          <a:lstStyle/>
+          <a:p>
+            <a:pPr algn="l">
+              <a:lnSpc>
+                <a:spcPct val="145000"/>
               </a:lnSpc>
             </a:pPr>
             <a:r>
@@ -9713,23 +9681,7 @@
                 </a:solidFill>
                 <a:latin typeface="Inter"/>
               </a:rPr>
-              <a:t>On-site with instructors,</a:t>
-            </a:r>
-          </a:p>
-          <a:p>
-            <a:pPr algn="ctr">
-              <a:lnSpc>
-                <a:spcPct val="140000"/>
-              </a:lnSpc>
-            </a:pPr>
-            <a:r>
-              <a:rPr sz="1600" b="0">
-                <a:solidFill>
-                  <a:srgbClr val="9EABB1"/>
-                </a:solidFill>
-                <a:latin typeface="Inter"/>
-              </a:rPr>
-              <a:t>students, and leadership.</a:t>
+              <a:t>On-site with instructors, students, and leadership. Legal and IT validation, approximately one month or more.</a:t>
             </a:r>
           </a:p>
         </p:txBody>
@@ -9742,12 +9694,12 @@
         </p:nvSpPr>
         <p:spPr>
           <a:xfrm>
-            <a:off x="7112000" y="2362200"/>
-            <a:ext cx="711200" cy="711200"/>
+            <a:off x="1219200" y="3441700"/>
+            <a:ext cx="508000" cy="508000"/>
           </a:xfrm>
           <a:prstGeom prst="roundRect">
             <a:avLst>
-              <a:gd name="adj" fmla="val 19642"/>
+              <a:gd name="adj" fmla="val 22500"/>
             </a:avLst>
           </a:prstGeom>
           <a:solidFill>
@@ -9796,8 +9748,8 @@
         </p:blipFill>
         <p:spPr>
           <a:xfrm>
-            <a:off x="7289800" y="2540000"/>
-            <a:ext cx="355600" cy="355600"/>
+            <a:off x="1346200" y="3568700"/>
+            <a:ext cx="254000" cy="254000"/>
           </a:xfrm>
           <a:prstGeom prst="rect">
             <a:avLst/>
@@ -9812,21 +9764,21 @@
         </p:nvSpPr>
         <p:spPr>
           <a:xfrm>
-            <a:off x="6248400" y="2032000"/>
-            <a:ext cx="2438400" cy="228600"/>
-          </a:xfrm>
-          <a:prstGeom prst="rect">
-            <a:avLst/>
-          </a:prstGeom>
-          <a:noFill/>
-        </p:spPr>
-        <p:txBody>
-          <a:bodyPr wrap="square" lIns="0" rIns="0" tIns="0" bIns="0">
-            <a:spAutoFit/>
-          </a:bodyPr>
-          <a:lstStyle/>
-          <a:p>
-            <a:pPr algn="ctr">
+            <a:off x="762000" y="3581400"/>
+            <a:ext cx="355600" cy="228600"/>
+          </a:xfrm>
+          <a:prstGeom prst="rect">
+            <a:avLst/>
+          </a:prstGeom>
+          <a:noFill/>
+        </p:spPr>
+        <p:txBody>
+          <a:bodyPr wrap="square" lIns="0" rIns="0" tIns="0" bIns="0">
+            <a:spAutoFit/>
+          </a:bodyPr>
+          <a:lstStyle/>
+          <a:p>
+            <a:pPr algn="l">
               <a:lnSpc>
                 <a:spcPct val="100000"/>
               </a:lnSpc>
@@ -9851,27 +9803,27 @@
         </p:nvSpPr>
         <p:spPr>
           <a:xfrm>
-            <a:off x="6248400" y="3403600"/>
-            <a:ext cx="2438400" cy="736600"/>
-          </a:xfrm>
-          <a:prstGeom prst="rect">
-            <a:avLst/>
-          </a:prstGeom>
-          <a:noFill/>
-        </p:spPr>
-        <p:txBody>
-          <a:bodyPr wrap="square" lIns="0" rIns="0" tIns="0" bIns="0">
-            <a:spAutoFit/>
-          </a:bodyPr>
-          <a:lstStyle/>
-          <a:p>
-            <a:pPr algn="ctr">
-              <a:lnSpc>
-                <a:spcPct val="118000"/>
-              </a:lnSpc>
-            </a:pPr>
-            <a:r>
-              <a:rPr sz="2200" b="1">
+            <a:off x="1981200" y="3390900"/>
+            <a:ext cx="2159000" cy="528320"/>
+          </a:xfrm>
+          <a:prstGeom prst="rect">
+            <a:avLst/>
+          </a:prstGeom>
+          <a:noFill/>
+        </p:spPr>
+        <p:txBody>
+          <a:bodyPr wrap="square" lIns="0" rIns="0" tIns="0" bIns="0">
+            <a:spAutoFit/>
+          </a:bodyPr>
+          <a:lstStyle/>
+          <a:p>
+            <a:pPr algn="l">
+              <a:lnSpc>
+                <a:spcPct val="120000"/>
+              </a:lnSpc>
+            </a:pPr>
+            <a:r>
+              <a:rPr sz="1600" b="1">
                 <a:solidFill>
                   <a:srgbClr val="FFFFFF"/>
                 </a:solidFill>
@@ -9881,13 +9833,13 @@
             </a:r>
           </a:p>
           <a:p>
-            <a:pPr algn="ctr">
-              <a:lnSpc>
-                <a:spcPct val="118000"/>
-              </a:lnSpc>
-            </a:pPr>
-            <a:r>
-              <a:rPr sz="2200" b="1">
+            <a:pPr algn="l">
+              <a:lnSpc>
+                <a:spcPct val="120000"/>
+              </a:lnSpc>
+            </a:pPr>
+            <a:r>
+              <a:rPr sz="1600" b="1">
                 <a:solidFill>
                   <a:srgbClr val="FFFFFF"/>
                 </a:solidFill>
@@ -9906,23 +9858,23 @@
         </p:nvSpPr>
         <p:spPr>
           <a:xfrm>
-            <a:off x="6248400" y="4267200"/>
-            <a:ext cx="2438400" cy="952500"/>
-          </a:xfrm>
-          <a:prstGeom prst="rect">
-            <a:avLst/>
-          </a:prstGeom>
-          <a:noFill/>
-        </p:spPr>
-        <p:txBody>
-          <a:bodyPr wrap="square" lIns="0" rIns="0" tIns="0" bIns="0">
-            <a:spAutoFit/>
-          </a:bodyPr>
-          <a:lstStyle/>
-          <a:p>
-            <a:pPr algn="ctr">
-              <a:lnSpc>
-                <a:spcPct val="140000"/>
+            <a:off x="4445000" y="3390900"/>
+            <a:ext cx="6985000" cy="528320"/>
+          </a:xfrm>
+          <a:prstGeom prst="rect">
+            <a:avLst/>
+          </a:prstGeom>
+          <a:noFill/>
+        </p:spPr>
+        <p:txBody>
+          <a:bodyPr wrap="square" lIns="0" rIns="0" tIns="0" bIns="0">
+            <a:spAutoFit/>
+          </a:bodyPr>
+          <a:lstStyle/>
+          <a:p>
+            <a:pPr algn="l">
+              <a:lnSpc>
+                <a:spcPct val="145000"/>
               </a:lnSpc>
             </a:pPr>
             <a:r>
@@ -9932,23 +9884,7 @@
                 </a:solidFill>
                 <a:latin typeface="Inter"/>
               </a:rPr>
-              <a:t>Launch with a</a:t>
-            </a:r>
-          </a:p>
-          <a:p>
-            <a:pPr algn="ctr">
-              <a:lnSpc>
-                <a:spcPct val="140000"/>
-              </a:lnSpc>
-            </a:pPr>
-            <a:r>
-              <a:rPr sz="1600" b="0">
-                <a:solidFill>
-                  <a:srgbClr val="9EABB1"/>
-                </a:solidFill>
-                <a:latin typeface="Inter"/>
-              </a:rPr>
-              <a:t>self-scaling license.</a:t>
+              <a:t>Launch with a self-scaling license. On-site instructor training support from the Eduface team at pilot start. Target launch December 2026.</a:t>
             </a:r>
           </a:p>
         </p:txBody>
@@ -9961,12 +9897,12 @@
         </p:nvSpPr>
         <p:spPr>
           <a:xfrm>
-            <a:off x="9855200" y="2362200"/>
-            <a:ext cx="711200" cy="711200"/>
+            <a:off x="1219200" y="4254500"/>
+            <a:ext cx="508000" cy="508000"/>
           </a:xfrm>
           <a:prstGeom prst="roundRect">
             <a:avLst>
-              <a:gd name="adj" fmla="val 19642"/>
+              <a:gd name="adj" fmla="val 22500"/>
             </a:avLst>
           </a:prstGeom>
           <a:solidFill>
@@ -10001,7 +9937,7 @@
       </p:sp>
       <p:pic>
         <p:nvPicPr>
-          <p:cNvPr id="21" name="Picture 20" descr="icon-kalender-green.png"/>
+          <p:cNvPr id="21" name="Picture 20" descr="icon-route-green.png"/>
           <p:cNvPicPr>
             <a:picLocks noChangeAspect="1"/>
           </p:cNvPicPr>
@@ -10015,8 +9951,8 @@
         </p:blipFill>
         <p:spPr>
           <a:xfrm>
-            <a:off x="10033000" y="2540000"/>
-            <a:ext cx="355600" cy="355600"/>
+            <a:off x="1346200" y="4381500"/>
+            <a:ext cx="254000" cy="254000"/>
           </a:xfrm>
           <a:prstGeom prst="rect">
             <a:avLst/>
@@ -10031,21 +9967,21 @@
         </p:nvSpPr>
         <p:spPr>
           <a:xfrm>
-            <a:off x="8991600" y="2032000"/>
-            <a:ext cx="2438400" cy="228600"/>
-          </a:xfrm>
-          <a:prstGeom prst="rect">
-            <a:avLst/>
-          </a:prstGeom>
-          <a:noFill/>
-        </p:spPr>
-        <p:txBody>
-          <a:bodyPr wrap="square" lIns="0" rIns="0" tIns="0" bIns="0">
-            <a:spAutoFit/>
-          </a:bodyPr>
-          <a:lstStyle/>
-          <a:p>
-            <a:pPr algn="ctr">
+            <a:off x="762000" y="4394200"/>
+            <a:ext cx="355600" cy="228600"/>
+          </a:xfrm>
+          <a:prstGeom prst="rect">
+            <a:avLst/>
+          </a:prstGeom>
+          <a:noFill/>
+        </p:spPr>
+        <p:txBody>
+          <a:bodyPr wrap="square" lIns="0" rIns="0" tIns="0" bIns="0">
+            <a:spAutoFit/>
+          </a:bodyPr>
+          <a:lstStyle/>
+          <a:p>
+            <a:pPr algn="l">
               <a:lnSpc>
                 <a:spcPct val="100000"/>
               </a:lnSpc>
@@ -10070,43 +10006,246 @@
         </p:nvSpPr>
         <p:spPr>
           <a:xfrm>
-            <a:off x="8991600" y="3403600"/>
-            <a:ext cx="2438400" cy="736600"/>
-          </a:xfrm>
-          <a:prstGeom prst="rect">
-            <a:avLst/>
-          </a:prstGeom>
-          <a:noFill/>
-        </p:spPr>
-        <p:txBody>
-          <a:bodyPr wrap="square" lIns="0" rIns="0" tIns="0" bIns="0">
-            <a:spAutoFit/>
-          </a:bodyPr>
-          <a:lstStyle/>
-          <a:p>
-            <a:pPr algn="ctr">
-              <a:lnSpc>
-                <a:spcPct val="118000"/>
-              </a:lnSpc>
-            </a:pPr>
-            <a:r>
-              <a:rPr sz="2200" b="1">
+            <a:off x="1981200" y="4203700"/>
+            <a:ext cx="2159000" cy="528320"/>
+          </a:xfrm>
+          <a:prstGeom prst="rect">
+            <a:avLst/>
+          </a:prstGeom>
+          <a:noFill/>
+        </p:spPr>
+        <p:txBody>
+          <a:bodyPr wrap="square" lIns="0" rIns="0" tIns="0" bIns="0">
+            <a:spAutoFit/>
+          </a:bodyPr>
+          <a:lstStyle/>
+          <a:p>
+            <a:pPr algn="l">
+              <a:lnSpc>
+                <a:spcPct val="120000"/>
+              </a:lnSpc>
+            </a:pPr>
+            <a:r>
+              <a:rPr sz="1600" b="1">
                 <a:solidFill>
                   <a:srgbClr val="FFFFFF"/>
                 </a:solidFill>
                 <a:latin typeface="League Spartan"/>
               </a:rPr>
+              <a:t>Programmatic</a:t>
+            </a:r>
+          </a:p>
+          <a:p>
+            <a:pPr algn="l">
+              <a:lnSpc>
+                <a:spcPct val="120000"/>
+              </a:lnSpc>
+            </a:pPr>
+            <a:r>
+              <a:rPr sz="1600" b="1">
+                <a:solidFill>
+                  <a:srgbClr val="FFFFFF"/>
+                </a:solidFill>
+                <a:latin typeface="League Spartan"/>
+              </a:rPr>
+              <a:t>Expansion</a:t>
+            </a:r>
+          </a:p>
+        </p:txBody>
+      </p:sp>
+      <p:sp>
+        <p:nvSpPr>
+          <p:cNvPr id="24" name="TextBox 23"/>
+          <p:cNvSpPr txBox="1"/>
+          <p:nvPr/>
+        </p:nvSpPr>
+        <p:spPr>
+          <a:xfrm>
+            <a:off x="4445000" y="4203700"/>
+            <a:ext cx="6985000" cy="528320"/>
+          </a:xfrm>
+          <a:prstGeom prst="rect">
+            <a:avLst/>
+          </a:prstGeom>
+          <a:noFill/>
+        </p:spPr>
+        <p:txBody>
+          <a:bodyPr wrap="square" lIns="0" rIns="0" tIns="0" bIns="0">
+            <a:spAutoFit/>
+          </a:bodyPr>
+          <a:lstStyle/>
+          <a:p>
+            <a:pPr algn="l">
+              <a:lnSpc>
+                <a:spcPct val="145000"/>
+              </a:lnSpc>
+            </a:pPr>
+            <a:r>
+              <a:rPr sz="1600" b="0">
+                <a:solidFill>
+                  <a:srgbClr val="9EABB1"/>
+                </a:solidFill>
+                <a:latin typeface="Inter"/>
+              </a:rPr>
+              <a:t>Roll out to additional programs following pilot success.</a:t>
+            </a:r>
+          </a:p>
+        </p:txBody>
+      </p:sp>
+      <p:sp>
+        <p:nvSpPr>
+          <p:cNvPr id="25" name="Rounded Rectangle 24"/>
+          <p:cNvSpPr/>
+          <p:nvPr/>
+        </p:nvSpPr>
+        <p:spPr>
+          <a:xfrm>
+            <a:off x="1219200" y="5067300"/>
+            <a:ext cx="508000" cy="508000"/>
+          </a:xfrm>
+          <a:prstGeom prst="roundRect">
+            <a:avLst>
+              <a:gd name="adj" fmla="val 22500"/>
+            </a:avLst>
+          </a:prstGeom>
+          <a:solidFill>
+            <a:srgbClr val="0A2C3B"/>
+          </a:solidFill>
+          <a:ln>
+            <a:noFill/>
+          </a:ln>
+          <a:effectLst/>
+        </p:spPr>
+        <p:style>
+          <a:lnRef idx="1">
+            <a:schemeClr val="accent1"/>
+          </a:lnRef>
+          <a:fillRef idx="3">
+            <a:schemeClr val="accent1"/>
+          </a:fillRef>
+          <a:effectRef idx="2">
+            <a:schemeClr val="accent1"/>
+          </a:effectRef>
+          <a:fontRef idx="minor">
+            <a:schemeClr val="lt1"/>
+          </a:fontRef>
+        </p:style>
+        <p:txBody>
+          <a:bodyPr rtlCol="0" anchor="ctr"/>
+          <a:lstStyle/>
+          <a:p>
+            <a:pPr algn="ctr"/>
+          </a:p>
+        </p:txBody>
+      </p:sp>
+      <p:pic>
+        <p:nvPicPr>
+          <p:cNvPr id="26" name="Picture 25" descr="icon-kalender-green.png"/>
+          <p:cNvPicPr>
+            <a:picLocks noChangeAspect="1"/>
+          </p:cNvPicPr>
+          <p:nvPr/>
+        </p:nvPicPr>
+        <p:blipFill>
+          <a:blip r:embed="rId6"/>
+          <a:stretch>
+            <a:fillRect/>
+          </a:stretch>
+        </p:blipFill>
+        <p:spPr>
+          <a:xfrm>
+            <a:off x="1346200" y="5194300"/>
+            <a:ext cx="254000" cy="254000"/>
+          </a:xfrm>
+          <a:prstGeom prst="rect">
+            <a:avLst/>
+          </a:prstGeom>
+        </p:spPr>
+      </p:pic>
+      <p:sp>
+        <p:nvSpPr>
+          <p:cNvPr id="27" name="TextBox 26"/>
+          <p:cNvSpPr txBox="1"/>
+          <p:nvPr/>
+        </p:nvSpPr>
+        <p:spPr>
+          <a:xfrm>
+            <a:off x="762000" y="5207000"/>
+            <a:ext cx="355600" cy="228600"/>
+          </a:xfrm>
+          <a:prstGeom prst="rect">
+            <a:avLst/>
+          </a:prstGeom>
+          <a:noFill/>
+        </p:spPr>
+        <p:txBody>
+          <a:bodyPr wrap="square" lIns="0" rIns="0" tIns="0" bIns="0">
+            <a:spAutoFit/>
+          </a:bodyPr>
+          <a:lstStyle/>
+          <a:p>
+            <a:pPr algn="l">
+              <a:lnSpc>
+                <a:spcPct val="100000"/>
+              </a:lnSpc>
+            </a:pPr>
+            <a:r>
+              <a:rPr sz="1200" b="0">
+                <a:solidFill>
+                  <a:srgbClr val="9EABB1"/>
+                </a:solidFill>
+                <a:latin typeface="League Spartan"/>
+              </a:rPr>
+              <a:t>05</a:t>
+            </a:r>
+          </a:p>
+        </p:txBody>
+      </p:sp>
+      <p:sp>
+        <p:nvSpPr>
+          <p:cNvPr id="28" name="TextBox 27"/>
+          <p:cNvSpPr txBox="1"/>
+          <p:nvPr/>
+        </p:nvSpPr>
+        <p:spPr>
+          <a:xfrm>
+            <a:off x="1981200" y="5016500"/>
+            <a:ext cx="2159000" cy="528320"/>
+          </a:xfrm>
+          <a:prstGeom prst="rect">
+            <a:avLst/>
+          </a:prstGeom>
+          <a:noFill/>
+        </p:spPr>
+        <p:txBody>
+          <a:bodyPr wrap="square" lIns="0" rIns="0" tIns="0" bIns="0">
+            <a:spAutoFit/>
+          </a:bodyPr>
+          <a:lstStyle/>
+          <a:p>
+            <a:pPr algn="l">
+              <a:lnSpc>
+                <a:spcPct val="120000"/>
+              </a:lnSpc>
+            </a:pPr>
+            <a:r>
+              <a:rPr sz="1600" b="1">
+                <a:solidFill>
+                  <a:srgbClr val="FFFFFF"/>
+                </a:solidFill>
+                <a:latin typeface="League Spartan"/>
+              </a:rPr>
               <a:t>Full Institutional</a:t>
             </a:r>
           </a:p>
           <a:p>
-            <a:pPr algn="ctr">
-              <a:lnSpc>
-                <a:spcPct val="118000"/>
-              </a:lnSpc>
-            </a:pPr>
-            <a:r>
-              <a:rPr sz="2200" b="1">
+            <a:pPr algn="l">
+              <a:lnSpc>
+                <a:spcPct val="120000"/>
+              </a:lnSpc>
+            </a:pPr>
+            <a:r>
+              <a:rPr sz="1600" b="1">
                 <a:solidFill>
                   <a:srgbClr val="FFFFFF"/>
                 </a:solidFill>
@@ -10119,29 +10258,29 @@
       </p:sp>
       <p:sp>
         <p:nvSpPr>
-          <p:cNvPr id="24" name="TextBox 23"/>
-          <p:cNvSpPr txBox="1"/>
-          <p:nvPr/>
-        </p:nvSpPr>
-        <p:spPr>
-          <a:xfrm>
-            <a:off x="8991600" y="4267200"/>
-            <a:ext cx="2438400" cy="952500"/>
-          </a:xfrm>
-          <a:prstGeom prst="rect">
-            <a:avLst/>
-          </a:prstGeom>
-          <a:noFill/>
-        </p:spPr>
-        <p:txBody>
-          <a:bodyPr wrap="square" lIns="0" rIns="0" tIns="0" bIns="0">
-            <a:spAutoFit/>
-          </a:bodyPr>
-          <a:lstStyle/>
-          <a:p>
-            <a:pPr algn="ctr">
-              <a:lnSpc>
-                <a:spcPct val="140000"/>
+          <p:cNvPr id="29" name="TextBox 28"/>
+          <p:cNvSpPr txBox="1"/>
+          <p:nvPr/>
+        </p:nvSpPr>
+        <p:spPr>
+          <a:xfrm>
+            <a:off x="4445000" y="5016500"/>
+            <a:ext cx="6985000" cy="528320"/>
+          </a:xfrm>
+          <a:prstGeom prst="rect">
+            <a:avLst/>
+          </a:prstGeom>
+          <a:noFill/>
+        </p:spPr>
+        <p:txBody>
+          <a:bodyPr wrap="square" lIns="0" rIns="0" tIns="0" bIns="0">
+            <a:spAutoFit/>
+          </a:bodyPr>
+          <a:lstStyle/>
+          <a:p>
+            <a:pPr algn="l">
+              <a:lnSpc>
+                <a:spcPct val="145000"/>
               </a:lnSpc>
             </a:pPr>
             <a:r>
@@ -10151,30 +10290,14 @@
                 </a:solidFill>
                 <a:latin typeface="Inter"/>
               </a:rPr>
-              <a:t>Roll out institution-wide</a:t>
-            </a:r>
-          </a:p>
-          <a:p>
-            <a:pPr algn="ctr">
-              <a:lnSpc>
-                <a:spcPct val="140000"/>
-              </a:lnSpc>
-            </a:pPr>
-            <a:r>
-              <a:rPr sz="1600" b="0">
-                <a:solidFill>
-                  <a:srgbClr val="9EABB1"/>
-                </a:solidFill>
-                <a:latin typeface="Inter"/>
-              </a:rPr>
-              <a:t>from next academic year.</a:t>
-            </a:r>
-          </a:p>
-        </p:txBody>
-      </p:sp>
-      <p:sp>
-        <p:nvSpPr>
-          <p:cNvPr id="25" name="Rectangle 24"/>
+              <a:t>Roll out institution-wide from next academic year.</a:t>
+            </a:r>
+          </a:p>
+        </p:txBody>
+      </p:sp>
+      <p:sp>
+        <p:nvSpPr>
+          <p:cNvPr id="30" name="Rectangle 29"/>
           <p:cNvSpPr/>
           <p:nvPr/>
         </p:nvSpPr>
@@ -10218,14 +10341,14 @@
       </p:sp>
       <p:pic>
         <p:nvPicPr>
-          <p:cNvPr id="26" name="Picture 25" descr="logo_white.png"/>
+          <p:cNvPr id="31" name="Picture 30" descr="logo_white.png"/>
           <p:cNvPicPr>
             <a:picLocks noChangeAspect="1"/>
           </p:cNvPicPr>
           <p:nvPr/>
         </p:nvPicPr>
         <p:blipFill>
-          <a:blip r:embed="rId6"/>
+          <a:blip r:embed="rId7"/>
           <a:stretch>
             <a:fillRect/>
           </a:stretch>
@@ -10242,7 +10365,7 @@
       </p:pic>
       <p:sp>
         <p:nvSpPr>
-          <p:cNvPr id="27" name="Rectangle 26"/>
+          <p:cNvPr id="32" name="Rectangle 31"/>
           <p:cNvSpPr/>
           <p:nvPr/>
         </p:nvSpPr>
@@ -10286,7 +10409,7 @@
       </p:sp>
       <p:sp>
         <p:nvSpPr>
-          <p:cNvPr id="28" name="TextBox 27"/>
+          <p:cNvPr id="33" name="TextBox 32"/>
           <p:cNvSpPr txBox="1"/>
           <p:nvPr/>
         </p:nvSpPr>
@@ -10325,7 +10448,7 @@
       </p:sp>
       <p:sp>
         <p:nvSpPr>
-          <p:cNvPr id="29" name="TextBox 28"/>
+          <p:cNvPr id="34" name="TextBox 33"/>
           <p:cNvSpPr txBox="1"/>
           <p:nvPr/>
         </p:nvSpPr>
@@ -10364,7 +10487,7 @@
       </p:sp>
       <p:sp>
         <p:nvSpPr>
-          <p:cNvPr id="30" name="TextBox 29"/>
+          <p:cNvPr id="35" name="TextBox 34"/>
           <p:cNvSpPr txBox="1"/>
           <p:nvPr/>
         </p:nvSpPr>
@@ -12697,7 +12820,7 @@
         <p:spPr>
           <a:xfrm>
             <a:off x="762000" y="3378200"/>
-            <a:ext cx="5029200" cy="963930"/>
+            <a:ext cx="4445000" cy="963930"/>
           </a:xfrm>
           <a:prstGeom prst="rect">
             <a:avLst/>
@@ -12736,7 +12859,7 @@
         <p:spPr>
           <a:xfrm>
             <a:off x="3987800" y="3790950"/>
-            <a:ext cx="1803400" cy="363220"/>
+            <a:ext cx="1219200" cy="363220"/>
           </a:xfrm>
           <a:prstGeom prst="rect">
             <a:avLst/>
@@ -12774,8 +12897,8 @@
         </p:nvSpPr>
         <p:spPr>
           <a:xfrm>
-            <a:off x="762000" y="4800600"/>
-            <a:ext cx="5029200" cy="812800"/>
+            <a:off x="762000" y="4381500"/>
+            <a:ext cx="4191000" cy="812800"/>
           </a:xfrm>
           <a:prstGeom prst="rect">
             <a:avLst/>
@@ -12813,7 +12936,7 @@
         </p:nvSpPr>
         <p:spPr>
           <a:xfrm>
-            <a:off x="6400800" y="2235200"/>
+            <a:off x="5715000" y="2235200"/>
             <a:ext cx="762000" cy="762000"/>
           </a:xfrm>
           <a:prstGeom prst="roundRect">
@@ -12867,7 +12990,7 @@
         </p:blipFill>
         <p:spPr>
           <a:xfrm>
-            <a:off x="6604000" y="2438400"/>
+            <a:off x="5918200" y="2438400"/>
             <a:ext cx="355600" cy="355600"/>
           </a:xfrm>
           <a:prstGeom prst="rect">
@@ -12883,8 +13006,8 @@
         </p:nvSpPr>
         <p:spPr>
           <a:xfrm>
-            <a:off x="6400800" y="3657600"/>
-            <a:ext cx="5029200" cy="363220"/>
+            <a:off x="5715000" y="3657600"/>
+            <a:ext cx="2540000" cy="363220"/>
           </a:xfrm>
           <a:prstGeom prst="rect">
             <a:avLst/>
@@ -12922,8 +13045,8 @@
         </p:nvSpPr>
         <p:spPr>
           <a:xfrm>
-            <a:off x="6400800" y="4800600"/>
-            <a:ext cx="5029200" cy="812800"/>
+            <a:off x="5715000" y="4381500"/>
+            <a:ext cx="2540000" cy="1016000"/>
           </a:xfrm>
           <a:prstGeom prst="rect">
             <a:avLst/>
@@ -12955,7 +13078,171 @@
       </p:sp>
       <p:sp>
         <p:nvSpPr>
-          <p:cNvPr id="13" name="Rectangle 12"/>
+          <p:cNvPr id="13" name="Rounded Rectangle 12"/>
+          <p:cNvSpPr/>
+          <p:nvPr/>
+        </p:nvSpPr>
+        <p:spPr>
+          <a:xfrm>
+            <a:off x="8763000" y="2235200"/>
+            <a:ext cx="762000" cy="762000"/>
+          </a:xfrm>
+          <a:prstGeom prst="roundRect">
+            <a:avLst>
+              <a:gd name="adj" fmla="val 16666"/>
+            </a:avLst>
+          </a:prstGeom>
+          <a:solidFill>
+            <a:srgbClr val="F3F7F8"/>
+          </a:solidFill>
+          <a:ln>
+            <a:noFill/>
+          </a:ln>
+          <a:effectLst/>
+        </p:spPr>
+        <p:style>
+          <a:lnRef idx="1">
+            <a:schemeClr val="accent1"/>
+          </a:lnRef>
+          <a:fillRef idx="3">
+            <a:schemeClr val="accent1"/>
+          </a:fillRef>
+          <a:effectRef idx="2">
+            <a:schemeClr val="accent1"/>
+          </a:effectRef>
+          <a:fontRef idx="minor">
+            <a:schemeClr val="lt1"/>
+          </a:fontRef>
+        </p:style>
+        <p:txBody>
+          <a:bodyPr rtlCol="0" anchor="ctr"/>
+          <a:lstStyle/>
+          <a:p>
+            <a:pPr algn="ctr"/>
+          </a:p>
+        </p:txBody>
+      </p:sp>
+      <p:pic>
+        <p:nvPicPr>
+          <p:cNvPr id="14" name="Picture 13" descr="icon-mensen-navy.png"/>
+          <p:cNvPicPr>
+            <a:picLocks noChangeAspect="1"/>
+          </p:cNvPicPr>
+          <p:nvPr/>
+        </p:nvPicPr>
+        <p:blipFill>
+          <a:blip r:embed="rId4"/>
+          <a:stretch>
+            <a:fillRect/>
+          </a:stretch>
+        </p:blipFill>
+        <p:spPr>
+          <a:xfrm>
+            <a:off x="8966200" y="2438400"/>
+            <a:ext cx="355600" cy="355600"/>
+          </a:xfrm>
+          <a:prstGeom prst="rect">
+            <a:avLst/>
+          </a:prstGeom>
+        </p:spPr>
+      </p:pic>
+      <p:sp>
+        <p:nvSpPr>
+          <p:cNvPr id="15" name="TextBox 14"/>
+          <p:cNvSpPr txBox="1"/>
+          <p:nvPr/>
+        </p:nvSpPr>
+        <p:spPr>
+          <a:xfrm>
+            <a:off x="8763000" y="3657600"/>
+            <a:ext cx="2667000" cy="726440"/>
+          </a:xfrm>
+          <a:prstGeom prst="rect">
+            <a:avLst/>
+          </a:prstGeom>
+          <a:noFill/>
+        </p:spPr>
+        <p:txBody>
+          <a:bodyPr wrap="square" lIns="0" rIns="0" tIns="0" bIns="0">
+            <a:spAutoFit/>
+          </a:bodyPr>
+          <a:lstStyle/>
+          <a:p>
+            <a:pPr algn="l">
+              <a:lnSpc>
+                <a:spcPct val="115000"/>
+              </a:lnSpc>
+            </a:pPr>
+            <a:r>
+              <a:rPr sz="2200" b="1">
+                <a:solidFill>
+                  <a:srgbClr val="002333"/>
+                </a:solidFill>
+                <a:latin typeface="League Spartan"/>
+              </a:rPr>
+              <a:t>No Time</a:t>
+            </a:r>
+          </a:p>
+          <a:p>
+            <a:pPr algn="l">
+              <a:lnSpc>
+                <a:spcPct val="115000"/>
+              </a:lnSpc>
+            </a:pPr>
+            <a:r>
+              <a:rPr sz="2200" b="1">
+                <a:solidFill>
+                  <a:srgbClr val="002333"/>
+                </a:solidFill>
+                <a:latin typeface="League Spartan"/>
+              </a:rPr>
+              <a:t>for Tutoring</a:t>
+            </a:r>
+          </a:p>
+        </p:txBody>
+      </p:sp>
+      <p:sp>
+        <p:nvSpPr>
+          <p:cNvPr id="16" name="TextBox 15"/>
+          <p:cNvSpPr txBox="1"/>
+          <p:nvPr/>
+        </p:nvSpPr>
+        <p:spPr>
+          <a:xfrm>
+            <a:off x="8763000" y="4381500"/>
+            <a:ext cx="2667000" cy="1219200"/>
+          </a:xfrm>
+          <a:prstGeom prst="rect">
+            <a:avLst/>
+          </a:prstGeom>
+          <a:noFill/>
+        </p:spPr>
+        <p:txBody>
+          <a:bodyPr wrap="square" lIns="0" rIns="0" tIns="0" bIns="0">
+            <a:spAutoFit/>
+          </a:bodyPr>
+          <a:lstStyle/>
+          <a:p>
+            <a:pPr algn="l">
+              <a:lnSpc>
+                <a:spcPct val="145000"/>
+              </a:lnSpc>
+            </a:pPr>
+            <a:r>
+              <a:rPr sz="1600" b="0">
+                <a:solidFill>
+                  <a:srgbClr val="2C4A57"/>
+                </a:solidFill>
+                <a:latin typeface="Inter"/>
+              </a:rPr>
+              <a:t>Instructors are too caught up in grading to provide the tutoring and remedial support students increasingly need.</a:t>
+            </a:r>
+          </a:p>
+        </p:txBody>
+      </p:sp>
+      <p:sp>
+        <p:nvSpPr>
+          <p:cNvPr id="17" name="Rectangle 16"/>
           <p:cNvSpPr/>
           <p:nvPr/>
         </p:nvSpPr>
@@ -12999,14 +13286,14 @@
       </p:sp>
       <p:pic>
         <p:nvPicPr>
-          <p:cNvPr id="14" name="Picture 13" descr="logo_navy.png"/>
+          <p:cNvPr id="18" name="Picture 17" descr="logo_navy.png"/>
           <p:cNvPicPr>
             <a:picLocks noChangeAspect="1"/>
           </p:cNvPicPr>
           <p:nvPr/>
         </p:nvPicPr>
         <p:blipFill>
-          <a:blip r:embed="rId4"/>
+          <a:blip r:embed="rId5"/>
           <a:stretch>
             <a:fillRect/>
           </a:stretch>
@@ -13023,7 +13310,7 @@
       </p:pic>
       <p:sp>
         <p:nvSpPr>
-          <p:cNvPr id="15" name="Rectangle 14"/>
+          <p:cNvPr id="19" name="Rectangle 18"/>
           <p:cNvSpPr/>
           <p:nvPr/>
         </p:nvSpPr>
@@ -13067,7 +13354,7 @@
       </p:sp>
       <p:sp>
         <p:nvSpPr>
-          <p:cNvPr id="16" name="TextBox 15"/>
+          <p:cNvPr id="20" name="TextBox 19"/>
           <p:cNvSpPr txBox="1"/>
           <p:nvPr/>
         </p:nvSpPr>
@@ -13106,7 +13393,7 @@
       </p:sp>
       <p:sp>
         <p:nvSpPr>
-          <p:cNvPr id="17" name="TextBox 16"/>
+          <p:cNvPr id="21" name="TextBox 20"/>
           <p:cNvSpPr txBox="1"/>
           <p:nvPr/>
         </p:nvSpPr>
@@ -13558,7 +13845,7 @@
         <p:spPr>
           <a:xfrm>
             <a:off x="6400800" y="4165600"/>
-            <a:ext cx="1676400" cy="579120"/>
+            <a:ext cx="457200" cy="579120"/>
           </a:xfrm>
           <a:prstGeom prst="rect">
             <a:avLst/>
@@ -13583,7 +13870,7 @@
                 </a:solidFill>
                 <a:latin typeface="League Spartan"/>
               </a:rPr>
-              <a:t>12–16</a:t>
+              <a:t>2</a:t>
             </a:r>
           </a:p>
         </p:txBody>
@@ -13596,8 +13883,8 @@
         </p:nvSpPr>
         <p:spPr>
           <a:xfrm>
-            <a:off x="8255000" y="4356100"/>
-            <a:ext cx="3175000" cy="325120"/>
+            <a:off x="7035800" y="4356100"/>
+            <a:ext cx="4394200" cy="325120"/>
           </a:xfrm>
           <a:prstGeom prst="rect">
             <a:avLst/>
@@ -13622,92 +13909,14 @@
                 </a:solidFill>
                 <a:latin typeface="Inter"/>
               </a:rPr>
-              <a:t>new campuses</a:t>
-            </a:r>
-          </a:p>
-        </p:txBody>
-      </p:sp>
-      <p:sp>
-        <p:nvSpPr>
-          <p:cNvPr id="13" name="TextBox 12"/>
-          <p:cNvSpPr txBox="1"/>
-          <p:nvPr/>
-        </p:nvSpPr>
-        <p:spPr>
-          <a:xfrm>
-            <a:off x="6400800" y="4826000"/>
-            <a:ext cx="1676400" cy="579120"/>
-          </a:xfrm>
-          <a:prstGeom prst="rect">
-            <a:avLst/>
-          </a:prstGeom>
-          <a:noFill/>
-        </p:spPr>
-        <p:txBody>
-          <a:bodyPr wrap="square" lIns="0" rIns="0" tIns="0" bIns="0">
-            <a:spAutoFit/>
-          </a:bodyPr>
-          <a:lstStyle/>
-          <a:p>
-            <a:pPr algn="l">
-              <a:lnSpc>
-                <a:spcPct val="100000"/>
-              </a:lnSpc>
-            </a:pPr>
-            <a:r>
-              <a:rPr sz="3800" b="1">
-                <a:solidFill>
-                  <a:srgbClr val="FFFFFF"/>
-                </a:solidFill>
-                <a:latin typeface="League Spartan"/>
-              </a:rPr>
-              <a:t>50–70</a:t>
-            </a:r>
-          </a:p>
-        </p:txBody>
-      </p:sp>
-      <p:sp>
-        <p:nvSpPr>
-          <p:cNvPr id="14" name="TextBox 13"/>
-          <p:cNvSpPr txBox="1"/>
-          <p:nvPr/>
-        </p:nvSpPr>
-        <p:spPr>
-          <a:xfrm>
-            <a:off x="8255000" y="5016500"/>
-            <a:ext cx="3175000" cy="325120"/>
-          </a:xfrm>
-          <a:prstGeom prst="rect">
-            <a:avLst/>
-          </a:prstGeom>
-          <a:noFill/>
-        </p:spPr>
-        <p:txBody>
-          <a:bodyPr wrap="square" lIns="0" rIns="0" tIns="0" bIns="0">
-            <a:spAutoFit/>
-          </a:bodyPr>
-          <a:lstStyle/>
-          <a:p>
-            <a:pPr algn="l">
-              <a:lnSpc>
-                <a:spcPct val="120000"/>
-              </a:lnSpc>
-            </a:pPr>
-            <a:r>
-              <a:rPr sz="1600" b="0">
-                <a:solidFill>
-                  <a:srgbClr val="9EABB1"/>
-                </a:solidFill>
-                <a:latin typeface="Inter"/>
-              </a:rPr>
-              <a:t>new programs</a:t>
-            </a:r>
-          </a:p>
-        </p:txBody>
-      </p:sp>
-      <p:sp>
-        <p:nvSpPr>
-          <p:cNvPr id="15" name="Rectangle 14"/>
+              <a:t>new campuses per year</a:t>
+            </a:r>
+          </a:p>
+        </p:txBody>
+      </p:sp>
+      <p:sp>
+        <p:nvSpPr>
+          <p:cNvPr id="13" name="Rectangle 12"/>
           <p:cNvSpPr/>
           <p:nvPr/>
         </p:nvSpPr>
@@ -13751,7 +13960,7 @@
       </p:sp>
       <p:pic>
         <p:nvPicPr>
-          <p:cNvPr id="16" name="Picture 15" descr="logo_white.png"/>
+          <p:cNvPr id="14" name="Picture 13" descr="logo_white.png"/>
           <p:cNvPicPr>
             <a:picLocks noChangeAspect="1"/>
           </p:cNvPicPr>
@@ -13775,7 +13984,7 @@
       </p:pic>
       <p:sp>
         <p:nvSpPr>
-          <p:cNvPr id="17" name="Rectangle 16"/>
+          <p:cNvPr id="15" name="Rectangle 14"/>
           <p:cNvSpPr/>
           <p:nvPr/>
         </p:nvSpPr>
@@ -13819,7 +14028,7 @@
       </p:sp>
       <p:sp>
         <p:nvSpPr>
-          <p:cNvPr id="18" name="TextBox 17"/>
+          <p:cNvPr id="16" name="TextBox 15"/>
           <p:cNvSpPr txBox="1"/>
           <p:nvPr/>
         </p:nvSpPr>
@@ -13858,7 +14067,7 @@
       </p:sp>
       <p:sp>
         <p:nvSpPr>
-          <p:cNvPr id="19" name="TextBox 18"/>
+          <p:cNvPr id="17" name="TextBox 16"/>
           <p:cNvSpPr txBox="1"/>
           <p:nvPr/>
         </p:nvSpPr>
@@ -13890,14 +14099,14 @@
                 </a:solidFill>
                 <a:latin typeface="Inter"/>
               </a:rPr>
-              <a:t>North Star Phase II, by FY2029.</a:t>
-            </a:r>
-          </a:p>
-        </p:txBody>
-      </p:sp>
-      <p:sp>
-        <p:nvSpPr>
-          <p:cNvPr id="20" name="TextBox 19"/>
+              <a:t>North Star strategy target.</a:t>
+            </a:r>
+          </a:p>
+        </p:txBody>
+      </p:sp>
+      <p:sp>
+        <p:nvSpPr>
+          <p:cNvPr id="18" name="TextBox 17"/>
           <p:cNvSpPr txBox="1"/>
           <p:nvPr/>
         </p:nvSpPr>
@@ -14846,7 +15055,7 @@
         </p:nvSpPr>
         <p:spPr>
           <a:xfrm>
-            <a:off x="762000" y="2400300"/>
+            <a:off x="762000" y="1905000"/>
             <a:ext cx="838200" cy="838200"/>
           </a:xfrm>
           <a:prstGeom prst="roundRect">
@@ -14900,7 +15109,7 @@
         </p:blipFill>
         <p:spPr>
           <a:xfrm>
-            <a:off x="977900" y="2616200"/>
+            <a:off x="977900" y="2120900"/>
             <a:ext cx="406400" cy="406400"/>
           </a:xfrm>
           <a:prstGeom prst="rect">
@@ -14916,7 +15125,7 @@
         </p:nvSpPr>
         <p:spPr>
           <a:xfrm>
-            <a:off x="762000" y="3530600"/>
+            <a:off x="762000" y="3035300"/>
             <a:ext cx="3352800" cy="949960"/>
           </a:xfrm>
           <a:prstGeom prst="rect">
@@ -14971,7 +15180,7 @@
         </p:nvSpPr>
         <p:spPr>
           <a:xfrm>
-            <a:off x="762000" y="4622800"/>
+            <a:off x="762000" y="4127500"/>
             <a:ext cx="3149600" cy="650240"/>
           </a:xfrm>
           <a:prstGeom prst="rect">
@@ -15010,7 +15219,7 @@
         </p:nvSpPr>
         <p:spPr>
           <a:xfrm>
-            <a:off x="4419600" y="2400300"/>
+            <a:off x="4419600" y="1905000"/>
             <a:ext cx="838200" cy="838200"/>
           </a:xfrm>
           <a:prstGeom prst="roundRect">
@@ -15064,7 +15273,7 @@
         </p:blipFill>
         <p:spPr>
           <a:xfrm>
-            <a:off x="4635500" y="2616200"/>
+            <a:off x="4635500" y="2120900"/>
             <a:ext cx="406400" cy="406400"/>
           </a:xfrm>
           <a:prstGeom prst="rect">
@@ -15080,7 +15289,7 @@
         </p:nvSpPr>
         <p:spPr>
           <a:xfrm>
-            <a:off x="4419600" y="3530600"/>
+            <a:off x="4419600" y="3035300"/>
             <a:ext cx="3352800" cy="949960"/>
           </a:xfrm>
           <a:prstGeom prst="rect">
@@ -15135,7 +15344,7 @@
         </p:nvSpPr>
         <p:spPr>
           <a:xfrm>
-            <a:off x="4419600" y="4622800"/>
+            <a:off x="4419600" y="4127500"/>
             <a:ext cx="3149600" cy="650240"/>
           </a:xfrm>
           <a:prstGeom prst="rect">
@@ -15161,7 +15370,7 @@
                 </a:solidFill>
                 <a:latin typeface="Inter"/>
               </a:rPr>
-              <a:t>Supports instructor retention.</a:t>
+              <a:t>Supports instructor retention. Instructor overtime is one of the largest variable cost items for education directors, so reduced grading time directly protects budget.</a:t>
             </a:r>
           </a:p>
         </p:txBody>
@@ -15174,7 +15383,7 @@
         </p:nvSpPr>
         <p:spPr>
           <a:xfrm>
-            <a:off x="8077200" y="2400300"/>
+            <a:off x="8077200" y="1905000"/>
             <a:ext cx="838200" cy="838200"/>
           </a:xfrm>
           <a:prstGeom prst="roundRect">
@@ -15228,7 +15437,7 @@
         </p:blipFill>
         <p:spPr>
           <a:xfrm>
-            <a:off x="8293100" y="2616200"/>
+            <a:off x="8293100" y="2120900"/>
             <a:ext cx="406400" cy="406400"/>
           </a:xfrm>
           <a:prstGeom prst="rect">
@@ -15244,7 +15453,7 @@
         </p:nvSpPr>
         <p:spPr>
           <a:xfrm>
-            <a:off x="8077200" y="3530600"/>
+            <a:off x="8077200" y="3035300"/>
             <a:ext cx="3352800" cy="949960"/>
           </a:xfrm>
           <a:prstGeom prst="rect">
@@ -15299,7 +15508,7 @@
         </p:nvSpPr>
         <p:spPr>
           <a:xfrm>
-            <a:off x="8077200" y="4622800"/>
+            <a:off x="8077200" y="4127500"/>
             <a:ext cx="3149600" cy="650240"/>
           </a:xfrm>
           <a:prstGeom prst="rect">
@@ -15325,7 +15534,7 @@
                 </a:solidFill>
                 <a:latin typeface="Inter"/>
               </a:rPr>
-              <a:t>New campuses and programs, without headcount growing 1:1.</a:t>
+              <a:t>New campuses and programs, without headcount growing 1:1. Higher course completion rates increase revenue.</a:t>
             </a:r>
           </a:p>
         </p:txBody>

</xml_diff>

<commit_message>
UTI-deck: demo-slide toegevoegd tussen capabilities en bewijs
Agenda gaat van negen naar tien punten, met Demo op 07, en valt nu in twee
gelijke kolommen van vijf. De demo zelf is een statement-slide: navy, alleen het
woord, verder niets, want dat is het moment waarop de kijker naar het scherm
moet kijken in plaats van mee te lezen.

Bath Spa, Our Solution en Next Steps schuiven daardoor op naar 14, 15 en 16.

Co-Authored-By: Claude Opus 5 <noreply@anthropic.com>
Claude-Session: https://claude.ai/code/session_01NLHJ2Mm4EhXvCdoUv8TcEZ
</commit_message>
<xml_diff>
--- a/projects/uti/deck/UTI-Eduface-deck.pptx
+++ b/projects/uti/deck/UTI-Eduface-deck.pptx
@@ -20,6 +20,7 @@
     <p:sldId id="268" r:id="rId19"/>
     <p:sldId id="269" r:id="rId20"/>
     <p:sldId id="270" r:id="rId21"/>
+    <p:sldId id="271" r:id="rId22"/>
   </p:sldIdLst>
   <p:sldSz cx="12192000" cy="6858000" type="screen4x3"/>
   <p:notesSz cx="6858000" cy="9144000"/>
@@ -6569,7 +6570,7 @@
             <a:avLst/>
           </a:prstGeom>
           <a:solidFill>
-            <a:srgbClr val="FFFFFF"/>
+            <a:srgbClr val="002333"/>
           </a:solidFill>
           <a:ln>
             <a:noFill/>
@@ -6606,8 +6607,8 @@
         </p:nvSpPr>
         <p:spPr>
           <a:xfrm>
-            <a:off x="762000" y="558800"/>
-            <a:ext cx="10668000" cy="1061720"/>
+            <a:off x="762000" y="3175000"/>
+            <a:ext cx="10668000" cy="1173480"/>
           </a:xfrm>
           <a:prstGeom prst="rect">
             <a:avLst/>
@@ -6622,76 +6623,37 @@
           <a:p>
             <a:pPr algn="l">
               <a:lnSpc>
-                <a:spcPct val="104000"/>
-              </a:lnSpc>
-            </a:pPr>
-            <a:r>
-              <a:rPr sz="3800" b="1">
-                <a:solidFill>
-                  <a:srgbClr val="002333"/>
+                <a:spcPct val="98000"/>
+              </a:lnSpc>
+            </a:pPr>
+            <a:r>
+              <a:rPr sz="6600" b="1">
+                <a:solidFill>
+                  <a:srgbClr val="FFFFFF"/>
                 </a:solidFill>
                 <a:latin typeface="League Spartan"/>
               </a:rPr>
-              <a:t>Marking Time Drops 6–10x at Bath Spa University</a:t>
-            </a:r>
-          </a:p>
-        </p:txBody>
-      </p:sp>
-      <p:sp>
-        <p:nvSpPr>
-          <p:cNvPr id="4" name="TextBox 3"/>
-          <p:cNvSpPr txBox="1"/>
-          <p:nvPr/>
-        </p:nvSpPr>
-        <p:spPr>
-          <a:xfrm>
-            <a:off x="762000" y="2095500"/>
-            <a:ext cx="2540000" cy="304800"/>
-          </a:xfrm>
-          <a:prstGeom prst="rect">
-            <a:avLst/>
-          </a:prstGeom>
-          <a:noFill/>
-        </p:spPr>
-        <p:txBody>
-          <a:bodyPr wrap="square" lIns="0" rIns="0" tIns="0" bIns="0">
-            <a:spAutoFit/>
-          </a:bodyPr>
-          <a:lstStyle/>
-          <a:p>
-            <a:pPr algn="r">
-              <a:lnSpc>
-                <a:spcPct val="120000"/>
-              </a:lnSpc>
-            </a:pPr>
-            <a:r>
-              <a:rPr sz="1600" b="0">
-                <a:solidFill>
-                  <a:srgbClr val="2C4A57"/>
-                </a:solidFill>
-                <a:latin typeface="Inter"/>
-              </a:rPr>
-              <a:t>Traditional marking</a:t>
-            </a:r>
-          </a:p>
-        </p:txBody>
-      </p:sp>
-      <p:sp>
-        <p:nvSpPr>
-          <p:cNvPr id="5" name="Rectangle 4"/>
+              <a:t>Demo</a:t>
+            </a:r>
+          </a:p>
+        </p:txBody>
+      </p:sp>
+      <p:sp>
+        <p:nvSpPr>
+          <p:cNvPr id="4" name="Rectangle 3"/>
           <p:cNvSpPr/>
           <p:nvPr/>
         </p:nvSpPr>
         <p:spPr>
           <a:xfrm>
-            <a:off x="3556000" y="1943100"/>
-            <a:ext cx="6096000" cy="558800"/>
+            <a:off x="762000" y="6045200"/>
+            <a:ext cx="10668000" cy="6350"/>
           </a:xfrm>
           <a:prstGeom prst="rect">
             <a:avLst/>
           </a:prstGeom>
           <a:solidFill>
-            <a:srgbClr val="F3F7F8"/>
+            <a:srgbClr val="1F3D4B"/>
           </a:solidFill>
           <a:ln>
             <a:noFill/>
@@ -6720,6 +6682,30 @@
           </a:p>
         </p:txBody>
       </p:sp>
+      <p:pic>
+        <p:nvPicPr>
+          <p:cNvPr id="5" name="Picture 4" descr="logo_white.png"/>
+          <p:cNvPicPr>
+            <a:picLocks noChangeAspect="1"/>
+          </p:cNvPicPr>
+          <p:nvPr/>
+        </p:nvPicPr>
+        <p:blipFill>
+          <a:blip r:embed="rId2"/>
+          <a:stretch>
+            <a:fillRect/>
+          </a:stretch>
+        </p:blipFill>
+        <p:spPr>
+          <a:xfrm>
+            <a:off x="762000" y="6324600"/>
+            <a:ext cx="934528" cy="254000"/>
+          </a:xfrm>
+          <a:prstGeom prst="rect">
+            <a:avLst/>
+          </a:prstGeom>
+        </p:spPr>
+      </p:pic>
       <p:sp>
         <p:nvSpPr>
           <p:cNvPr id="6" name="Rectangle 5"/>
@@ -6728,14 +6714,14 @@
         </p:nvSpPr>
         <p:spPr>
           <a:xfrm>
-            <a:off x="6604000" y="1943100"/>
-            <a:ext cx="3048000" cy="558800"/>
+            <a:off x="1968500" y="6311900"/>
+            <a:ext cx="6350" cy="279400"/>
           </a:xfrm>
           <a:prstGeom prst="rect">
             <a:avLst/>
           </a:prstGeom>
           <a:solidFill>
-            <a:srgbClr val="CDD9DE"/>
+            <a:srgbClr val="1F3D4B"/>
           </a:solidFill>
           <a:ln>
             <a:noFill/>
@@ -6766,430 +6752,18 @@
       </p:sp>
       <p:sp>
         <p:nvSpPr>
-          <p:cNvPr id="7" name="TextBox 6"/>
-          <p:cNvSpPr txBox="1"/>
-          <p:nvPr/>
-        </p:nvSpPr>
-        <p:spPr>
-          <a:xfrm>
-            <a:off x="9906000" y="2070100"/>
-            <a:ext cx="1524000" cy="355600"/>
-          </a:xfrm>
-          <a:prstGeom prst="rect">
-            <a:avLst/>
-          </a:prstGeom>
-          <a:noFill/>
-        </p:spPr>
-        <p:txBody>
-          <a:bodyPr wrap="square" lIns="0" rIns="0" tIns="0" bIns="0">
-            <a:spAutoFit/>
-          </a:bodyPr>
-          <a:lstStyle/>
-          <a:p>
-            <a:pPr algn="l">
-              <a:lnSpc>
-                <a:spcPct val="100000"/>
-              </a:lnSpc>
-            </a:pPr>
-            <a:r>
-              <a:rPr sz="2200" b="1">
-                <a:solidFill>
-                  <a:srgbClr val="002333"/>
-                </a:solidFill>
-                <a:latin typeface="League Spartan"/>
-              </a:rPr>
-              <a:t>15–30 min</a:t>
-            </a:r>
-          </a:p>
-        </p:txBody>
-      </p:sp>
-      <p:sp>
-        <p:nvSpPr>
-          <p:cNvPr id="8" name="TextBox 7"/>
-          <p:cNvSpPr txBox="1"/>
-          <p:nvPr/>
-        </p:nvSpPr>
-        <p:spPr>
-          <a:xfrm>
-            <a:off x="762000" y="2908300"/>
-            <a:ext cx="2540000" cy="304800"/>
-          </a:xfrm>
-          <a:prstGeom prst="rect">
-            <a:avLst/>
-          </a:prstGeom>
-          <a:noFill/>
-        </p:spPr>
-        <p:txBody>
-          <a:bodyPr wrap="square" lIns="0" rIns="0" tIns="0" bIns="0">
-            <a:spAutoFit/>
-          </a:bodyPr>
-          <a:lstStyle/>
-          <a:p>
-            <a:pPr algn="r">
-              <a:lnSpc>
-                <a:spcPct val="120000"/>
-              </a:lnSpc>
-            </a:pPr>
-            <a:r>
-              <a:rPr sz="1600" b="0">
-                <a:solidFill>
-                  <a:srgbClr val="002333"/>
-                </a:solidFill>
-                <a:latin typeface="Inter"/>
-              </a:rPr>
-              <a:t>With Eduface</a:t>
-            </a:r>
-          </a:p>
-        </p:txBody>
-      </p:sp>
-      <p:sp>
-        <p:nvSpPr>
-          <p:cNvPr id="9" name="Rectangle 8"/>
+          <p:cNvPr id="7" name="Rounded Rectangle 6"/>
           <p:cNvSpPr/>
           <p:nvPr/>
         </p:nvSpPr>
         <p:spPr>
           <a:xfrm>
-            <a:off x="3556000" y="2755900"/>
-            <a:ext cx="6096000" cy="558800"/>
-          </a:xfrm>
-          <a:prstGeom prst="rect">
-            <a:avLst/>
-          </a:prstGeom>
-          <a:solidFill>
-            <a:srgbClr val="F3F7F8"/>
-          </a:solidFill>
-          <a:ln>
-            <a:noFill/>
-          </a:ln>
-          <a:effectLst/>
-        </p:spPr>
-        <p:style>
-          <a:lnRef idx="1">
-            <a:schemeClr val="accent1"/>
-          </a:lnRef>
-          <a:fillRef idx="3">
-            <a:schemeClr val="accent1"/>
-          </a:fillRef>
-          <a:effectRef idx="2">
-            <a:schemeClr val="accent1"/>
-          </a:effectRef>
-          <a:fontRef idx="minor">
-            <a:schemeClr val="lt1"/>
-          </a:fontRef>
-        </p:style>
-        <p:txBody>
-          <a:bodyPr rtlCol="0" anchor="ctr"/>
-          <a:lstStyle/>
-          <a:p>
-            <a:pPr algn="ctr"/>
-          </a:p>
-        </p:txBody>
-      </p:sp>
-      <p:sp>
-        <p:nvSpPr>
-          <p:cNvPr id="10" name="Rectangle 9"/>
-          <p:cNvSpPr/>
-          <p:nvPr/>
-        </p:nvSpPr>
-        <p:spPr>
-          <a:xfrm>
-            <a:off x="3860800" y="2755900"/>
-            <a:ext cx="711200" cy="558800"/>
-          </a:xfrm>
-          <a:prstGeom prst="rect">
-            <a:avLst/>
-          </a:prstGeom>
-          <a:solidFill>
-            <a:srgbClr val="00E075"/>
-          </a:solidFill>
-          <a:ln>
-            <a:noFill/>
-          </a:ln>
-          <a:effectLst/>
-        </p:spPr>
-        <p:style>
-          <a:lnRef idx="1">
-            <a:schemeClr val="accent1"/>
-          </a:lnRef>
-          <a:fillRef idx="3">
-            <a:schemeClr val="accent1"/>
-          </a:fillRef>
-          <a:effectRef idx="2">
-            <a:schemeClr val="accent1"/>
-          </a:effectRef>
-          <a:fontRef idx="minor">
-            <a:schemeClr val="lt1"/>
-          </a:fontRef>
-        </p:style>
-        <p:txBody>
-          <a:bodyPr rtlCol="0" anchor="ctr"/>
-          <a:lstStyle/>
-          <a:p>
-            <a:pPr algn="ctr"/>
-          </a:p>
-        </p:txBody>
-      </p:sp>
-      <p:sp>
-        <p:nvSpPr>
-          <p:cNvPr id="11" name="TextBox 10"/>
-          <p:cNvSpPr txBox="1"/>
-          <p:nvPr/>
-        </p:nvSpPr>
-        <p:spPr>
-          <a:xfrm>
-            <a:off x="9906000" y="2882900"/>
-            <a:ext cx="1524000" cy="355600"/>
-          </a:xfrm>
-          <a:prstGeom prst="rect">
-            <a:avLst/>
-          </a:prstGeom>
-          <a:noFill/>
-        </p:spPr>
-        <p:txBody>
-          <a:bodyPr wrap="square" lIns="0" rIns="0" tIns="0" bIns="0">
-            <a:spAutoFit/>
-          </a:bodyPr>
-          <a:lstStyle/>
-          <a:p>
-            <a:pPr algn="l">
-              <a:lnSpc>
-                <a:spcPct val="100000"/>
-              </a:lnSpc>
-            </a:pPr>
-            <a:r>
-              <a:rPr sz="2200" b="1">
-                <a:solidFill>
-                  <a:srgbClr val="002333"/>
-                </a:solidFill>
-                <a:latin typeface="League Spartan"/>
-              </a:rPr>
-              <a:t>1.5–5 min</a:t>
-            </a:r>
-          </a:p>
-        </p:txBody>
-      </p:sp>
-      <p:sp>
-        <p:nvSpPr>
-          <p:cNvPr id="12" name="Rectangle 11"/>
-          <p:cNvSpPr/>
-          <p:nvPr/>
-        </p:nvSpPr>
-        <p:spPr>
-          <a:xfrm>
-            <a:off x="3556000" y="1943100"/>
-            <a:ext cx="6350" cy="1371600"/>
-          </a:xfrm>
-          <a:prstGeom prst="rect">
-            <a:avLst/>
-          </a:prstGeom>
-          <a:solidFill>
-            <a:srgbClr val="CDD9DE"/>
-          </a:solidFill>
-          <a:ln>
-            <a:noFill/>
-          </a:ln>
-          <a:effectLst/>
-        </p:spPr>
-        <p:style>
-          <a:lnRef idx="1">
-            <a:schemeClr val="accent1"/>
-          </a:lnRef>
-          <a:fillRef idx="3">
-            <a:schemeClr val="accent1"/>
-          </a:fillRef>
-          <a:effectRef idx="2">
-            <a:schemeClr val="accent1"/>
-          </a:effectRef>
-          <a:fontRef idx="minor">
-            <a:schemeClr val="lt1"/>
-          </a:fontRef>
-        </p:style>
-        <p:txBody>
-          <a:bodyPr rtlCol="0" anchor="ctr"/>
-          <a:lstStyle/>
-          <a:p>
-            <a:pPr algn="ctr"/>
-          </a:p>
-        </p:txBody>
-      </p:sp>
-      <p:sp>
-        <p:nvSpPr>
-          <p:cNvPr id="13" name="TextBox 12"/>
-          <p:cNvSpPr txBox="1"/>
-          <p:nvPr/>
-        </p:nvSpPr>
-        <p:spPr>
-          <a:xfrm>
-            <a:off x="3302000" y="3416300"/>
-            <a:ext cx="508000" cy="228600"/>
-          </a:xfrm>
-          <a:prstGeom prst="rect">
-            <a:avLst/>
-          </a:prstGeom>
-          <a:noFill/>
-        </p:spPr>
-        <p:txBody>
-          <a:bodyPr wrap="square" lIns="0" rIns="0" tIns="0" bIns="0">
-            <a:spAutoFit/>
-          </a:bodyPr>
-          <a:lstStyle/>
-          <a:p>
-            <a:pPr algn="r">
-              <a:lnSpc>
-                <a:spcPct val="120000"/>
-              </a:lnSpc>
-            </a:pPr>
-            <a:r>
-              <a:rPr sz="1200" b="0">
-                <a:solidFill>
-                  <a:srgbClr val="5B7480"/>
-                </a:solidFill>
-                <a:latin typeface="Inter"/>
-              </a:rPr>
-              <a:t>0</a:t>
-            </a:r>
-          </a:p>
-        </p:txBody>
-      </p:sp>
-      <p:sp>
-        <p:nvSpPr>
-          <p:cNvPr id="14" name="TextBox 13"/>
-          <p:cNvSpPr txBox="1"/>
-          <p:nvPr/>
-        </p:nvSpPr>
-        <p:spPr>
-          <a:xfrm>
-            <a:off x="8382000" y="3416300"/>
-            <a:ext cx="1270000" cy="228600"/>
-          </a:xfrm>
-          <a:prstGeom prst="rect">
-            <a:avLst/>
-          </a:prstGeom>
-          <a:noFill/>
-        </p:spPr>
-        <p:txBody>
-          <a:bodyPr wrap="square" lIns="0" rIns="0" tIns="0" bIns="0">
-            <a:spAutoFit/>
-          </a:bodyPr>
-          <a:lstStyle/>
-          <a:p>
-            <a:pPr algn="r">
-              <a:lnSpc>
-                <a:spcPct val="120000"/>
-              </a:lnSpc>
-            </a:pPr>
-            <a:r>
-              <a:rPr sz="1200" b="0">
-                <a:solidFill>
-                  <a:srgbClr val="5B7480"/>
-                </a:solidFill>
-                <a:latin typeface="Inter"/>
-              </a:rPr>
-              <a:t>30</a:t>
-            </a:r>
-          </a:p>
-        </p:txBody>
-      </p:sp>
-      <p:sp>
-        <p:nvSpPr>
-          <p:cNvPr id="15" name="TextBox 14"/>
-          <p:cNvSpPr txBox="1"/>
-          <p:nvPr/>
-        </p:nvSpPr>
-        <p:spPr>
-          <a:xfrm>
-            <a:off x="3556000" y="3416300"/>
-            <a:ext cx="6096000" cy="228600"/>
-          </a:xfrm>
-          <a:prstGeom prst="rect">
-            <a:avLst/>
-          </a:prstGeom>
-          <a:noFill/>
-        </p:spPr>
-        <p:txBody>
-          <a:bodyPr wrap="square" lIns="0" rIns="0" tIns="0" bIns="0">
-            <a:spAutoFit/>
-          </a:bodyPr>
-          <a:lstStyle/>
-          <a:p>
-            <a:pPr algn="ctr">
-              <a:lnSpc>
-                <a:spcPct val="120000"/>
-              </a:lnSpc>
-            </a:pPr>
-            <a:r>
-              <a:rPr sz="1200" b="0">
-                <a:solidFill>
-                  <a:srgbClr val="5B7480"/>
-                </a:solidFill>
-                <a:latin typeface="Inter"/>
-              </a:rPr>
-              <a:t>minutes per submission</a:t>
-            </a:r>
-          </a:p>
-        </p:txBody>
-      </p:sp>
-      <p:sp>
-        <p:nvSpPr>
-          <p:cNvPr id="16" name="Rounded Rectangle 15"/>
-          <p:cNvSpPr/>
-          <p:nvPr/>
-        </p:nvSpPr>
-        <p:spPr>
-          <a:xfrm>
-            <a:off x="762000" y="4191000"/>
-            <a:ext cx="10668000" cy="1447800"/>
+            <a:off x="2133600" y="6184900"/>
+            <a:ext cx="952046" cy="533400"/>
           </a:xfrm>
           <a:prstGeom prst="roundRect">
             <a:avLst>
-              <a:gd name="adj" fmla="val 8771"/>
-            </a:avLst>
-          </a:prstGeom>
-          <a:solidFill>
-            <a:srgbClr val="F3F7F8"/>
-          </a:solidFill>
-          <a:ln>
-            <a:noFill/>
-          </a:ln>
-          <a:effectLst/>
-        </p:spPr>
-        <p:style>
-          <a:lnRef idx="1">
-            <a:schemeClr val="accent1"/>
-          </a:lnRef>
-          <a:fillRef idx="3">
-            <a:schemeClr val="accent1"/>
-          </a:fillRef>
-          <a:effectRef idx="2">
-            <a:schemeClr val="accent1"/>
-          </a:effectRef>
-          <a:fontRef idx="minor">
-            <a:schemeClr val="lt1"/>
-          </a:fontRef>
-        </p:style>
-        <p:txBody>
-          <a:bodyPr rtlCol="0" anchor="ctr"/>
-          <a:lstStyle/>
-          <a:p>
-            <a:pPr algn="ctr"/>
-          </a:p>
-        </p:txBody>
-      </p:sp>
-      <p:sp>
-        <p:nvSpPr>
-          <p:cNvPr id="17" name="Rounded Rectangle 16"/>
-          <p:cNvSpPr/>
-          <p:nvPr/>
-        </p:nvSpPr>
-        <p:spPr>
-          <a:xfrm>
-            <a:off x="914400" y="4521200"/>
-            <a:ext cx="609600" cy="609600"/>
-          </a:xfrm>
-          <a:prstGeom prst="roundRect">
-            <a:avLst>
-              <a:gd name="adj" fmla="val 16666"/>
+              <a:gd name="adj" fmla="val 11904"/>
             </a:avLst>
           </a:prstGeom>
           <a:solidFill>
@@ -7224,199 +6798,7 @@
       </p:sp>
       <p:pic>
         <p:nvPicPr>
-          <p:cNvPr id="18" name="Picture 17" descr="icon-doel-greendeep.png"/>
-          <p:cNvPicPr>
-            <a:picLocks noChangeAspect="1"/>
-          </p:cNvPicPr>
-          <p:nvPr/>
-        </p:nvPicPr>
-        <p:blipFill>
-          <a:blip r:embed="rId2"/>
-          <a:stretch>
-            <a:fillRect/>
-          </a:stretch>
-        </p:blipFill>
-        <p:spPr>
-          <a:xfrm>
-            <a:off x="1066800" y="4673600"/>
-            <a:ext cx="304800" cy="304800"/>
-          </a:xfrm>
-          <a:prstGeom prst="rect">
-            <a:avLst/>
-          </a:prstGeom>
-        </p:spPr>
-      </p:pic>
-      <p:sp>
-        <p:nvSpPr>
-          <p:cNvPr id="19" name="TextBox 18"/>
-          <p:cNvSpPr txBox="1"/>
-          <p:nvPr/>
-        </p:nvSpPr>
-        <p:spPr>
-          <a:xfrm>
-            <a:off x="1676400" y="4483100"/>
-            <a:ext cx="2438400" cy="406400"/>
-          </a:xfrm>
-          <a:prstGeom prst="rect">
-            <a:avLst/>
-          </a:prstGeom>
-          <a:noFill/>
-        </p:spPr>
-        <p:txBody>
-          <a:bodyPr wrap="square" lIns="0" rIns="0" tIns="0" bIns="0">
-            <a:spAutoFit/>
-          </a:bodyPr>
-          <a:lstStyle/>
-          <a:p>
-            <a:pPr algn="l">
-              <a:lnSpc>
-                <a:spcPct val="100000"/>
-              </a:lnSpc>
-            </a:pPr>
-            <a:r>
-              <a:rPr sz="2200" b="1">
-                <a:solidFill>
-                  <a:srgbClr val="002333"/>
-                </a:solidFill>
-                <a:latin typeface="League Spartan"/>
-              </a:rPr>
-              <a:t>~94%</a:t>
-            </a:r>
-          </a:p>
-        </p:txBody>
-      </p:sp>
-      <p:sp>
-        <p:nvSpPr>
-          <p:cNvPr id="20" name="TextBox 19"/>
-          <p:cNvSpPr txBox="1"/>
-          <p:nvPr/>
-        </p:nvSpPr>
-        <p:spPr>
-          <a:xfrm>
-            <a:off x="1676400" y="4902200"/>
-            <a:ext cx="2438400" cy="571500"/>
-          </a:xfrm>
-          <a:prstGeom prst="rect">
-            <a:avLst/>
-          </a:prstGeom>
-          <a:noFill/>
-        </p:spPr>
-        <p:txBody>
-          <a:bodyPr wrap="square" lIns="0" rIns="0" tIns="0" bIns="0">
-            <a:spAutoFit/>
-          </a:bodyPr>
-          <a:lstStyle/>
-          <a:p>
-            <a:pPr algn="l">
-              <a:lnSpc>
-                <a:spcPct val="135000"/>
-              </a:lnSpc>
-            </a:pPr>
-            <a:r>
-              <a:rPr sz="1200" b="0">
-                <a:solidFill>
-                  <a:srgbClr val="5B7480"/>
-                </a:solidFill>
-                <a:latin typeface="Inter"/>
-              </a:rPr>
-              <a:t>AI grading accuracy</a:t>
-            </a:r>
-          </a:p>
-        </p:txBody>
-      </p:sp>
-      <p:sp>
-        <p:nvSpPr>
-          <p:cNvPr id="21" name="Rectangle 20"/>
-          <p:cNvSpPr/>
-          <p:nvPr/>
-        </p:nvSpPr>
-        <p:spPr>
-          <a:xfrm>
-            <a:off x="4267200" y="4445000"/>
-            <a:ext cx="6350" cy="939800"/>
-          </a:xfrm>
-          <a:prstGeom prst="rect">
-            <a:avLst/>
-          </a:prstGeom>
-          <a:solidFill>
-            <a:srgbClr val="CDD9DE"/>
-          </a:solidFill>
-          <a:ln>
-            <a:noFill/>
-          </a:ln>
-          <a:effectLst/>
-        </p:spPr>
-        <p:style>
-          <a:lnRef idx="1">
-            <a:schemeClr val="accent1"/>
-          </a:lnRef>
-          <a:fillRef idx="3">
-            <a:schemeClr val="accent1"/>
-          </a:fillRef>
-          <a:effectRef idx="2">
-            <a:schemeClr val="accent1"/>
-          </a:effectRef>
-          <a:fontRef idx="minor">
-            <a:schemeClr val="lt1"/>
-          </a:fontRef>
-        </p:style>
-        <p:txBody>
-          <a:bodyPr rtlCol="0" anchor="ctr"/>
-          <a:lstStyle/>
-          <a:p>
-            <a:pPr algn="ctr"/>
-          </a:p>
-        </p:txBody>
-      </p:sp>
-      <p:sp>
-        <p:nvSpPr>
-          <p:cNvPr id="22" name="Rounded Rectangle 21"/>
-          <p:cNvSpPr/>
-          <p:nvPr/>
-        </p:nvSpPr>
-        <p:spPr>
-          <a:xfrm>
-            <a:off x="4572000" y="4521200"/>
-            <a:ext cx="609600" cy="609600"/>
-          </a:xfrm>
-          <a:prstGeom prst="roundRect">
-            <a:avLst>
-              <a:gd name="adj" fmla="val 16666"/>
-            </a:avLst>
-          </a:prstGeom>
-          <a:solidFill>
-            <a:srgbClr val="FFFFFF"/>
-          </a:solidFill>
-          <a:ln>
-            <a:noFill/>
-          </a:ln>
-          <a:effectLst/>
-        </p:spPr>
-        <p:style>
-          <a:lnRef idx="1">
-            <a:schemeClr val="accent1"/>
-          </a:lnRef>
-          <a:fillRef idx="3">
-            <a:schemeClr val="accent1"/>
-          </a:fillRef>
-          <a:effectRef idx="2">
-            <a:schemeClr val="accent1"/>
-          </a:effectRef>
-          <a:fontRef idx="minor">
-            <a:schemeClr val="lt1"/>
-          </a:fontRef>
-        </p:style>
-        <p:txBody>
-          <a:bodyPr rtlCol="0" anchor="ctr"/>
-          <a:lstStyle/>
-          <a:p>
-            <a:pPr algn="ctr"/>
-          </a:p>
-        </p:txBody>
-      </p:sp>
-      <p:pic>
-        <p:nvPicPr>
-          <p:cNvPr id="23" name="Picture 22" descr="icon-bestand-greendeep.png"/>
+          <p:cNvPr id="8" name="Picture 7" descr="uti-logo.png"/>
           <p:cNvPicPr>
             <a:picLocks noChangeAspect="1"/>
           </p:cNvPicPr>
@@ -7430,8 +6812,8 @@
         </p:blipFill>
         <p:spPr>
           <a:xfrm>
-            <a:off x="4724400" y="4673600"/>
-            <a:ext cx="304800" cy="304800"/>
+            <a:off x="2222500" y="6273800"/>
+            <a:ext cx="774246" cy="355600"/>
           </a:xfrm>
           <a:prstGeom prst="rect">
             <a:avLst/>
@@ -7440,14 +6822,14 @@
       </p:pic>
       <p:sp>
         <p:nvSpPr>
-          <p:cNvPr id="24" name="TextBox 23"/>
+          <p:cNvPr id="9" name="TextBox 8"/>
           <p:cNvSpPr txBox="1"/>
           <p:nvPr/>
         </p:nvSpPr>
         <p:spPr>
           <a:xfrm>
-            <a:off x="5334000" y="4483100"/>
-            <a:ext cx="2438400" cy="406400"/>
+            <a:off x="10922000" y="6375400"/>
+            <a:ext cx="508000" cy="228600"/>
           </a:xfrm>
           <a:prstGeom prst="rect">
             <a:avLst/>
@@ -7460,492 +6842,15 @@
           </a:bodyPr>
           <a:lstStyle/>
           <a:p>
-            <a:pPr algn="l">
-              <a:lnSpc>
-                <a:spcPct val="100000"/>
-              </a:lnSpc>
-            </a:pPr>
-            <a:r>
-              <a:rPr sz="2200" b="1">
-                <a:solidFill>
-                  <a:srgbClr val="002333"/>
-                </a:solidFill>
-                <a:latin typeface="League Spartan"/>
-              </a:rPr>
-              <a:t>2,300+</a:t>
-            </a:r>
-          </a:p>
-        </p:txBody>
-      </p:sp>
-      <p:sp>
-        <p:nvSpPr>
-          <p:cNvPr id="25" name="TextBox 24"/>
-          <p:cNvSpPr txBox="1"/>
-          <p:nvPr/>
-        </p:nvSpPr>
-        <p:spPr>
-          <a:xfrm>
-            <a:off x="5334000" y="4902200"/>
-            <a:ext cx="2438400" cy="571500"/>
-          </a:xfrm>
-          <a:prstGeom prst="rect">
-            <a:avLst/>
-          </a:prstGeom>
-          <a:noFill/>
-        </p:spPr>
-        <p:txBody>
-          <a:bodyPr wrap="square" lIns="0" rIns="0" tIns="0" bIns="0">
-            <a:spAutoFit/>
-          </a:bodyPr>
-          <a:lstStyle/>
-          <a:p>
-            <a:pPr algn="l">
-              <a:lnSpc>
-                <a:spcPct val="135000"/>
+            <a:pPr algn="r">
+              <a:lnSpc>
+                <a:spcPct val="115000"/>
               </a:lnSpc>
             </a:pPr>
             <a:r>
               <a:rPr sz="1200" b="0">
                 <a:solidFill>
-                  <a:srgbClr val="5B7480"/>
-                </a:solidFill>
-                <a:latin typeface="Inter"/>
-              </a:rPr>
-              <a:t>feedback items across</a:t>
-            </a:r>
-          </a:p>
-          <a:p>
-            <a:pPr algn="l">
-              <a:lnSpc>
-                <a:spcPct val="135000"/>
-              </a:lnSpc>
-            </a:pPr>
-            <a:r>
-              <a:rPr sz="1200" b="0">
-                <a:solidFill>
-                  <a:srgbClr val="5B7480"/>
-                </a:solidFill>
-                <a:latin typeface="Inter"/>
-              </a:rPr>
-              <a:t>435 submissions</a:t>
-            </a:r>
-          </a:p>
-        </p:txBody>
-      </p:sp>
-      <p:sp>
-        <p:nvSpPr>
-          <p:cNvPr id="26" name="Rectangle 25"/>
-          <p:cNvSpPr/>
-          <p:nvPr/>
-        </p:nvSpPr>
-        <p:spPr>
-          <a:xfrm>
-            <a:off x="7924800" y="4445000"/>
-            <a:ext cx="6350" cy="939800"/>
-          </a:xfrm>
-          <a:prstGeom prst="rect">
-            <a:avLst/>
-          </a:prstGeom>
-          <a:solidFill>
-            <a:srgbClr val="CDD9DE"/>
-          </a:solidFill>
-          <a:ln>
-            <a:noFill/>
-          </a:ln>
-          <a:effectLst/>
-        </p:spPr>
-        <p:style>
-          <a:lnRef idx="1">
-            <a:schemeClr val="accent1"/>
-          </a:lnRef>
-          <a:fillRef idx="3">
-            <a:schemeClr val="accent1"/>
-          </a:fillRef>
-          <a:effectRef idx="2">
-            <a:schemeClr val="accent1"/>
-          </a:effectRef>
-          <a:fontRef idx="minor">
-            <a:schemeClr val="lt1"/>
-          </a:fontRef>
-        </p:style>
-        <p:txBody>
-          <a:bodyPr rtlCol="0" anchor="ctr"/>
-          <a:lstStyle/>
-          <a:p>
-            <a:pPr algn="ctr"/>
-          </a:p>
-        </p:txBody>
-      </p:sp>
-      <p:sp>
-        <p:nvSpPr>
-          <p:cNvPr id="27" name="Rounded Rectangle 26"/>
-          <p:cNvSpPr/>
-          <p:nvPr/>
-        </p:nvSpPr>
-        <p:spPr>
-          <a:xfrm>
-            <a:off x="8229600" y="4521200"/>
-            <a:ext cx="609600" cy="609600"/>
-          </a:xfrm>
-          <a:prstGeom prst="roundRect">
-            <a:avLst>
-              <a:gd name="adj" fmla="val 16666"/>
-            </a:avLst>
-          </a:prstGeom>
-          <a:solidFill>
-            <a:srgbClr val="FFFFFF"/>
-          </a:solidFill>
-          <a:ln>
-            <a:noFill/>
-          </a:ln>
-          <a:effectLst/>
-        </p:spPr>
-        <p:style>
-          <a:lnRef idx="1">
-            <a:schemeClr val="accent1"/>
-          </a:lnRef>
-          <a:fillRef idx="3">
-            <a:schemeClr val="accent1"/>
-          </a:fillRef>
-          <a:effectRef idx="2">
-            <a:schemeClr val="accent1"/>
-          </a:effectRef>
-          <a:fontRef idx="minor">
-            <a:schemeClr val="lt1"/>
-          </a:fontRef>
-        </p:style>
-        <p:txBody>
-          <a:bodyPr rtlCol="0" anchor="ctr"/>
-          <a:lstStyle/>
-          <a:p>
-            <a:pPr algn="ctr"/>
-          </a:p>
-        </p:txBody>
-      </p:sp>
-      <p:pic>
-        <p:nvPicPr>
-          <p:cNvPr id="28" name="Picture 27" descr="icon-klok-greendeep.png"/>
-          <p:cNvPicPr>
-            <a:picLocks noChangeAspect="1"/>
-          </p:cNvPicPr>
-          <p:nvPr/>
-        </p:nvPicPr>
-        <p:blipFill>
-          <a:blip r:embed="rId4"/>
-          <a:stretch>
-            <a:fillRect/>
-          </a:stretch>
-        </p:blipFill>
-        <p:spPr>
-          <a:xfrm>
-            <a:off x="8382000" y="4673600"/>
-            <a:ext cx="304800" cy="304800"/>
-          </a:xfrm>
-          <a:prstGeom prst="rect">
-            <a:avLst/>
-          </a:prstGeom>
-        </p:spPr>
-      </p:pic>
-      <p:sp>
-        <p:nvSpPr>
-          <p:cNvPr id="29" name="TextBox 28"/>
-          <p:cNvSpPr txBox="1"/>
-          <p:nvPr/>
-        </p:nvSpPr>
-        <p:spPr>
-          <a:xfrm>
-            <a:off x="8991600" y="4483100"/>
-            <a:ext cx="2438400" cy="406400"/>
-          </a:xfrm>
-          <a:prstGeom prst="rect">
-            <a:avLst/>
-          </a:prstGeom>
-          <a:noFill/>
-        </p:spPr>
-        <p:txBody>
-          <a:bodyPr wrap="square" lIns="0" rIns="0" tIns="0" bIns="0">
-            <a:spAutoFit/>
-          </a:bodyPr>
-          <a:lstStyle/>
-          <a:p>
-            <a:pPr algn="l">
-              <a:lnSpc>
-                <a:spcPct val="100000"/>
-              </a:lnSpc>
-            </a:pPr>
-            <a:r>
-              <a:rPr sz="2200" b="1">
-                <a:solidFill>
-                  <a:srgbClr val="002333"/>
-                </a:solidFill>
-                <a:latin typeface="League Spartan"/>
-              </a:rPr>
-              <a:t>15–20 hrs</a:t>
-            </a:r>
-          </a:p>
-        </p:txBody>
-      </p:sp>
-      <p:sp>
-        <p:nvSpPr>
-          <p:cNvPr id="30" name="TextBox 29"/>
-          <p:cNvSpPr txBox="1"/>
-          <p:nvPr/>
-        </p:nvSpPr>
-        <p:spPr>
-          <a:xfrm>
-            <a:off x="8991600" y="4902200"/>
-            <a:ext cx="2438400" cy="571500"/>
-          </a:xfrm>
-          <a:prstGeom prst="rect">
-            <a:avLst/>
-          </a:prstGeom>
-          <a:noFill/>
-        </p:spPr>
-        <p:txBody>
-          <a:bodyPr wrap="square" lIns="0" rIns="0" tIns="0" bIns="0">
-            <a:spAutoFit/>
-          </a:bodyPr>
-          <a:lstStyle/>
-          <a:p>
-            <a:pPr algn="l">
-              <a:lnSpc>
-                <a:spcPct val="135000"/>
-              </a:lnSpc>
-            </a:pPr>
-            <a:r>
-              <a:rPr sz="1200" b="0">
-                <a:solidFill>
-                  <a:srgbClr val="5B7480"/>
-                </a:solidFill>
-                <a:latin typeface="Inter"/>
-              </a:rPr>
-              <a:t>saved per 60-student cohort,</a:t>
-            </a:r>
-          </a:p>
-          <a:p>
-            <a:pPr algn="l">
-              <a:lnSpc>
-                <a:spcPct val="135000"/>
-              </a:lnSpc>
-            </a:pPr>
-            <a:r>
-              <a:rPr sz="1200" b="0">
-                <a:solidFill>
-                  <a:srgbClr val="5B7480"/>
-                </a:solidFill>
-                <a:latin typeface="Inter"/>
-              </a:rPr>
-              <a:t>every cycle</a:t>
-            </a:r>
-          </a:p>
-        </p:txBody>
-      </p:sp>
-      <p:sp>
-        <p:nvSpPr>
-          <p:cNvPr id="31" name="Rectangle 30"/>
-          <p:cNvSpPr/>
-          <p:nvPr/>
-        </p:nvSpPr>
-        <p:spPr>
-          <a:xfrm>
-            <a:off x="762000" y="6045200"/>
-            <a:ext cx="10668000" cy="6350"/>
-          </a:xfrm>
-          <a:prstGeom prst="rect">
-            <a:avLst/>
-          </a:prstGeom>
-          <a:solidFill>
-            <a:srgbClr val="E7EEF0"/>
-          </a:solidFill>
-          <a:ln>
-            <a:noFill/>
-          </a:ln>
-          <a:effectLst/>
-        </p:spPr>
-        <p:style>
-          <a:lnRef idx="1">
-            <a:schemeClr val="accent1"/>
-          </a:lnRef>
-          <a:fillRef idx="3">
-            <a:schemeClr val="accent1"/>
-          </a:fillRef>
-          <a:effectRef idx="2">
-            <a:schemeClr val="accent1"/>
-          </a:effectRef>
-          <a:fontRef idx="minor">
-            <a:schemeClr val="lt1"/>
-          </a:fontRef>
-        </p:style>
-        <p:txBody>
-          <a:bodyPr rtlCol="0" anchor="ctr"/>
-          <a:lstStyle/>
-          <a:p>
-            <a:pPr algn="ctr"/>
-          </a:p>
-        </p:txBody>
-      </p:sp>
-      <p:pic>
-        <p:nvPicPr>
-          <p:cNvPr id="32" name="Picture 31" descr="logo_navy.png"/>
-          <p:cNvPicPr>
-            <a:picLocks noChangeAspect="1"/>
-          </p:cNvPicPr>
-          <p:nvPr/>
-        </p:nvPicPr>
-        <p:blipFill>
-          <a:blip r:embed="rId5"/>
-          <a:stretch>
-            <a:fillRect/>
-          </a:stretch>
-        </p:blipFill>
-        <p:spPr>
-          <a:xfrm>
-            <a:off x="762000" y="6324600"/>
-            <a:ext cx="937957" cy="254000"/>
-          </a:xfrm>
-          <a:prstGeom prst="rect">
-            <a:avLst/>
-          </a:prstGeom>
-        </p:spPr>
-      </p:pic>
-      <p:sp>
-        <p:nvSpPr>
-          <p:cNvPr id="33" name="Rectangle 32"/>
-          <p:cNvSpPr/>
-          <p:nvPr/>
-        </p:nvSpPr>
-        <p:spPr>
-          <a:xfrm>
-            <a:off x="1968500" y="6311900"/>
-            <a:ext cx="6350" cy="279400"/>
-          </a:xfrm>
-          <a:prstGeom prst="rect">
-            <a:avLst/>
-          </a:prstGeom>
-          <a:solidFill>
-            <a:srgbClr val="CDD9DE"/>
-          </a:solidFill>
-          <a:ln>
-            <a:noFill/>
-          </a:ln>
-          <a:effectLst/>
-        </p:spPr>
-        <p:style>
-          <a:lnRef idx="1">
-            <a:schemeClr val="accent1"/>
-          </a:lnRef>
-          <a:fillRef idx="3">
-            <a:schemeClr val="accent1"/>
-          </a:fillRef>
-          <a:effectRef idx="2">
-            <a:schemeClr val="accent1"/>
-          </a:effectRef>
-          <a:fontRef idx="minor">
-            <a:schemeClr val="lt1"/>
-          </a:fontRef>
-        </p:style>
-        <p:txBody>
-          <a:bodyPr rtlCol="0" anchor="ctr"/>
-          <a:lstStyle/>
-          <a:p>
-            <a:pPr algn="ctr"/>
-          </a:p>
-        </p:txBody>
-      </p:sp>
-      <p:pic>
-        <p:nvPicPr>
-          <p:cNvPr id="34" name="Picture 33" descr="uti-logo.png"/>
-          <p:cNvPicPr>
-            <a:picLocks noChangeAspect="1"/>
-          </p:cNvPicPr>
-          <p:nvPr/>
-        </p:nvPicPr>
-        <p:blipFill>
-          <a:blip r:embed="rId6"/>
-          <a:stretch>
-            <a:fillRect/>
-          </a:stretch>
-        </p:blipFill>
-        <p:spPr>
-          <a:xfrm>
-            <a:off x="2222500" y="6273800"/>
-            <a:ext cx="774246" cy="355600"/>
-          </a:xfrm>
-          <a:prstGeom prst="rect">
-            <a:avLst/>
-          </a:prstGeom>
-        </p:spPr>
-      </p:pic>
-      <p:sp>
-        <p:nvSpPr>
-          <p:cNvPr id="35" name="TextBox 34"/>
-          <p:cNvSpPr txBox="1"/>
-          <p:nvPr/>
-        </p:nvSpPr>
-        <p:spPr>
-          <a:xfrm>
-            <a:off x="5715000" y="6375400"/>
-            <a:ext cx="5080000" cy="243840"/>
-          </a:xfrm>
-          <a:prstGeom prst="rect">
-            <a:avLst/>
-          </a:prstGeom>
-          <a:noFill/>
-        </p:spPr>
-        <p:txBody>
-          <a:bodyPr wrap="square" lIns="0" rIns="0" tIns="0" bIns="0">
-            <a:spAutoFit/>
-          </a:bodyPr>
-          <a:lstStyle/>
-          <a:p>
-            <a:pPr algn="r">
-              <a:lnSpc>
-                <a:spcPct val="135000"/>
-              </a:lnSpc>
-            </a:pPr>
-            <a:r>
-              <a:rPr sz="1200" b="0">
-                <a:solidFill>
-                  <a:srgbClr val="5B7480"/>
-                </a:solidFill>
-                <a:latin typeface="Inter"/>
-              </a:rPr>
-              <a:t>Source: Bath Spa University · Eduface pilot data.</a:t>
-            </a:r>
-          </a:p>
-        </p:txBody>
-      </p:sp>
-      <p:sp>
-        <p:nvSpPr>
-          <p:cNvPr id="36" name="TextBox 35"/>
-          <p:cNvSpPr txBox="1"/>
-          <p:nvPr/>
-        </p:nvSpPr>
-        <p:spPr>
-          <a:xfrm>
-            <a:off x="10922000" y="6375400"/>
-            <a:ext cx="508000" cy="228600"/>
-          </a:xfrm>
-          <a:prstGeom prst="rect">
-            <a:avLst/>
-          </a:prstGeom>
-          <a:noFill/>
-        </p:spPr>
-        <p:txBody>
-          <a:bodyPr wrap="square" lIns="0" rIns="0" tIns="0" bIns="0">
-            <a:spAutoFit/>
-          </a:bodyPr>
-          <a:lstStyle/>
-          <a:p>
-            <a:pPr algn="r">
-              <a:lnSpc>
-                <a:spcPct val="115000"/>
-              </a:lnSpc>
-            </a:pPr>
-            <a:r>
-              <a:rPr sz="1200" b="0">
-                <a:solidFill>
-                  <a:srgbClr val="5B7480"/>
+                  <a:srgbClr val="9EABB1"/>
                 </a:solidFill>
                 <a:latin typeface="Inter"/>
               </a:rPr>
@@ -8025,7 +6930,7 @@
         <p:spPr>
           <a:xfrm>
             <a:off x="762000" y="558800"/>
-            <a:ext cx="10668000" cy="627380"/>
+            <a:ext cx="10668000" cy="1061720"/>
           </a:xfrm>
           <a:prstGeom prst="rect">
             <a:avLst/>
@@ -8050,7 +6955,7 @@
                 </a:solidFill>
                 <a:latin typeface="League Spartan"/>
               </a:rPr>
-              <a:t>Institution-wide feedback, priced per student</a:t>
+              <a:t>Marking Time Drops 6–10x at Bath Spa University</a:t>
             </a:r>
           </a:p>
         </p:txBody>
@@ -8063,8 +6968,8 @@
         </p:nvSpPr>
         <p:spPr>
           <a:xfrm>
-            <a:off x="762000" y="1270000"/>
-            <a:ext cx="10668000" cy="304800"/>
+            <a:off x="762000" y="2095500"/>
+            <a:ext cx="2540000" cy="304800"/>
           </a:xfrm>
           <a:prstGeom prst="rect">
             <a:avLst/>
@@ -8077,41 +6982,39 @@
           </a:bodyPr>
           <a:lstStyle/>
           <a:p>
-            <a:pPr algn="l">
-              <a:lnSpc>
-                <a:spcPct val="130000"/>
+            <a:pPr algn="r">
+              <a:lnSpc>
+                <a:spcPct val="120000"/>
               </a:lnSpc>
             </a:pPr>
             <a:r>
               <a:rPr sz="1600" b="0">
                 <a:solidFill>
-                  <a:srgbClr val="5B7480"/>
+                  <a:srgbClr val="2C4A57"/>
                 </a:solidFill>
                 <a:latin typeface="Inter"/>
               </a:rPr>
-              <a:t>Delivered by Eduface, mapped to what UTI needs.</a:t>
-            </a:r>
-          </a:p>
-        </p:txBody>
-      </p:sp>
-      <p:sp>
-        <p:nvSpPr>
-          <p:cNvPr id="5" name="Rounded Rectangle 4"/>
+              <a:t>Traditional marking</a:t>
+            </a:r>
+          </a:p>
+        </p:txBody>
+      </p:sp>
+      <p:sp>
+        <p:nvSpPr>
+          <p:cNvPr id="5" name="Rectangle 4"/>
           <p:cNvSpPr/>
           <p:nvPr/>
         </p:nvSpPr>
         <p:spPr>
           <a:xfrm>
-            <a:off x="762000" y="1905000"/>
-            <a:ext cx="10668000" cy="2260600"/>
-          </a:xfrm>
-          <a:prstGeom prst="roundRect">
-            <a:avLst>
-              <a:gd name="adj" fmla="val 6741"/>
-            </a:avLst>
+            <a:off x="3556000" y="1943100"/>
+            <a:ext cx="6096000" cy="558800"/>
+          </a:xfrm>
+          <a:prstGeom prst="rect">
+            <a:avLst/>
           </a:prstGeom>
           <a:solidFill>
-            <a:srgbClr val="002333"/>
+            <a:srgbClr val="F3F7F8"/>
           </a:solidFill>
           <a:ln>
             <a:noFill/>
@@ -8142,153 +7045,20 @@
       </p:sp>
       <p:sp>
         <p:nvSpPr>
-          <p:cNvPr id="6" name="TextBox 5"/>
-          <p:cNvSpPr txBox="1"/>
-          <p:nvPr/>
-        </p:nvSpPr>
-        <p:spPr>
-          <a:xfrm>
-            <a:off x="1219200" y="2362200"/>
-            <a:ext cx="1905000" cy="1333500"/>
-          </a:xfrm>
-          <a:prstGeom prst="rect">
-            <a:avLst/>
-          </a:prstGeom>
-          <a:noFill/>
-        </p:spPr>
-        <p:txBody>
-          <a:bodyPr wrap="square" lIns="0" rIns="0" tIns="0" bIns="0">
-            <a:spAutoFit/>
-          </a:bodyPr>
-          <a:lstStyle/>
-          <a:p>
-            <a:pPr algn="l">
-              <a:lnSpc>
-                <a:spcPct val="90000"/>
-              </a:lnSpc>
-            </a:pPr>
-            <a:r>
-              <a:rPr sz="9000" b="1">
-                <a:solidFill>
-                  <a:srgbClr val="FFFFFF"/>
-                </a:solidFill>
-                <a:latin typeface="League Spartan"/>
-              </a:rPr>
-              <a:t>$3</a:t>
-            </a:r>
-          </a:p>
-        </p:txBody>
-      </p:sp>
-      <p:sp>
-        <p:nvSpPr>
-          <p:cNvPr id="7" name="TextBox 6"/>
-          <p:cNvSpPr txBox="1"/>
-          <p:nvPr/>
-        </p:nvSpPr>
-        <p:spPr>
-          <a:xfrm>
-            <a:off x="2717800" y="2540000"/>
-            <a:ext cx="2667000" cy="711200"/>
-          </a:xfrm>
-          <a:prstGeom prst="rect">
-            <a:avLst/>
-          </a:prstGeom>
-          <a:noFill/>
-        </p:spPr>
-        <p:txBody>
-          <a:bodyPr wrap="square" lIns="0" rIns="0" tIns="0" bIns="0">
-            <a:spAutoFit/>
-          </a:bodyPr>
-          <a:lstStyle/>
-          <a:p>
-            <a:pPr algn="l">
-              <a:lnSpc>
-                <a:spcPct val="115000"/>
-              </a:lnSpc>
-            </a:pPr>
-            <a:r>
-              <a:rPr sz="2200" b="1">
-                <a:solidFill>
-                  <a:srgbClr val="FFFFFF"/>
-                </a:solidFill>
-                <a:latin typeface="League Spartan"/>
-              </a:rPr>
-              <a:t>per student,</a:t>
-            </a:r>
-          </a:p>
-          <a:p>
-            <a:pPr algn="l">
-              <a:lnSpc>
-                <a:spcPct val="115000"/>
-              </a:lnSpc>
-            </a:pPr>
-            <a:r>
-              <a:rPr sz="2200" b="1">
-                <a:solidFill>
-                  <a:srgbClr val="FFFFFF"/>
-                </a:solidFill>
-                <a:latin typeface="League Spartan"/>
-              </a:rPr>
-              <a:t>per month</a:t>
-            </a:r>
-          </a:p>
-        </p:txBody>
-      </p:sp>
-      <p:sp>
-        <p:nvSpPr>
-          <p:cNvPr id="8" name="TextBox 7"/>
-          <p:cNvSpPr txBox="1"/>
-          <p:nvPr/>
-        </p:nvSpPr>
-        <p:spPr>
-          <a:xfrm>
-            <a:off x="1219200" y="3429000"/>
-            <a:ext cx="3302000" cy="279400"/>
-          </a:xfrm>
-          <a:prstGeom prst="rect">
-            <a:avLst/>
-          </a:prstGeom>
-          <a:noFill/>
-        </p:spPr>
-        <p:txBody>
-          <a:bodyPr wrap="square" lIns="0" rIns="0" tIns="0" bIns="0">
-            <a:spAutoFit/>
-          </a:bodyPr>
-          <a:lstStyle/>
-          <a:p>
-            <a:pPr algn="l">
-              <a:lnSpc>
-                <a:spcPct val="120000"/>
-              </a:lnSpc>
-            </a:pPr>
-            <a:r>
-              <a:rPr sz="1600" b="0">
-                <a:solidFill>
-                  <a:srgbClr val="9EABB1"/>
-                </a:solidFill>
-                <a:latin typeface="Inter"/>
-              </a:rPr>
-              <a:t>billed annually</a:t>
-            </a:r>
-          </a:p>
-        </p:txBody>
-      </p:sp>
-      <p:sp>
-        <p:nvSpPr>
-          <p:cNvPr id="9" name="Rectangle 8"/>
+          <p:cNvPr id="6" name="Rectangle 5"/>
           <p:cNvSpPr/>
           <p:nvPr/>
         </p:nvSpPr>
         <p:spPr>
           <a:xfrm>
-            <a:off x="5715000" y="2159000"/>
-            <a:ext cx="6350" cy="1752600"/>
+            <a:off x="6604000" y="1943100"/>
+            <a:ext cx="3048000" cy="558800"/>
           </a:xfrm>
           <a:prstGeom prst="rect">
             <a:avLst/>
           </a:prstGeom>
           <a:solidFill>
-            <a:srgbClr val="1F3D4B"/>
+            <a:srgbClr val="CDD9DE"/>
           </a:solidFill>
           <a:ln>
             <a:noFill/>
@@ -8319,22 +7089,98 @@
       </p:sp>
       <p:sp>
         <p:nvSpPr>
-          <p:cNvPr id="10" name="Rounded Rectangle 9"/>
+          <p:cNvPr id="7" name="TextBox 6"/>
+          <p:cNvSpPr txBox="1"/>
+          <p:nvPr/>
+        </p:nvSpPr>
+        <p:spPr>
+          <a:xfrm>
+            <a:off x="9906000" y="2070100"/>
+            <a:ext cx="1524000" cy="355600"/>
+          </a:xfrm>
+          <a:prstGeom prst="rect">
+            <a:avLst/>
+          </a:prstGeom>
+          <a:noFill/>
+        </p:spPr>
+        <p:txBody>
+          <a:bodyPr wrap="square" lIns="0" rIns="0" tIns="0" bIns="0">
+            <a:spAutoFit/>
+          </a:bodyPr>
+          <a:lstStyle/>
+          <a:p>
+            <a:pPr algn="l">
+              <a:lnSpc>
+                <a:spcPct val="100000"/>
+              </a:lnSpc>
+            </a:pPr>
+            <a:r>
+              <a:rPr sz="2200" b="1">
+                <a:solidFill>
+                  <a:srgbClr val="002333"/>
+                </a:solidFill>
+                <a:latin typeface="League Spartan"/>
+              </a:rPr>
+              <a:t>15–30 min</a:t>
+            </a:r>
+          </a:p>
+        </p:txBody>
+      </p:sp>
+      <p:sp>
+        <p:nvSpPr>
+          <p:cNvPr id="8" name="TextBox 7"/>
+          <p:cNvSpPr txBox="1"/>
+          <p:nvPr/>
+        </p:nvSpPr>
+        <p:spPr>
+          <a:xfrm>
+            <a:off x="762000" y="2908300"/>
+            <a:ext cx="2540000" cy="304800"/>
+          </a:xfrm>
+          <a:prstGeom prst="rect">
+            <a:avLst/>
+          </a:prstGeom>
+          <a:noFill/>
+        </p:spPr>
+        <p:txBody>
+          <a:bodyPr wrap="square" lIns="0" rIns="0" tIns="0" bIns="0">
+            <a:spAutoFit/>
+          </a:bodyPr>
+          <a:lstStyle/>
+          <a:p>
+            <a:pPr algn="r">
+              <a:lnSpc>
+                <a:spcPct val="120000"/>
+              </a:lnSpc>
+            </a:pPr>
+            <a:r>
+              <a:rPr sz="1600" b="0">
+                <a:solidFill>
+                  <a:srgbClr val="002333"/>
+                </a:solidFill>
+                <a:latin typeface="Inter"/>
+              </a:rPr>
+              <a:t>With Eduface</a:t>
+            </a:r>
+          </a:p>
+        </p:txBody>
+      </p:sp>
+      <p:sp>
+        <p:nvSpPr>
+          <p:cNvPr id="9" name="Rectangle 8"/>
           <p:cNvSpPr/>
           <p:nvPr/>
         </p:nvSpPr>
         <p:spPr>
           <a:xfrm>
-            <a:off x="6121400" y="2552700"/>
-            <a:ext cx="355600" cy="355600"/>
-          </a:xfrm>
-          <a:prstGeom prst="roundRect">
-            <a:avLst>
-              <a:gd name="adj" fmla="val 25000"/>
-            </a:avLst>
+            <a:off x="3556000" y="2755900"/>
+            <a:ext cx="6096000" cy="558800"/>
+          </a:xfrm>
+          <a:prstGeom prst="rect">
+            <a:avLst/>
           </a:prstGeom>
           <a:solidFill>
-            <a:srgbClr val="0A2C3B"/>
+            <a:srgbClr val="F3F7F8"/>
           </a:solidFill>
           <a:ln>
             <a:noFill/>
@@ -8363,9 +7209,345 @@
           </a:p>
         </p:txBody>
       </p:sp>
+      <p:sp>
+        <p:nvSpPr>
+          <p:cNvPr id="10" name="Rectangle 9"/>
+          <p:cNvSpPr/>
+          <p:nvPr/>
+        </p:nvSpPr>
+        <p:spPr>
+          <a:xfrm>
+            <a:off x="3860800" y="2755900"/>
+            <a:ext cx="711200" cy="558800"/>
+          </a:xfrm>
+          <a:prstGeom prst="rect">
+            <a:avLst/>
+          </a:prstGeom>
+          <a:solidFill>
+            <a:srgbClr val="00E075"/>
+          </a:solidFill>
+          <a:ln>
+            <a:noFill/>
+          </a:ln>
+          <a:effectLst/>
+        </p:spPr>
+        <p:style>
+          <a:lnRef idx="1">
+            <a:schemeClr val="accent1"/>
+          </a:lnRef>
+          <a:fillRef idx="3">
+            <a:schemeClr val="accent1"/>
+          </a:fillRef>
+          <a:effectRef idx="2">
+            <a:schemeClr val="accent1"/>
+          </a:effectRef>
+          <a:fontRef idx="minor">
+            <a:schemeClr val="lt1"/>
+          </a:fontRef>
+        </p:style>
+        <p:txBody>
+          <a:bodyPr rtlCol="0" anchor="ctr"/>
+          <a:lstStyle/>
+          <a:p>
+            <a:pPr algn="ctr"/>
+          </a:p>
+        </p:txBody>
+      </p:sp>
+      <p:sp>
+        <p:nvSpPr>
+          <p:cNvPr id="11" name="TextBox 10"/>
+          <p:cNvSpPr txBox="1"/>
+          <p:nvPr/>
+        </p:nvSpPr>
+        <p:spPr>
+          <a:xfrm>
+            <a:off x="9906000" y="2882900"/>
+            <a:ext cx="1524000" cy="355600"/>
+          </a:xfrm>
+          <a:prstGeom prst="rect">
+            <a:avLst/>
+          </a:prstGeom>
+          <a:noFill/>
+        </p:spPr>
+        <p:txBody>
+          <a:bodyPr wrap="square" lIns="0" rIns="0" tIns="0" bIns="0">
+            <a:spAutoFit/>
+          </a:bodyPr>
+          <a:lstStyle/>
+          <a:p>
+            <a:pPr algn="l">
+              <a:lnSpc>
+                <a:spcPct val="100000"/>
+              </a:lnSpc>
+            </a:pPr>
+            <a:r>
+              <a:rPr sz="2200" b="1">
+                <a:solidFill>
+                  <a:srgbClr val="002333"/>
+                </a:solidFill>
+                <a:latin typeface="League Spartan"/>
+              </a:rPr>
+              <a:t>1.5–5 min</a:t>
+            </a:r>
+          </a:p>
+        </p:txBody>
+      </p:sp>
+      <p:sp>
+        <p:nvSpPr>
+          <p:cNvPr id="12" name="Rectangle 11"/>
+          <p:cNvSpPr/>
+          <p:nvPr/>
+        </p:nvSpPr>
+        <p:spPr>
+          <a:xfrm>
+            <a:off x="3556000" y="1943100"/>
+            <a:ext cx="6350" cy="1371600"/>
+          </a:xfrm>
+          <a:prstGeom prst="rect">
+            <a:avLst/>
+          </a:prstGeom>
+          <a:solidFill>
+            <a:srgbClr val="CDD9DE"/>
+          </a:solidFill>
+          <a:ln>
+            <a:noFill/>
+          </a:ln>
+          <a:effectLst/>
+        </p:spPr>
+        <p:style>
+          <a:lnRef idx="1">
+            <a:schemeClr val="accent1"/>
+          </a:lnRef>
+          <a:fillRef idx="3">
+            <a:schemeClr val="accent1"/>
+          </a:fillRef>
+          <a:effectRef idx="2">
+            <a:schemeClr val="accent1"/>
+          </a:effectRef>
+          <a:fontRef idx="minor">
+            <a:schemeClr val="lt1"/>
+          </a:fontRef>
+        </p:style>
+        <p:txBody>
+          <a:bodyPr rtlCol="0" anchor="ctr"/>
+          <a:lstStyle/>
+          <a:p>
+            <a:pPr algn="ctr"/>
+          </a:p>
+        </p:txBody>
+      </p:sp>
+      <p:sp>
+        <p:nvSpPr>
+          <p:cNvPr id="13" name="TextBox 12"/>
+          <p:cNvSpPr txBox="1"/>
+          <p:nvPr/>
+        </p:nvSpPr>
+        <p:spPr>
+          <a:xfrm>
+            <a:off x="3302000" y="3416300"/>
+            <a:ext cx="508000" cy="228600"/>
+          </a:xfrm>
+          <a:prstGeom prst="rect">
+            <a:avLst/>
+          </a:prstGeom>
+          <a:noFill/>
+        </p:spPr>
+        <p:txBody>
+          <a:bodyPr wrap="square" lIns="0" rIns="0" tIns="0" bIns="0">
+            <a:spAutoFit/>
+          </a:bodyPr>
+          <a:lstStyle/>
+          <a:p>
+            <a:pPr algn="r">
+              <a:lnSpc>
+                <a:spcPct val="120000"/>
+              </a:lnSpc>
+            </a:pPr>
+            <a:r>
+              <a:rPr sz="1200" b="0">
+                <a:solidFill>
+                  <a:srgbClr val="5B7480"/>
+                </a:solidFill>
+                <a:latin typeface="Inter"/>
+              </a:rPr>
+              <a:t>0</a:t>
+            </a:r>
+          </a:p>
+        </p:txBody>
+      </p:sp>
+      <p:sp>
+        <p:nvSpPr>
+          <p:cNvPr id="14" name="TextBox 13"/>
+          <p:cNvSpPr txBox="1"/>
+          <p:nvPr/>
+        </p:nvSpPr>
+        <p:spPr>
+          <a:xfrm>
+            <a:off x="8382000" y="3416300"/>
+            <a:ext cx="1270000" cy="228600"/>
+          </a:xfrm>
+          <a:prstGeom prst="rect">
+            <a:avLst/>
+          </a:prstGeom>
+          <a:noFill/>
+        </p:spPr>
+        <p:txBody>
+          <a:bodyPr wrap="square" lIns="0" rIns="0" tIns="0" bIns="0">
+            <a:spAutoFit/>
+          </a:bodyPr>
+          <a:lstStyle/>
+          <a:p>
+            <a:pPr algn="r">
+              <a:lnSpc>
+                <a:spcPct val="120000"/>
+              </a:lnSpc>
+            </a:pPr>
+            <a:r>
+              <a:rPr sz="1200" b="0">
+                <a:solidFill>
+                  <a:srgbClr val="5B7480"/>
+                </a:solidFill>
+                <a:latin typeface="Inter"/>
+              </a:rPr>
+              <a:t>30</a:t>
+            </a:r>
+          </a:p>
+        </p:txBody>
+      </p:sp>
+      <p:sp>
+        <p:nvSpPr>
+          <p:cNvPr id="15" name="TextBox 14"/>
+          <p:cNvSpPr txBox="1"/>
+          <p:nvPr/>
+        </p:nvSpPr>
+        <p:spPr>
+          <a:xfrm>
+            <a:off x="3556000" y="3416300"/>
+            <a:ext cx="6096000" cy="228600"/>
+          </a:xfrm>
+          <a:prstGeom prst="rect">
+            <a:avLst/>
+          </a:prstGeom>
+          <a:noFill/>
+        </p:spPr>
+        <p:txBody>
+          <a:bodyPr wrap="square" lIns="0" rIns="0" tIns="0" bIns="0">
+            <a:spAutoFit/>
+          </a:bodyPr>
+          <a:lstStyle/>
+          <a:p>
+            <a:pPr algn="ctr">
+              <a:lnSpc>
+                <a:spcPct val="120000"/>
+              </a:lnSpc>
+            </a:pPr>
+            <a:r>
+              <a:rPr sz="1200" b="0">
+                <a:solidFill>
+                  <a:srgbClr val="5B7480"/>
+                </a:solidFill>
+                <a:latin typeface="Inter"/>
+              </a:rPr>
+              <a:t>minutes per submission</a:t>
+            </a:r>
+          </a:p>
+        </p:txBody>
+      </p:sp>
+      <p:sp>
+        <p:nvSpPr>
+          <p:cNvPr id="16" name="Rounded Rectangle 15"/>
+          <p:cNvSpPr/>
+          <p:nvPr/>
+        </p:nvSpPr>
+        <p:spPr>
+          <a:xfrm>
+            <a:off x="762000" y="4191000"/>
+            <a:ext cx="10668000" cy="1447800"/>
+          </a:xfrm>
+          <a:prstGeom prst="roundRect">
+            <a:avLst>
+              <a:gd name="adj" fmla="val 8771"/>
+            </a:avLst>
+          </a:prstGeom>
+          <a:solidFill>
+            <a:srgbClr val="F3F7F8"/>
+          </a:solidFill>
+          <a:ln>
+            <a:noFill/>
+          </a:ln>
+          <a:effectLst/>
+        </p:spPr>
+        <p:style>
+          <a:lnRef idx="1">
+            <a:schemeClr val="accent1"/>
+          </a:lnRef>
+          <a:fillRef idx="3">
+            <a:schemeClr val="accent1"/>
+          </a:fillRef>
+          <a:effectRef idx="2">
+            <a:schemeClr val="accent1"/>
+          </a:effectRef>
+          <a:fontRef idx="minor">
+            <a:schemeClr val="lt1"/>
+          </a:fontRef>
+        </p:style>
+        <p:txBody>
+          <a:bodyPr rtlCol="0" anchor="ctr"/>
+          <a:lstStyle/>
+          <a:p>
+            <a:pPr algn="ctr"/>
+          </a:p>
+        </p:txBody>
+      </p:sp>
+      <p:sp>
+        <p:nvSpPr>
+          <p:cNvPr id="17" name="Rounded Rectangle 16"/>
+          <p:cNvSpPr/>
+          <p:nvPr/>
+        </p:nvSpPr>
+        <p:spPr>
+          <a:xfrm>
+            <a:off x="914400" y="4521200"/>
+            <a:ext cx="609600" cy="609600"/>
+          </a:xfrm>
+          <a:prstGeom prst="roundRect">
+            <a:avLst>
+              <a:gd name="adj" fmla="val 16666"/>
+            </a:avLst>
+          </a:prstGeom>
+          <a:solidFill>
+            <a:srgbClr val="FFFFFF"/>
+          </a:solidFill>
+          <a:ln>
+            <a:noFill/>
+          </a:ln>
+          <a:effectLst/>
+        </p:spPr>
+        <p:style>
+          <a:lnRef idx="1">
+            <a:schemeClr val="accent1"/>
+          </a:lnRef>
+          <a:fillRef idx="3">
+            <a:schemeClr val="accent1"/>
+          </a:fillRef>
+          <a:effectRef idx="2">
+            <a:schemeClr val="accent1"/>
+          </a:effectRef>
+          <a:fontRef idx="minor">
+            <a:schemeClr val="lt1"/>
+          </a:fontRef>
+        </p:style>
+        <p:txBody>
+          <a:bodyPr rtlCol="0" anchor="ctr"/>
+          <a:lstStyle/>
+          <a:p>
+            <a:pPr algn="ctr"/>
+          </a:p>
+        </p:txBody>
+      </p:sp>
       <p:pic>
         <p:nvPicPr>
-          <p:cNvPr id="11" name="Picture 10" descr="icon-check-green.png"/>
+          <p:cNvPr id="18" name="Picture 17" descr="icon-doel-greendeep.png"/>
           <p:cNvPicPr>
             <a:picLocks noChangeAspect="1"/>
           </p:cNvPicPr>
@@ -8379,8 +7561,8 @@
         </p:blipFill>
         <p:spPr>
           <a:xfrm>
-            <a:off x="6210300" y="2641600"/>
-            <a:ext cx="177800" cy="177800"/>
+            <a:off x="1066800" y="4673600"/>
+            <a:ext cx="304800" cy="304800"/>
           </a:xfrm>
           <a:prstGeom prst="rect">
             <a:avLst/>
@@ -8389,14 +7571,14 @@
       </p:pic>
       <p:sp>
         <p:nvSpPr>
-          <p:cNvPr id="12" name="TextBox 11"/>
+          <p:cNvPr id="19" name="TextBox 18"/>
           <p:cNvSpPr txBox="1"/>
           <p:nvPr/>
         </p:nvSpPr>
         <p:spPr>
           <a:xfrm>
-            <a:off x="6654800" y="2590800"/>
-            <a:ext cx="4318000" cy="304800"/>
+            <a:off x="1676400" y="4483100"/>
+            <a:ext cx="2438400" cy="406400"/>
           </a:xfrm>
           <a:prstGeom prst="rect">
             <a:avLst/>
@@ -8411,39 +7593,76 @@
           <a:p>
             <a:pPr algn="l">
               <a:lnSpc>
+                <a:spcPct val="100000"/>
+              </a:lnSpc>
+            </a:pPr>
+            <a:r>
+              <a:rPr sz="2200" b="1">
+                <a:solidFill>
+                  <a:srgbClr val="002333"/>
+                </a:solidFill>
+                <a:latin typeface="League Spartan"/>
+              </a:rPr>
+              <a:t>~94%</a:t>
+            </a:r>
+          </a:p>
+        </p:txBody>
+      </p:sp>
+      <p:sp>
+        <p:nvSpPr>
+          <p:cNvPr id="20" name="TextBox 19"/>
+          <p:cNvSpPr txBox="1"/>
+          <p:nvPr/>
+        </p:nvSpPr>
+        <p:spPr>
+          <a:xfrm>
+            <a:off x="1676400" y="4902200"/>
+            <a:ext cx="2438400" cy="571500"/>
+          </a:xfrm>
+          <a:prstGeom prst="rect">
+            <a:avLst/>
+          </a:prstGeom>
+          <a:noFill/>
+        </p:spPr>
+        <p:txBody>
+          <a:bodyPr wrap="square" lIns="0" rIns="0" tIns="0" bIns="0">
+            <a:spAutoFit/>
+          </a:bodyPr>
+          <a:lstStyle/>
+          <a:p>
+            <a:pPr algn="l">
+              <a:lnSpc>
                 <a:spcPct val="135000"/>
               </a:lnSpc>
             </a:pPr>
             <a:r>
-              <a:rPr sz="1600" b="0">
-                <a:solidFill>
-                  <a:srgbClr val="FFFFFF"/>
+              <a:rPr sz="1200" b="0">
+                <a:solidFill>
+                  <a:srgbClr val="5B7480"/>
                 </a:solidFill>
                 <a:latin typeface="Inter"/>
               </a:rPr>
-              <a:t>Discount for multi-year commitment</a:t>
-            </a:r>
-          </a:p>
-        </p:txBody>
-      </p:sp>
-      <p:sp>
-        <p:nvSpPr>
-          <p:cNvPr id="13" name="Rounded Rectangle 12"/>
+              <a:t>AI grading accuracy</a:t>
+            </a:r>
+          </a:p>
+        </p:txBody>
+      </p:sp>
+      <p:sp>
+        <p:nvSpPr>
+          <p:cNvPr id="21" name="Rectangle 20"/>
           <p:cNvSpPr/>
           <p:nvPr/>
         </p:nvSpPr>
         <p:spPr>
           <a:xfrm>
-            <a:off x="6121400" y="3162300"/>
-            <a:ext cx="355600" cy="355600"/>
-          </a:xfrm>
-          <a:prstGeom prst="roundRect">
-            <a:avLst>
-              <a:gd name="adj" fmla="val 25000"/>
-            </a:avLst>
+            <a:off x="4267200" y="4445000"/>
+            <a:ext cx="6350" cy="939800"/>
+          </a:xfrm>
+          <a:prstGeom prst="rect">
+            <a:avLst/>
           </a:prstGeom>
           <a:solidFill>
-            <a:srgbClr val="0A2C3B"/>
+            <a:srgbClr val="CDD9DE"/>
           </a:solidFill>
           <a:ln>
             <a:noFill/>
@@ -8472,24 +7691,70 @@
           </a:p>
         </p:txBody>
       </p:sp>
+      <p:sp>
+        <p:nvSpPr>
+          <p:cNvPr id="22" name="Rounded Rectangle 21"/>
+          <p:cNvSpPr/>
+          <p:nvPr/>
+        </p:nvSpPr>
+        <p:spPr>
+          <a:xfrm>
+            <a:off x="4572000" y="4521200"/>
+            <a:ext cx="609600" cy="609600"/>
+          </a:xfrm>
+          <a:prstGeom prst="roundRect">
+            <a:avLst>
+              <a:gd name="adj" fmla="val 16666"/>
+            </a:avLst>
+          </a:prstGeom>
+          <a:solidFill>
+            <a:srgbClr val="FFFFFF"/>
+          </a:solidFill>
+          <a:ln>
+            <a:noFill/>
+          </a:ln>
+          <a:effectLst/>
+        </p:spPr>
+        <p:style>
+          <a:lnRef idx="1">
+            <a:schemeClr val="accent1"/>
+          </a:lnRef>
+          <a:fillRef idx="3">
+            <a:schemeClr val="accent1"/>
+          </a:fillRef>
+          <a:effectRef idx="2">
+            <a:schemeClr val="accent1"/>
+          </a:effectRef>
+          <a:fontRef idx="minor">
+            <a:schemeClr val="lt1"/>
+          </a:fontRef>
+        </p:style>
+        <p:txBody>
+          <a:bodyPr rtlCol="0" anchor="ctr"/>
+          <a:lstStyle/>
+          <a:p>
+            <a:pPr algn="ctr"/>
+          </a:p>
+        </p:txBody>
+      </p:sp>
       <p:pic>
         <p:nvPicPr>
-          <p:cNvPr id="14" name="Picture 13" descr="icon-check-green.png"/>
+          <p:cNvPr id="23" name="Picture 22" descr="icon-bestand-greendeep.png"/>
           <p:cNvPicPr>
             <a:picLocks noChangeAspect="1"/>
           </p:cNvPicPr>
           <p:nvPr/>
         </p:nvPicPr>
         <p:blipFill>
-          <a:blip r:embed="rId2"/>
+          <a:blip r:embed="rId3"/>
           <a:stretch>
             <a:fillRect/>
           </a:stretch>
         </p:blipFill>
         <p:spPr>
           <a:xfrm>
-            <a:off x="6210300" y="3251200"/>
-            <a:ext cx="177800" cy="177800"/>
+            <a:off x="4724400" y="4673600"/>
+            <a:ext cx="304800" cy="304800"/>
           </a:xfrm>
           <a:prstGeom prst="rect">
             <a:avLst/>
@@ -8498,14 +7763,14 @@
       </p:pic>
       <p:sp>
         <p:nvSpPr>
-          <p:cNvPr id="15" name="TextBox 14"/>
+          <p:cNvPr id="24" name="TextBox 23"/>
           <p:cNvSpPr txBox="1"/>
           <p:nvPr/>
         </p:nvSpPr>
         <p:spPr>
           <a:xfrm>
-            <a:off x="6654800" y="3200400"/>
-            <a:ext cx="4318000" cy="304800"/>
+            <a:off x="5334000" y="4483100"/>
+            <a:ext cx="2438400" cy="406400"/>
           </a:xfrm>
           <a:prstGeom prst="rect">
             <a:avLst/>
@@ -8520,30 +7785,293 @@
           <a:p>
             <a:pPr algn="l">
               <a:lnSpc>
+                <a:spcPct val="100000"/>
+              </a:lnSpc>
+            </a:pPr>
+            <a:r>
+              <a:rPr sz="2200" b="1">
+                <a:solidFill>
+                  <a:srgbClr val="002333"/>
+                </a:solidFill>
+                <a:latin typeface="League Spartan"/>
+              </a:rPr>
+              <a:t>2,300+</a:t>
+            </a:r>
+          </a:p>
+        </p:txBody>
+      </p:sp>
+      <p:sp>
+        <p:nvSpPr>
+          <p:cNvPr id="25" name="TextBox 24"/>
+          <p:cNvSpPr txBox="1"/>
+          <p:nvPr/>
+        </p:nvSpPr>
+        <p:spPr>
+          <a:xfrm>
+            <a:off x="5334000" y="4902200"/>
+            <a:ext cx="2438400" cy="571500"/>
+          </a:xfrm>
+          <a:prstGeom prst="rect">
+            <a:avLst/>
+          </a:prstGeom>
+          <a:noFill/>
+        </p:spPr>
+        <p:txBody>
+          <a:bodyPr wrap="square" lIns="0" rIns="0" tIns="0" bIns="0">
+            <a:spAutoFit/>
+          </a:bodyPr>
+          <a:lstStyle/>
+          <a:p>
+            <a:pPr algn="l">
+              <a:lnSpc>
                 <a:spcPct val="135000"/>
               </a:lnSpc>
             </a:pPr>
             <a:r>
-              <a:rPr sz="1600" b="0">
-                <a:solidFill>
-                  <a:srgbClr val="FFFFFF"/>
+              <a:rPr sz="1200" b="0">
+                <a:solidFill>
+                  <a:srgbClr val="5B7480"/>
                 </a:solidFill>
                 <a:latin typeface="Inter"/>
               </a:rPr>
-              <a:t>Scales with growing students &amp; instructors</a:t>
-            </a:r>
-          </a:p>
-        </p:txBody>
-      </p:sp>
-      <p:sp>
-        <p:nvSpPr>
-          <p:cNvPr id="16" name="Rectangle 15"/>
+              <a:t>feedback items across</a:t>
+            </a:r>
+          </a:p>
+          <a:p>
+            <a:pPr algn="l">
+              <a:lnSpc>
+                <a:spcPct val="135000"/>
+              </a:lnSpc>
+            </a:pPr>
+            <a:r>
+              <a:rPr sz="1200" b="0">
+                <a:solidFill>
+                  <a:srgbClr val="5B7480"/>
+                </a:solidFill>
+                <a:latin typeface="Inter"/>
+              </a:rPr>
+              <a:t>435 submissions</a:t>
+            </a:r>
+          </a:p>
+        </p:txBody>
+      </p:sp>
+      <p:sp>
+        <p:nvSpPr>
+          <p:cNvPr id="26" name="Rectangle 25"/>
           <p:cNvSpPr/>
           <p:nvPr/>
         </p:nvSpPr>
         <p:spPr>
           <a:xfrm>
-            <a:off x="762000" y="4673600"/>
+            <a:off x="7924800" y="4445000"/>
+            <a:ext cx="6350" cy="939800"/>
+          </a:xfrm>
+          <a:prstGeom prst="rect">
+            <a:avLst/>
+          </a:prstGeom>
+          <a:solidFill>
+            <a:srgbClr val="CDD9DE"/>
+          </a:solidFill>
+          <a:ln>
+            <a:noFill/>
+          </a:ln>
+          <a:effectLst/>
+        </p:spPr>
+        <p:style>
+          <a:lnRef idx="1">
+            <a:schemeClr val="accent1"/>
+          </a:lnRef>
+          <a:fillRef idx="3">
+            <a:schemeClr val="accent1"/>
+          </a:fillRef>
+          <a:effectRef idx="2">
+            <a:schemeClr val="accent1"/>
+          </a:effectRef>
+          <a:fontRef idx="minor">
+            <a:schemeClr val="lt1"/>
+          </a:fontRef>
+        </p:style>
+        <p:txBody>
+          <a:bodyPr rtlCol="0" anchor="ctr"/>
+          <a:lstStyle/>
+          <a:p>
+            <a:pPr algn="ctr"/>
+          </a:p>
+        </p:txBody>
+      </p:sp>
+      <p:sp>
+        <p:nvSpPr>
+          <p:cNvPr id="27" name="Rounded Rectangle 26"/>
+          <p:cNvSpPr/>
+          <p:nvPr/>
+        </p:nvSpPr>
+        <p:spPr>
+          <a:xfrm>
+            <a:off x="8229600" y="4521200"/>
+            <a:ext cx="609600" cy="609600"/>
+          </a:xfrm>
+          <a:prstGeom prst="roundRect">
+            <a:avLst>
+              <a:gd name="adj" fmla="val 16666"/>
+            </a:avLst>
+          </a:prstGeom>
+          <a:solidFill>
+            <a:srgbClr val="FFFFFF"/>
+          </a:solidFill>
+          <a:ln>
+            <a:noFill/>
+          </a:ln>
+          <a:effectLst/>
+        </p:spPr>
+        <p:style>
+          <a:lnRef idx="1">
+            <a:schemeClr val="accent1"/>
+          </a:lnRef>
+          <a:fillRef idx="3">
+            <a:schemeClr val="accent1"/>
+          </a:fillRef>
+          <a:effectRef idx="2">
+            <a:schemeClr val="accent1"/>
+          </a:effectRef>
+          <a:fontRef idx="minor">
+            <a:schemeClr val="lt1"/>
+          </a:fontRef>
+        </p:style>
+        <p:txBody>
+          <a:bodyPr rtlCol="0" anchor="ctr"/>
+          <a:lstStyle/>
+          <a:p>
+            <a:pPr algn="ctr"/>
+          </a:p>
+        </p:txBody>
+      </p:sp>
+      <p:pic>
+        <p:nvPicPr>
+          <p:cNvPr id="28" name="Picture 27" descr="icon-klok-greendeep.png"/>
+          <p:cNvPicPr>
+            <a:picLocks noChangeAspect="1"/>
+          </p:cNvPicPr>
+          <p:nvPr/>
+        </p:nvPicPr>
+        <p:blipFill>
+          <a:blip r:embed="rId4"/>
+          <a:stretch>
+            <a:fillRect/>
+          </a:stretch>
+        </p:blipFill>
+        <p:spPr>
+          <a:xfrm>
+            <a:off x="8382000" y="4673600"/>
+            <a:ext cx="304800" cy="304800"/>
+          </a:xfrm>
+          <a:prstGeom prst="rect">
+            <a:avLst/>
+          </a:prstGeom>
+        </p:spPr>
+      </p:pic>
+      <p:sp>
+        <p:nvSpPr>
+          <p:cNvPr id="29" name="TextBox 28"/>
+          <p:cNvSpPr txBox="1"/>
+          <p:nvPr/>
+        </p:nvSpPr>
+        <p:spPr>
+          <a:xfrm>
+            <a:off x="8991600" y="4483100"/>
+            <a:ext cx="2438400" cy="406400"/>
+          </a:xfrm>
+          <a:prstGeom prst="rect">
+            <a:avLst/>
+          </a:prstGeom>
+          <a:noFill/>
+        </p:spPr>
+        <p:txBody>
+          <a:bodyPr wrap="square" lIns="0" rIns="0" tIns="0" bIns="0">
+            <a:spAutoFit/>
+          </a:bodyPr>
+          <a:lstStyle/>
+          <a:p>
+            <a:pPr algn="l">
+              <a:lnSpc>
+                <a:spcPct val="100000"/>
+              </a:lnSpc>
+            </a:pPr>
+            <a:r>
+              <a:rPr sz="2200" b="1">
+                <a:solidFill>
+                  <a:srgbClr val="002333"/>
+                </a:solidFill>
+                <a:latin typeface="League Spartan"/>
+              </a:rPr>
+              <a:t>15–20 hrs</a:t>
+            </a:r>
+          </a:p>
+        </p:txBody>
+      </p:sp>
+      <p:sp>
+        <p:nvSpPr>
+          <p:cNvPr id="30" name="TextBox 29"/>
+          <p:cNvSpPr txBox="1"/>
+          <p:nvPr/>
+        </p:nvSpPr>
+        <p:spPr>
+          <a:xfrm>
+            <a:off x="8991600" y="4902200"/>
+            <a:ext cx="2438400" cy="571500"/>
+          </a:xfrm>
+          <a:prstGeom prst="rect">
+            <a:avLst/>
+          </a:prstGeom>
+          <a:noFill/>
+        </p:spPr>
+        <p:txBody>
+          <a:bodyPr wrap="square" lIns="0" rIns="0" tIns="0" bIns="0">
+            <a:spAutoFit/>
+          </a:bodyPr>
+          <a:lstStyle/>
+          <a:p>
+            <a:pPr algn="l">
+              <a:lnSpc>
+                <a:spcPct val="135000"/>
+              </a:lnSpc>
+            </a:pPr>
+            <a:r>
+              <a:rPr sz="1200" b="0">
+                <a:solidFill>
+                  <a:srgbClr val="5B7480"/>
+                </a:solidFill>
+                <a:latin typeface="Inter"/>
+              </a:rPr>
+              <a:t>saved per 60-student cohort,</a:t>
+            </a:r>
+          </a:p>
+          <a:p>
+            <a:pPr algn="l">
+              <a:lnSpc>
+                <a:spcPct val="135000"/>
+              </a:lnSpc>
+            </a:pPr>
+            <a:r>
+              <a:rPr sz="1200" b="0">
+                <a:solidFill>
+                  <a:srgbClr val="5B7480"/>
+                </a:solidFill>
+                <a:latin typeface="Inter"/>
+              </a:rPr>
+              <a:t>every cycle</a:t>
+            </a:r>
+          </a:p>
+        </p:txBody>
+      </p:sp>
+      <p:sp>
+        <p:nvSpPr>
+          <p:cNvPr id="31" name="Rectangle 30"/>
+          <p:cNvSpPr/>
+          <p:nvPr/>
+        </p:nvSpPr>
+        <p:spPr>
+          <a:xfrm>
+            <a:off x="762000" y="6045200"/>
             <a:ext cx="10668000" cy="6350"/>
           </a:xfrm>
           <a:prstGeom prst="rect">
@@ -8579,312 +8107,9 @@
           </a:p>
         </p:txBody>
       </p:sp>
-      <p:sp>
-        <p:nvSpPr>
-          <p:cNvPr id="17" name="TextBox 16"/>
-          <p:cNvSpPr txBox="1"/>
-          <p:nvPr/>
-        </p:nvSpPr>
-        <p:spPr>
-          <a:xfrm>
-            <a:off x="762000" y="4826000"/>
-            <a:ext cx="3810000" cy="215900"/>
-          </a:xfrm>
-          <a:prstGeom prst="rect">
-            <a:avLst/>
-          </a:prstGeom>
-          <a:noFill/>
-        </p:spPr>
-        <p:txBody>
-          <a:bodyPr wrap="square" lIns="0" rIns="0" tIns="0" bIns="0">
-            <a:spAutoFit/>
-          </a:bodyPr>
-          <a:lstStyle/>
-          <a:p>
-            <a:pPr algn="l">
-              <a:lnSpc>
-                <a:spcPct val="120000"/>
-              </a:lnSpc>
-            </a:pPr>
-            <a:r>
-              <a:rPr sz="1200" b="0">
-                <a:solidFill>
-                  <a:srgbClr val="5B7480"/>
-                </a:solidFill>
-                <a:latin typeface="Inter"/>
-              </a:rPr>
-              <a:t>What that covers</a:t>
-            </a:r>
-          </a:p>
-        </p:txBody>
-      </p:sp>
-      <p:sp>
-        <p:nvSpPr>
-          <p:cNvPr id="18" name="Rounded Rectangle 17"/>
-          <p:cNvSpPr/>
-          <p:nvPr/>
-        </p:nvSpPr>
-        <p:spPr>
-          <a:xfrm>
-            <a:off x="762000" y="5207000"/>
-            <a:ext cx="457200" cy="457200"/>
-          </a:xfrm>
-          <a:prstGeom prst="roundRect">
-            <a:avLst>
-              <a:gd name="adj" fmla="val 22222"/>
-            </a:avLst>
-          </a:prstGeom>
-          <a:solidFill>
-            <a:srgbClr val="F3F7F8"/>
-          </a:solidFill>
-          <a:ln>
-            <a:noFill/>
-          </a:ln>
-          <a:effectLst/>
-        </p:spPr>
-        <p:style>
-          <a:lnRef idx="1">
-            <a:schemeClr val="accent1"/>
-          </a:lnRef>
-          <a:fillRef idx="3">
-            <a:schemeClr val="accent1"/>
-          </a:fillRef>
-          <a:effectRef idx="2">
-            <a:schemeClr val="accent1"/>
-          </a:effectRef>
-          <a:fontRef idx="minor">
-            <a:schemeClr val="lt1"/>
-          </a:fontRef>
-        </p:style>
-        <p:txBody>
-          <a:bodyPr rtlCol="0" anchor="ctr"/>
-          <a:lstStyle/>
-          <a:p>
-            <a:pPr algn="ctr"/>
-          </a:p>
-        </p:txBody>
-      </p:sp>
       <p:pic>
         <p:nvPicPr>
-          <p:cNvPr id="19" name="Picture 18" descr="icon-doel-navy.png"/>
-          <p:cNvPicPr>
-            <a:picLocks noChangeAspect="1"/>
-          </p:cNvPicPr>
-          <p:nvPr/>
-        </p:nvPicPr>
-        <p:blipFill>
-          <a:blip r:embed="rId3"/>
-          <a:stretch>
-            <a:fillRect/>
-          </a:stretch>
-        </p:blipFill>
-        <p:spPr>
-          <a:xfrm>
-            <a:off x="876300" y="5321300"/>
-            <a:ext cx="228600" cy="228600"/>
-          </a:xfrm>
-          <a:prstGeom prst="rect">
-            <a:avLst/>
-          </a:prstGeom>
-        </p:spPr>
-      </p:pic>
-      <p:sp>
-        <p:nvSpPr>
-          <p:cNvPr id="20" name="TextBox 19"/>
-          <p:cNvSpPr txBox="1"/>
-          <p:nvPr/>
-        </p:nvSpPr>
-        <p:spPr>
-          <a:xfrm>
-            <a:off x="1346200" y="5334000"/>
-            <a:ext cx="1854200" cy="254000"/>
-          </a:xfrm>
-          <a:prstGeom prst="rect">
-            <a:avLst/>
-          </a:prstGeom>
-          <a:noFill/>
-        </p:spPr>
-        <p:txBody>
-          <a:bodyPr wrap="square" lIns="0" rIns="0" tIns="0" bIns="0">
-            <a:spAutoFit/>
-          </a:bodyPr>
-          <a:lstStyle/>
-          <a:p>
-            <a:pPr algn="l">
-              <a:lnSpc>
-                <a:spcPct val="130000"/>
-              </a:lnSpc>
-            </a:pPr>
-            <a:r>
-              <a:rPr sz="1200" b="0">
-                <a:solidFill>
-                  <a:srgbClr val="5B7480"/>
-                </a:solidFill>
-                <a:latin typeface="Inter"/>
-              </a:rPr>
-              <a:t>Accuracy &amp; Consistency</a:t>
-            </a:r>
-          </a:p>
-        </p:txBody>
-      </p:sp>
-      <p:sp>
-        <p:nvSpPr>
-          <p:cNvPr id="21" name="Rounded Rectangle 20"/>
-          <p:cNvSpPr/>
-          <p:nvPr/>
-        </p:nvSpPr>
-        <p:spPr>
-          <a:xfrm>
-            <a:off x="3505200" y="5207000"/>
-            <a:ext cx="457200" cy="457200"/>
-          </a:xfrm>
-          <a:prstGeom prst="roundRect">
-            <a:avLst>
-              <a:gd name="adj" fmla="val 22222"/>
-            </a:avLst>
-          </a:prstGeom>
-          <a:solidFill>
-            <a:srgbClr val="F3F7F8"/>
-          </a:solidFill>
-          <a:ln>
-            <a:noFill/>
-          </a:ln>
-          <a:effectLst/>
-        </p:spPr>
-        <p:style>
-          <a:lnRef idx="1">
-            <a:schemeClr val="accent1"/>
-          </a:lnRef>
-          <a:fillRef idx="3">
-            <a:schemeClr val="accent1"/>
-          </a:fillRef>
-          <a:effectRef idx="2">
-            <a:schemeClr val="accent1"/>
-          </a:effectRef>
-          <a:fontRef idx="minor">
-            <a:schemeClr val="lt1"/>
-          </a:fontRef>
-        </p:style>
-        <p:txBody>
-          <a:bodyPr rtlCol="0" anchor="ctr"/>
-          <a:lstStyle/>
-          <a:p>
-            <a:pPr algn="ctr"/>
-          </a:p>
-        </p:txBody>
-      </p:sp>
-      <p:pic>
-        <p:nvPicPr>
-          <p:cNvPr id="22" name="Picture 21" descr="icon-sleutel-navy.png"/>
-          <p:cNvPicPr>
-            <a:picLocks noChangeAspect="1"/>
-          </p:cNvPicPr>
-          <p:nvPr/>
-        </p:nvPicPr>
-        <p:blipFill>
-          <a:blip r:embed="rId4"/>
-          <a:stretch>
-            <a:fillRect/>
-          </a:stretch>
-        </p:blipFill>
-        <p:spPr>
-          <a:xfrm>
-            <a:off x="3619500" y="5321300"/>
-            <a:ext cx="228600" cy="228600"/>
-          </a:xfrm>
-          <a:prstGeom prst="rect">
-            <a:avLst/>
-          </a:prstGeom>
-        </p:spPr>
-      </p:pic>
-      <p:sp>
-        <p:nvSpPr>
-          <p:cNvPr id="23" name="TextBox 22"/>
-          <p:cNvSpPr txBox="1"/>
-          <p:nvPr/>
-        </p:nvSpPr>
-        <p:spPr>
-          <a:xfrm>
-            <a:off x="4089400" y="5334000"/>
-            <a:ext cx="1854200" cy="254000"/>
-          </a:xfrm>
-          <a:prstGeom prst="rect">
-            <a:avLst/>
-          </a:prstGeom>
-          <a:noFill/>
-        </p:spPr>
-        <p:txBody>
-          <a:bodyPr wrap="square" lIns="0" rIns="0" tIns="0" bIns="0">
-            <a:spAutoFit/>
-          </a:bodyPr>
-          <a:lstStyle/>
-          <a:p>
-            <a:pPr algn="l">
-              <a:lnSpc>
-                <a:spcPct val="130000"/>
-              </a:lnSpc>
-            </a:pPr>
-            <a:r>
-              <a:rPr sz="1200" b="0">
-                <a:solidFill>
-                  <a:srgbClr val="5B7480"/>
-                </a:solidFill>
-                <a:latin typeface="Inter"/>
-              </a:rPr>
-              <a:t>Technical Domain Fit</a:t>
-            </a:r>
-          </a:p>
-        </p:txBody>
-      </p:sp>
-      <p:sp>
-        <p:nvSpPr>
-          <p:cNvPr id="24" name="Rounded Rectangle 23"/>
-          <p:cNvSpPr/>
-          <p:nvPr/>
-        </p:nvSpPr>
-        <p:spPr>
-          <a:xfrm>
-            <a:off x="6248400" y="5207000"/>
-            <a:ext cx="457200" cy="457200"/>
-          </a:xfrm>
-          <a:prstGeom prst="roundRect">
-            <a:avLst>
-              <a:gd name="adj" fmla="val 22222"/>
-            </a:avLst>
-          </a:prstGeom>
-          <a:solidFill>
-            <a:srgbClr val="F3F7F8"/>
-          </a:solidFill>
-          <a:ln>
-            <a:noFill/>
-          </a:ln>
-          <a:effectLst/>
-        </p:spPr>
-        <p:style>
-          <a:lnRef idx="1">
-            <a:schemeClr val="accent1"/>
-          </a:lnRef>
-          <a:fillRef idx="3">
-            <a:schemeClr val="accent1"/>
-          </a:fillRef>
-          <a:effectRef idx="2">
-            <a:schemeClr val="accent1"/>
-          </a:effectRef>
-          <a:fontRef idx="minor">
-            <a:schemeClr val="lt1"/>
-          </a:fontRef>
-        </p:style>
-        <p:txBody>
-          <a:bodyPr rtlCol="0" anchor="ctr"/>
-          <a:lstStyle/>
-          <a:p>
-            <a:pPr algn="ctr"/>
-          </a:p>
-        </p:txBody>
-      </p:sp>
-      <p:pic>
-        <p:nvPicPr>
-          <p:cNvPr id="25" name="Picture 24" descr="icon-instelling-navy.png"/>
+          <p:cNvPr id="32" name="Picture 31" descr="logo_navy.png"/>
           <p:cNvPicPr>
             <a:picLocks noChangeAspect="1"/>
           </p:cNvPicPr>
@@ -8898,8 +8123,8 @@
         </p:blipFill>
         <p:spPr>
           <a:xfrm>
-            <a:off x="6362700" y="5321300"/>
-            <a:ext cx="228600" cy="228600"/>
+            <a:off x="762000" y="6324600"/>
+            <a:ext cx="937957" cy="254000"/>
           </a:xfrm>
           <a:prstGeom prst="rect">
             <a:avLst/>
@@ -8908,61 +8133,20 @@
       </p:pic>
       <p:sp>
         <p:nvSpPr>
-          <p:cNvPr id="26" name="TextBox 25"/>
-          <p:cNvSpPr txBox="1"/>
-          <p:nvPr/>
-        </p:nvSpPr>
-        <p:spPr>
-          <a:xfrm>
-            <a:off x="6832600" y="5334000"/>
-            <a:ext cx="1854200" cy="254000"/>
-          </a:xfrm>
-          <a:prstGeom prst="rect">
-            <a:avLst/>
-          </a:prstGeom>
-          <a:noFill/>
-        </p:spPr>
-        <p:txBody>
-          <a:bodyPr wrap="square" lIns="0" rIns="0" tIns="0" bIns="0">
-            <a:spAutoFit/>
-          </a:bodyPr>
-          <a:lstStyle/>
-          <a:p>
-            <a:pPr algn="l">
-              <a:lnSpc>
-                <a:spcPct val="130000"/>
-              </a:lnSpc>
-            </a:pPr>
-            <a:r>
-              <a:rPr sz="1200" b="0">
-                <a:solidFill>
-                  <a:srgbClr val="5B7480"/>
-                </a:solidFill>
-                <a:latin typeface="Inter"/>
-              </a:rPr>
-              <a:t>Institution-Wide</a:t>
-            </a:r>
-          </a:p>
-        </p:txBody>
-      </p:sp>
-      <p:sp>
-        <p:nvSpPr>
-          <p:cNvPr id="27" name="Rounded Rectangle 26"/>
+          <p:cNvPr id="33" name="Rectangle 32"/>
           <p:cNvSpPr/>
           <p:nvPr/>
         </p:nvSpPr>
         <p:spPr>
           <a:xfrm>
-            <a:off x="8991600" y="5207000"/>
-            <a:ext cx="457200" cy="457200"/>
-          </a:xfrm>
-          <a:prstGeom prst="roundRect">
-            <a:avLst>
-              <a:gd name="adj" fmla="val 22222"/>
-            </a:avLst>
+            <a:off x="1968500" y="6311900"/>
+            <a:ext cx="6350" cy="279400"/>
+          </a:xfrm>
+          <a:prstGeom prst="rect">
+            <a:avLst/>
           </a:prstGeom>
           <a:solidFill>
-            <a:srgbClr val="F3F7F8"/>
+            <a:srgbClr val="CDD9DE"/>
           </a:solidFill>
           <a:ln>
             <a:noFill/>
@@ -8993,7 +8177,7 @@
       </p:sp>
       <p:pic>
         <p:nvPicPr>
-          <p:cNvPr id="28" name="Picture 27" descr="icon-schuifjes-navy.png"/>
+          <p:cNvPr id="34" name="Picture 33" descr="uti-logo.png"/>
           <p:cNvPicPr>
             <a:picLocks noChangeAspect="1"/>
           </p:cNvPicPr>
@@ -9007,8 +8191,8 @@
         </p:blipFill>
         <p:spPr>
           <a:xfrm>
-            <a:off x="9105900" y="5321300"/>
-            <a:ext cx="228600" cy="228600"/>
+            <a:off x="2222500" y="6273800"/>
+            <a:ext cx="774246" cy="355600"/>
           </a:xfrm>
           <a:prstGeom prst="rect">
             <a:avLst/>
@@ -9017,14 +8201,14 @@
       </p:pic>
       <p:sp>
         <p:nvSpPr>
-          <p:cNvPr id="29" name="TextBox 28"/>
+          <p:cNvPr id="35" name="TextBox 34"/>
           <p:cNvSpPr txBox="1"/>
           <p:nvPr/>
         </p:nvSpPr>
         <p:spPr>
           <a:xfrm>
-            <a:off x="9575800" y="5334000"/>
-            <a:ext cx="1854200" cy="254000"/>
+            <a:off x="5715000" y="6375400"/>
+            <a:ext cx="5080000" cy="243840"/>
           </a:xfrm>
           <a:prstGeom prst="rect">
             <a:avLst/>
@@ -9037,9 +8221,9 @@
           </a:bodyPr>
           <a:lstStyle/>
           <a:p>
-            <a:pPr algn="l">
-              <a:lnSpc>
-                <a:spcPct val="130000"/>
+            <a:pPr algn="r">
+              <a:lnSpc>
+                <a:spcPct val="135000"/>
               </a:lnSpc>
             </a:pPr>
             <a:r>
@@ -9049,150 +8233,14 @@
                 </a:solidFill>
                 <a:latin typeface="Inter"/>
               </a:rPr>
-              <a:t>Self-Configuring</a:t>
-            </a:r>
-          </a:p>
-        </p:txBody>
-      </p:sp>
-      <p:sp>
-        <p:nvSpPr>
-          <p:cNvPr id="30" name="Rectangle 29"/>
-          <p:cNvSpPr/>
-          <p:nvPr/>
-        </p:nvSpPr>
-        <p:spPr>
-          <a:xfrm>
-            <a:off x="762000" y="6045200"/>
-            <a:ext cx="10668000" cy="6350"/>
-          </a:xfrm>
-          <a:prstGeom prst="rect">
-            <a:avLst/>
-          </a:prstGeom>
-          <a:solidFill>
-            <a:srgbClr val="E7EEF0"/>
-          </a:solidFill>
-          <a:ln>
-            <a:noFill/>
-          </a:ln>
-          <a:effectLst/>
-        </p:spPr>
-        <p:style>
-          <a:lnRef idx="1">
-            <a:schemeClr val="accent1"/>
-          </a:lnRef>
-          <a:fillRef idx="3">
-            <a:schemeClr val="accent1"/>
-          </a:fillRef>
-          <a:effectRef idx="2">
-            <a:schemeClr val="accent1"/>
-          </a:effectRef>
-          <a:fontRef idx="minor">
-            <a:schemeClr val="lt1"/>
-          </a:fontRef>
-        </p:style>
-        <p:txBody>
-          <a:bodyPr rtlCol="0" anchor="ctr"/>
-          <a:lstStyle/>
-          <a:p>
-            <a:pPr algn="ctr"/>
-          </a:p>
-        </p:txBody>
-      </p:sp>
-      <p:pic>
-        <p:nvPicPr>
-          <p:cNvPr id="31" name="Picture 30" descr="logo_navy.png"/>
-          <p:cNvPicPr>
-            <a:picLocks noChangeAspect="1"/>
-          </p:cNvPicPr>
-          <p:nvPr/>
-        </p:nvPicPr>
-        <p:blipFill>
-          <a:blip r:embed="rId7"/>
-          <a:stretch>
-            <a:fillRect/>
-          </a:stretch>
-        </p:blipFill>
-        <p:spPr>
-          <a:xfrm>
-            <a:off x="762000" y="6324600"/>
-            <a:ext cx="937957" cy="254000"/>
-          </a:xfrm>
-          <a:prstGeom prst="rect">
-            <a:avLst/>
-          </a:prstGeom>
-        </p:spPr>
-      </p:pic>
-      <p:sp>
-        <p:nvSpPr>
-          <p:cNvPr id="32" name="Rectangle 31"/>
-          <p:cNvSpPr/>
-          <p:nvPr/>
-        </p:nvSpPr>
-        <p:spPr>
-          <a:xfrm>
-            <a:off x="1968500" y="6311900"/>
-            <a:ext cx="6350" cy="279400"/>
-          </a:xfrm>
-          <a:prstGeom prst="rect">
-            <a:avLst/>
-          </a:prstGeom>
-          <a:solidFill>
-            <a:srgbClr val="CDD9DE"/>
-          </a:solidFill>
-          <a:ln>
-            <a:noFill/>
-          </a:ln>
-          <a:effectLst/>
-        </p:spPr>
-        <p:style>
-          <a:lnRef idx="1">
-            <a:schemeClr val="accent1"/>
-          </a:lnRef>
-          <a:fillRef idx="3">
-            <a:schemeClr val="accent1"/>
-          </a:fillRef>
-          <a:effectRef idx="2">
-            <a:schemeClr val="accent1"/>
-          </a:effectRef>
-          <a:fontRef idx="minor">
-            <a:schemeClr val="lt1"/>
-          </a:fontRef>
-        </p:style>
-        <p:txBody>
-          <a:bodyPr rtlCol="0" anchor="ctr"/>
-          <a:lstStyle/>
-          <a:p>
-            <a:pPr algn="ctr"/>
-          </a:p>
-        </p:txBody>
-      </p:sp>
-      <p:pic>
-        <p:nvPicPr>
-          <p:cNvPr id="33" name="Picture 32" descr="uti-logo.png"/>
-          <p:cNvPicPr>
-            <a:picLocks noChangeAspect="1"/>
-          </p:cNvPicPr>
-          <p:nvPr/>
-        </p:nvPicPr>
-        <p:blipFill>
-          <a:blip r:embed="rId8"/>
-          <a:stretch>
-            <a:fillRect/>
-          </a:stretch>
-        </p:blipFill>
-        <p:spPr>
-          <a:xfrm>
-            <a:off x="2222500" y="6273800"/>
-            <a:ext cx="774246" cy="355600"/>
-          </a:xfrm>
-          <a:prstGeom prst="rect">
-            <a:avLst/>
-          </a:prstGeom>
-        </p:spPr>
-      </p:pic>
-      <p:sp>
-        <p:nvSpPr>
-          <p:cNvPr id="34" name="TextBox 33"/>
+              <a:t>Source: Bath Spa University · Eduface pilot data.</a:t>
+            </a:r>
+          </a:p>
+        </p:txBody>
+      </p:sp>
+      <p:sp>
+        <p:nvSpPr>
+          <p:cNvPr id="36" name="TextBox 35"/>
           <p:cNvSpPr txBox="1"/>
           <p:nvPr/>
         </p:nvSpPr>
@@ -9262,6 +8310,130 @@
             <a:avLst/>
           </a:prstGeom>
           <a:solidFill>
+            <a:srgbClr val="FFFFFF"/>
+          </a:solidFill>
+          <a:ln>
+            <a:noFill/>
+          </a:ln>
+          <a:effectLst/>
+        </p:spPr>
+        <p:style>
+          <a:lnRef idx="1">
+            <a:schemeClr val="accent1"/>
+          </a:lnRef>
+          <a:fillRef idx="3">
+            <a:schemeClr val="accent1"/>
+          </a:fillRef>
+          <a:effectRef idx="2">
+            <a:schemeClr val="accent1"/>
+          </a:effectRef>
+          <a:fontRef idx="minor">
+            <a:schemeClr val="lt1"/>
+          </a:fontRef>
+        </p:style>
+        <p:txBody>
+          <a:bodyPr rtlCol="0" anchor="ctr"/>
+          <a:lstStyle/>
+          <a:p>
+            <a:pPr algn="ctr"/>
+          </a:p>
+        </p:txBody>
+      </p:sp>
+      <p:sp>
+        <p:nvSpPr>
+          <p:cNvPr id="3" name="TextBox 2"/>
+          <p:cNvSpPr txBox="1"/>
+          <p:nvPr/>
+        </p:nvSpPr>
+        <p:spPr>
+          <a:xfrm>
+            <a:off x="762000" y="558800"/>
+            <a:ext cx="10668000" cy="627380"/>
+          </a:xfrm>
+          <a:prstGeom prst="rect">
+            <a:avLst/>
+          </a:prstGeom>
+          <a:noFill/>
+        </p:spPr>
+        <p:txBody>
+          <a:bodyPr wrap="square" lIns="0" rIns="0" tIns="0" bIns="0">
+            <a:spAutoFit/>
+          </a:bodyPr>
+          <a:lstStyle/>
+          <a:p>
+            <a:pPr algn="l">
+              <a:lnSpc>
+                <a:spcPct val="104000"/>
+              </a:lnSpc>
+            </a:pPr>
+            <a:r>
+              <a:rPr sz="3800" b="1">
+                <a:solidFill>
+                  <a:srgbClr val="002333"/>
+                </a:solidFill>
+                <a:latin typeface="League Spartan"/>
+              </a:rPr>
+              <a:t>Institution-wide feedback, priced per student</a:t>
+            </a:r>
+          </a:p>
+        </p:txBody>
+      </p:sp>
+      <p:sp>
+        <p:nvSpPr>
+          <p:cNvPr id="4" name="TextBox 3"/>
+          <p:cNvSpPr txBox="1"/>
+          <p:nvPr/>
+        </p:nvSpPr>
+        <p:spPr>
+          <a:xfrm>
+            <a:off x="762000" y="1270000"/>
+            <a:ext cx="10668000" cy="304800"/>
+          </a:xfrm>
+          <a:prstGeom prst="rect">
+            <a:avLst/>
+          </a:prstGeom>
+          <a:noFill/>
+        </p:spPr>
+        <p:txBody>
+          <a:bodyPr wrap="square" lIns="0" rIns="0" tIns="0" bIns="0">
+            <a:spAutoFit/>
+          </a:bodyPr>
+          <a:lstStyle/>
+          <a:p>
+            <a:pPr algn="l">
+              <a:lnSpc>
+                <a:spcPct val="130000"/>
+              </a:lnSpc>
+            </a:pPr>
+            <a:r>
+              <a:rPr sz="1600" b="0">
+                <a:solidFill>
+                  <a:srgbClr val="5B7480"/>
+                </a:solidFill>
+                <a:latin typeface="Inter"/>
+              </a:rPr>
+              <a:t>Delivered by Eduface, mapped to what UTI needs.</a:t>
+            </a:r>
+          </a:p>
+        </p:txBody>
+      </p:sp>
+      <p:sp>
+        <p:nvSpPr>
+          <p:cNvPr id="5" name="Rounded Rectangle 4"/>
+          <p:cNvSpPr/>
+          <p:nvPr/>
+        </p:nvSpPr>
+        <p:spPr>
+          <a:xfrm>
+            <a:off x="762000" y="1905000"/>
+            <a:ext cx="10668000" cy="2260600"/>
+          </a:xfrm>
+          <a:prstGeom prst="roundRect">
+            <a:avLst>
+              <a:gd name="adj" fmla="val 6741"/>
+            </a:avLst>
+          </a:prstGeom>
+          <a:solidFill>
             <a:srgbClr val="002333"/>
           </a:solidFill>
           <a:ln>
@@ -9293,14 +8465,14 @@
       </p:sp>
       <p:sp>
         <p:nvSpPr>
-          <p:cNvPr id="3" name="TextBox 2"/>
+          <p:cNvPr id="6" name="TextBox 5"/>
           <p:cNvSpPr txBox="1"/>
           <p:nvPr/>
         </p:nvSpPr>
         <p:spPr>
           <a:xfrm>
-            <a:off x="762000" y="558800"/>
-            <a:ext cx="10668000" cy="627380"/>
+            <a:off x="1219200" y="2362200"/>
+            <a:ext cx="1905000" cy="1333500"/>
           </a:xfrm>
           <a:prstGeom prst="rect">
             <a:avLst/>
@@ -9315,31 +8487,125 @@
           <a:p>
             <a:pPr algn="l">
               <a:lnSpc>
-                <a:spcPct val="104000"/>
-              </a:lnSpc>
-            </a:pPr>
-            <a:r>
-              <a:rPr sz="3800" b="1">
+                <a:spcPct val="90000"/>
+              </a:lnSpc>
+            </a:pPr>
+            <a:r>
+              <a:rPr sz="9000" b="1">
                 <a:solidFill>
                   <a:srgbClr val="FFFFFF"/>
                 </a:solidFill>
                 <a:latin typeface="League Spartan"/>
               </a:rPr>
-              <a:t>Proposed Next Steps</a:t>
-            </a:r>
-          </a:p>
-        </p:txBody>
-      </p:sp>
-      <p:sp>
-        <p:nvSpPr>
-          <p:cNvPr id="4" name="Rectangle 3"/>
+              <a:t>$3</a:t>
+            </a:r>
+          </a:p>
+        </p:txBody>
+      </p:sp>
+      <p:sp>
+        <p:nvSpPr>
+          <p:cNvPr id="7" name="TextBox 6"/>
+          <p:cNvSpPr txBox="1"/>
+          <p:nvPr/>
+        </p:nvSpPr>
+        <p:spPr>
+          <a:xfrm>
+            <a:off x="2717800" y="2540000"/>
+            <a:ext cx="2667000" cy="711200"/>
+          </a:xfrm>
+          <a:prstGeom prst="rect">
+            <a:avLst/>
+          </a:prstGeom>
+          <a:noFill/>
+        </p:spPr>
+        <p:txBody>
+          <a:bodyPr wrap="square" lIns="0" rIns="0" tIns="0" bIns="0">
+            <a:spAutoFit/>
+          </a:bodyPr>
+          <a:lstStyle/>
+          <a:p>
+            <a:pPr algn="l">
+              <a:lnSpc>
+                <a:spcPct val="115000"/>
+              </a:lnSpc>
+            </a:pPr>
+            <a:r>
+              <a:rPr sz="2200" b="1">
+                <a:solidFill>
+                  <a:srgbClr val="FFFFFF"/>
+                </a:solidFill>
+                <a:latin typeface="League Spartan"/>
+              </a:rPr>
+              <a:t>per student,</a:t>
+            </a:r>
+          </a:p>
+          <a:p>
+            <a:pPr algn="l">
+              <a:lnSpc>
+                <a:spcPct val="115000"/>
+              </a:lnSpc>
+            </a:pPr>
+            <a:r>
+              <a:rPr sz="2200" b="1">
+                <a:solidFill>
+                  <a:srgbClr val="FFFFFF"/>
+                </a:solidFill>
+                <a:latin typeface="League Spartan"/>
+              </a:rPr>
+              <a:t>per month</a:t>
+            </a:r>
+          </a:p>
+        </p:txBody>
+      </p:sp>
+      <p:sp>
+        <p:nvSpPr>
+          <p:cNvPr id="8" name="TextBox 7"/>
+          <p:cNvSpPr txBox="1"/>
+          <p:nvPr/>
+        </p:nvSpPr>
+        <p:spPr>
+          <a:xfrm>
+            <a:off x="1219200" y="3429000"/>
+            <a:ext cx="3302000" cy="279400"/>
+          </a:xfrm>
+          <a:prstGeom prst="rect">
+            <a:avLst/>
+          </a:prstGeom>
+          <a:noFill/>
+        </p:spPr>
+        <p:txBody>
+          <a:bodyPr wrap="square" lIns="0" rIns="0" tIns="0" bIns="0">
+            <a:spAutoFit/>
+          </a:bodyPr>
+          <a:lstStyle/>
+          <a:p>
+            <a:pPr algn="l">
+              <a:lnSpc>
+                <a:spcPct val="120000"/>
+              </a:lnSpc>
+            </a:pPr>
+            <a:r>
+              <a:rPr sz="1600" b="0">
+                <a:solidFill>
+                  <a:srgbClr val="9EABB1"/>
+                </a:solidFill>
+                <a:latin typeface="Inter"/>
+              </a:rPr>
+              <a:t>billed annually</a:t>
+            </a:r>
+          </a:p>
+        </p:txBody>
+      </p:sp>
+      <p:sp>
+        <p:nvSpPr>
+          <p:cNvPr id="9" name="Rectangle 8"/>
           <p:cNvSpPr/>
           <p:nvPr/>
         </p:nvSpPr>
         <p:spPr>
           <a:xfrm>
-            <a:off x="1466850" y="2070100"/>
-            <a:ext cx="12700" cy="3251200"/>
+            <a:off x="5715000" y="2159000"/>
+            <a:ext cx="6350" cy="1752600"/>
           </a:xfrm>
           <a:prstGeom prst="rect">
             <a:avLst/>
@@ -9376,6 +8642,1063 @@
       </p:sp>
       <p:sp>
         <p:nvSpPr>
+          <p:cNvPr id="10" name="Rounded Rectangle 9"/>
+          <p:cNvSpPr/>
+          <p:nvPr/>
+        </p:nvSpPr>
+        <p:spPr>
+          <a:xfrm>
+            <a:off x="6121400" y="2552700"/>
+            <a:ext cx="355600" cy="355600"/>
+          </a:xfrm>
+          <a:prstGeom prst="roundRect">
+            <a:avLst>
+              <a:gd name="adj" fmla="val 25000"/>
+            </a:avLst>
+          </a:prstGeom>
+          <a:solidFill>
+            <a:srgbClr val="0A2C3B"/>
+          </a:solidFill>
+          <a:ln>
+            <a:noFill/>
+          </a:ln>
+          <a:effectLst/>
+        </p:spPr>
+        <p:style>
+          <a:lnRef idx="1">
+            <a:schemeClr val="accent1"/>
+          </a:lnRef>
+          <a:fillRef idx="3">
+            <a:schemeClr val="accent1"/>
+          </a:fillRef>
+          <a:effectRef idx="2">
+            <a:schemeClr val="accent1"/>
+          </a:effectRef>
+          <a:fontRef idx="minor">
+            <a:schemeClr val="lt1"/>
+          </a:fontRef>
+        </p:style>
+        <p:txBody>
+          <a:bodyPr rtlCol="0" anchor="ctr"/>
+          <a:lstStyle/>
+          <a:p>
+            <a:pPr algn="ctr"/>
+          </a:p>
+        </p:txBody>
+      </p:sp>
+      <p:pic>
+        <p:nvPicPr>
+          <p:cNvPr id="11" name="Picture 10" descr="icon-check-green.png"/>
+          <p:cNvPicPr>
+            <a:picLocks noChangeAspect="1"/>
+          </p:cNvPicPr>
+          <p:nvPr/>
+        </p:nvPicPr>
+        <p:blipFill>
+          <a:blip r:embed="rId2"/>
+          <a:stretch>
+            <a:fillRect/>
+          </a:stretch>
+        </p:blipFill>
+        <p:spPr>
+          <a:xfrm>
+            <a:off x="6210300" y="2641600"/>
+            <a:ext cx="177800" cy="177800"/>
+          </a:xfrm>
+          <a:prstGeom prst="rect">
+            <a:avLst/>
+          </a:prstGeom>
+        </p:spPr>
+      </p:pic>
+      <p:sp>
+        <p:nvSpPr>
+          <p:cNvPr id="12" name="TextBox 11"/>
+          <p:cNvSpPr txBox="1"/>
+          <p:nvPr/>
+        </p:nvSpPr>
+        <p:spPr>
+          <a:xfrm>
+            <a:off x="6654800" y="2590800"/>
+            <a:ext cx="4318000" cy="304800"/>
+          </a:xfrm>
+          <a:prstGeom prst="rect">
+            <a:avLst/>
+          </a:prstGeom>
+          <a:noFill/>
+        </p:spPr>
+        <p:txBody>
+          <a:bodyPr wrap="square" lIns="0" rIns="0" tIns="0" bIns="0">
+            <a:spAutoFit/>
+          </a:bodyPr>
+          <a:lstStyle/>
+          <a:p>
+            <a:pPr algn="l">
+              <a:lnSpc>
+                <a:spcPct val="135000"/>
+              </a:lnSpc>
+            </a:pPr>
+            <a:r>
+              <a:rPr sz="1600" b="0">
+                <a:solidFill>
+                  <a:srgbClr val="FFFFFF"/>
+                </a:solidFill>
+                <a:latin typeface="Inter"/>
+              </a:rPr>
+              <a:t>Discount for multi-year commitment</a:t>
+            </a:r>
+          </a:p>
+        </p:txBody>
+      </p:sp>
+      <p:sp>
+        <p:nvSpPr>
+          <p:cNvPr id="13" name="Rounded Rectangle 12"/>
+          <p:cNvSpPr/>
+          <p:nvPr/>
+        </p:nvSpPr>
+        <p:spPr>
+          <a:xfrm>
+            <a:off x="6121400" y="3162300"/>
+            <a:ext cx="355600" cy="355600"/>
+          </a:xfrm>
+          <a:prstGeom prst="roundRect">
+            <a:avLst>
+              <a:gd name="adj" fmla="val 25000"/>
+            </a:avLst>
+          </a:prstGeom>
+          <a:solidFill>
+            <a:srgbClr val="0A2C3B"/>
+          </a:solidFill>
+          <a:ln>
+            <a:noFill/>
+          </a:ln>
+          <a:effectLst/>
+        </p:spPr>
+        <p:style>
+          <a:lnRef idx="1">
+            <a:schemeClr val="accent1"/>
+          </a:lnRef>
+          <a:fillRef idx="3">
+            <a:schemeClr val="accent1"/>
+          </a:fillRef>
+          <a:effectRef idx="2">
+            <a:schemeClr val="accent1"/>
+          </a:effectRef>
+          <a:fontRef idx="minor">
+            <a:schemeClr val="lt1"/>
+          </a:fontRef>
+        </p:style>
+        <p:txBody>
+          <a:bodyPr rtlCol="0" anchor="ctr"/>
+          <a:lstStyle/>
+          <a:p>
+            <a:pPr algn="ctr"/>
+          </a:p>
+        </p:txBody>
+      </p:sp>
+      <p:pic>
+        <p:nvPicPr>
+          <p:cNvPr id="14" name="Picture 13" descr="icon-check-green.png"/>
+          <p:cNvPicPr>
+            <a:picLocks noChangeAspect="1"/>
+          </p:cNvPicPr>
+          <p:nvPr/>
+        </p:nvPicPr>
+        <p:blipFill>
+          <a:blip r:embed="rId2"/>
+          <a:stretch>
+            <a:fillRect/>
+          </a:stretch>
+        </p:blipFill>
+        <p:spPr>
+          <a:xfrm>
+            <a:off x="6210300" y="3251200"/>
+            <a:ext cx="177800" cy="177800"/>
+          </a:xfrm>
+          <a:prstGeom prst="rect">
+            <a:avLst/>
+          </a:prstGeom>
+        </p:spPr>
+      </p:pic>
+      <p:sp>
+        <p:nvSpPr>
+          <p:cNvPr id="15" name="TextBox 14"/>
+          <p:cNvSpPr txBox="1"/>
+          <p:nvPr/>
+        </p:nvSpPr>
+        <p:spPr>
+          <a:xfrm>
+            <a:off x="6654800" y="3200400"/>
+            <a:ext cx="4318000" cy="304800"/>
+          </a:xfrm>
+          <a:prstGeom prst="rect">
+            <a:avLst/>
+          </a:prstGeom>
+          <a:noFill/>
+        </p:spPr>
+        <p:txBody>
+          <a:bodyPr wrap="square" lIns="0" rIns="0" tIns="0" bIns="0">
+            <a:spAutoFit/>
+          </a:bodyPr>
+          <a:lstStyle/>
+          <a:p>
+            <a:pPr algn="l">
+              <a:lnSpc>
+                <a:spcPct val="135000"/>
+              </a:lnSpc>
+            </a:pPr>
+            <a:r>
+              <a:rPr sz="1600" b="0">
+                <a:solidFill>
+                  <a:srgbClr val="FFFFFF"/>
+                </a:solidFill>
+                <a:latin typeface="Inter"/>
+              </a:rPr>
+              <a:t>Scales with growing students &amp; instructors</a:t>
+            </a:r>
+          </a:p>
+        </p:txBody>
+      </p:sp>
+      <p:sp>
+        <p:nvSpPr>
+          <p:cNvPr id="16" name="Rectangle 15"/>
+          <p:cNvSpPr/>
+          <p:nvPr/>
+        </p:nvSpPr>
+        <p:spPr>
+          <a:xfrm>
+            <a:off x="762000" y="4673600"/>
+            <a:ext cx="10668000" cy="6350"/>
+          </a:xfrm>
+          <a:prstGeom prst="rect">
+            <a:avLst/>
+          </a:prstGeom>
+          <a:solidFill>
+            <a:srgbClr val="E7EEF0"/>
+          </a:solidFill>
+          <a:ln>
+            <a:noFill/>
+          </a:ln>
+          <a:effectLst/>
+        </p:spPr>
+        <p:style>
+          <a:lnRef idx="1">
+            <a:schemeClr val="accent1"/>
+          </a:lnRef>
+          <a:fillRef idx="3">
+            <a:schemeClr val="accent1"/>
+          </a:fillRef>
+          <a:effectRef idx="2">
+            <a:schemeClr val="accent1"/>
+          </a:effectRef>
+          <a:fontRef idx="minor">
+            <a:schemeClr val="lt1"/>
+          </a:fontRef>
+        </p:style>
+        <p:txBody>
+          <a:bodyPr rtlCol="0" anchor="ctr"/>
+          <a:lstStyle/>
+          <a:p>
+            <a:pPr algn="ctr"/>
+          </a:p>
+        </p:txBody>
+      </p:sp>
+      <p:sp>
+        <p:nvSpPr>
+          <p:cNvPr id="17" name="TextBox 16"/>
+          <p:cNvSpPr txBox="1"/>
+          <p:nvPr/>
+        </p:nvSpPr>
+        <p:spPr>
+          <a:xfrm>
+            <a:off x="762000" y="4826000"/>
+            <a:ext cx="3810000" cy="215900"/>
+          </a:xfrm>
+          <a:prstGeom prst="rect">
+            <a:avLst/>
+          </a:prstGeom>
+          <a:noFill/>
+        </p:spPr>
+        <p:txBody>
+          <a:bodyPr wrap="square" lIns="0" rIns="0" tIns="0" bIns="0">
+            <a:spAutoFit/>
+          </a:bodyPr>
+          <a:lstStyle/>
+          <a:p>
+            <a:pPr algn="l">
+              <a:lnSpc>
+                <a:spcPct val="120000"/>
+              </a:lnSpc>
+            </a:pPr>
+            <a:r>
+              <a:rPr sz="1200" b="0">
+                <a:solidFill>
+                  <a:srgbClr val="5B7480"/>
+                </a:solidFill>
+                <a:latin typeface="Inter"/>
+              </a:rPr>
+              <a:t>What that covers</a:t>
+            </a:r>
+          </a:p>
+        </p:txBody>
+      </p:sp>
+      <p:sp>
+        <p:nvSpPr>
+          <p:cNvPr id="18" name="Rounded Rectangle 17"/>
+          <p:cNvSpPr/>
+          <p:nvPr/>
+        </p:nvSpPr>
+        <p:spPr>
+          <a:xfrm>
+            <a:off x="762000" y="5207000"/>
+            <a:ext cx="457200" cy="457200"/>
+          </a:xfrm>
+          <a:prstGeom prst="roundRect">
+            <a:avLst>
+              <a:gd name="adj" fmla="val 22222"/>
+            </a:avLst>
+          </a:prstGeom>
+          <a:solidFill>
+            <a:srgbClr val="F3F7F8"/>
+          </a:solidFill>
+          <a:ln>
+            <a:noFill/>
+          </a:ln>
+          <a:effectLst/>
+        </p:spPr>
+        <p:style>
+          <a:lnRef idx="1">
+            <a:schemeClr val="accent1"/>
+          </a:lnRef>
+          <a:fillRef idx="3">
+            <a:schemeClr val="accent1"/>
+          </a:fillRef>
+          <a:effectRef idx="2">
+            <a:schemeClr val="accent1"/>
+          </a:effectRef>
+          <a:fontRef idx="minor">
+            <a:schemeClr val="lt1"/>
+          </a:fontRef>
+        </p:style>
+        <p:txBody>
+          <a:bodyPr rtlCol="0" anchor="ctr"/>
+          <a:lstStyle/>
+          <a:p>
+            <a:pPr algn="ctr"/>
+          </a:p>
+        </p:txBody>
+      </p:sp>
+      <p:pic>
+        <p:nvPicPr>
+          <p:cNvPr id="19" name="Picture 18" descr="icon-doel-navy.png"/>
+          <p:cNvPicPr>
+            <a:picLocks noChangeAspect="1"/>
+          </p:cNvPicPr>
+          <p:nvPr/>
+        </p:nvPicPr>
+        <p:blipFill>
+          <a:blip r:embed="rId3"/>
+          <a:stretch>
+            <a:fillRect/>
+          </a:stretch>
+        </p:blipFill>
+        <p:spPr>
+          <a:xfrm>
+            <a:off x="876300" y="5321300"/>
+            <a:ext cx="228600" cy="228600"/>
+          </a:xfrm>
+          <a:prstGeom prst="rect">
+            <a:avLst/>
+          </a:prstGeom>
+        </p:spPr>
+      </p:pic>
+      <p:sp>
+        <p:nvSpPr>
+          <p:cNvPr id="20" name="TextBox 19"/>
+          <p:cNvSpPr txBox="1"/>
+          <p:nvPr/>
+        </p:nvSpPr>
+        <p:spPr>
+          <a:xfrm>
+            <a:off x="1346200" y="5334000"/>
+            <a:ext cx="1854200" cy="254000"/>
+          </a:xfrm>
+          <a:prstGeom prst="rect">
+            <a:avLst/>
+          </a:prstGeom>
+          <a:noFill/>
+        </p:spPr>
+        <p:txBody>
+          <a:bodyPr wrap="square" lIns="0" rIns="0" tIns="0" bIns="0">
+            <a:spAutoFit/>
+          </a:bodyPr>
+          <a:lstStyle/>
+          <a:p>
+            <a:pPr algn="l">
+              <a:lnSpc>
+                <a:spcPct val="130000"/>
+              </a:lnSpc>
+            </a:pPr>
+            <a:r>
+              <a:rPr sz="1200" b="0">
+                <a:solidFill>
+                  <a:srgbClr val="5B7480"/>
+                </a:solidFill>
+                <a:latin typeface="Inter"/>
+              </a:rPr>
+              <a:t>Accuracy &amp; Consistency</a:t>
+            </a:r>
+          </a:p>
+        </p:txBody>
+      </p:sp>
+      <p:sp>
+        <p:nvSpPr>
+          <p:cNvPr id="21" name="Rounded Rectangle 20"/>
+          <p:cNvSpPr/>
+          <p:nvPr/>
+        </p:nvSpPr>
+        <p:spPr>
+          <a:xfrm>
+            <a:off x="3505200" y="5207000"/>
+            <a:ext cx="457200" cy="457200"/>
+          </a:xfrm>
+          <a:prstGeom prst="roundRect">
+            <a:avLst>
+              <a:gd name="adj" fmla="val 22222"/>
+            </a:avLst>
+          </a:prstGeom>
+          <a:solidFill>
+            <a:srgbClr val="F3F7F8"/>
+          </a:solidFill>
+          <a:ln>
+            <a:noFill/>
+          </a:ln>
+          <a:effectLst/>
+        </p:spPr>
+        <p:style>
+          <a:lnRef idx="1">
+            <a:schemeClr val="accent1"/>
+          </a:lnRef>
+          <a:fillRef idx="3">
+            <a:schemeClr val="accent1"/>
+          </a:fillRef>
+          <a:effectRef idx="2">
+            <a:schemeClr val="accent1"/>
+          </a:effectRef>
+          <a:fontRef idx="minor">
+            <a:schemeClr val="lt1"/>
+          </a:fontRef>
+        </p:style>
+        <p:txBody>
+          <a:bodyPr rtlCol="0" anchor="ctr"/>
+          <a:lstStyle/>
+          <a:p>
+            <a:pPr algn="ctr"/>
+          </a:p>
+        </p:txBody>
+      </p:sp>
+      <p:pic>
+        <p:nvPicPr>
+          <p:cNvPr id="22" name="Picture 21" descr="icon-sleutel-navy.png"/>
+          <p:cNvPicPr>
+            <a:picLocks noChangeAspect="1"/>
+          </p:cNvPicPr>
+          <p:nvPr/>
+        </p:nvPicPr>
+        <p:blipFill>
+          <a:blip r:embed="rId4"/>
+          <a:stretch>
+            <a:fillRect/>
+          </a:stretch>
+        </p:blipFill>
+        <p:spPr>
+          <a:xfrm>
+            <a:off x="3619500" y="5321300"/>
+            <a:ext cx="228600" cy="228600"/>
+          </a:xfrm>
+          <a:prstGeom prst="rect">
+            <a:avLst/>
+          </a:prstGeom>
+        </p:spPr>
+      </p:pic>
+      <p:sp>
+        <p:nvSpPr>
+          <p:cNvPr id="23" name="TextBox 22"/>
+          <p:cNvSpPr txBox="1"/>
+          <p:nvPr/>
+        </p:nvSpPr>
+        <p:spPr>
+          <a:xfrm>
+            <a:off x="4089400" y="5334000"/>
+            <a:ext cx="1854200" cy="254000"/>
+          </a:xfrm>
+          <a:prstGeom prst="rect">
+            <a:avLst/>
+          </a:prstGeom>
+          <a:noFill/>
+        </p:spPr>
+        <p:txBody>
+          <a:bodyPr wrap="square" lIns="0" rIns="0" tIns="0" bIns="0">
+            <a:spAutoFit/>
+          </a:bodyPr>
+          <a:lstStyle/>
+          <a:p>
+            <a:pPr algn="l">
+              <a:lnSpc>
+                <a:spcPct val="130000"/>
+              </a:lnSpc>
+            </a:pPr>
+            <a:r>
+              <a:rPr sz="1200" b="0">
+                <a:solidFill>
+                  <a:srgbClr val="5B7480"/>
+                </a:solidFill>
+                <a:latin typeface="Inter"/>
+              </a:rPr>
+              <a:t>Technical Domain Fit</a:t>
+            </a:r>
+          </a:p>
+        </p:txBody>
+      </p:sp>
+      <p:sp>
+        <p:nvSpPr>
+          <p:cNvPr id="24" name="Rounded Rectangle 23"/>
+          <p:cNvSpPr/>
+          <p:nvPr/>
+        </p:nvSpPr>
+        <p:spPr>
+          <a:xfrm>
+            <a:off x="6248400" y="5207000"/>
+            <a:ext cx="457200" cy="457200"/>
+          </a:xfrm>
+          <a:prstGeom prst="roundRect">
+            <a:avLst>
+              <a:gd name="adj" fmla="val 22222"/>
+            </a:avLst>
+          </a:prstGeom>
+          <a:solidFill>
+            <a:srgbClr val="F3F7F8"/>
+          </a:solidFill>
+          <a:ln>
+            <a:noFill/>
+          </a:ln>
+          <a:effectLst/>
+        </p:spPr>
+        <p:style>
+          <a:lnRef idx="1">
+            <a:schemeClr val="accent1"/>
+          </a:lnRef>
+          <a:fillRef idx="3">
+            <a:schemeClr val="accent1"/>
+          </a:fillRef>
+          <a:effectRef idx="2">
+            <a:schemeClr val="accent1"/>
+          </a:effectRef>
+          <a:fontRef idx="minor">
+            <a:schemeClr val="lt1"/>
+          </a:fontRef>
+        </p:style>
+        <p:txBody>
+          <a:bodyPr rtlCol="0" anchor="ctr"/>
+          <a:lstStyle/>
+          <a:p>
+            <a:pPr algn="ctr"/>
+          </a:p>
+        </p:txBody>
+      </p:sp>
+      <p:pic>
+        <p:nvPicPr>
+          <p:cNvPr id="25" name="Picture 24" descr="icon-instelling-navy.png"/>
+          <p:cNvPicPr>
+            <a:picLocks noChangeAspect="1"/>
+          </p:cNvPicPr>
+          <p:nvPr/>
+        </p:nvPicPr>
+        <p:blipFill>
+          <a:blip r:embed="rId5"/>
+          <a:stretch>
+            <a:fillRect/>
+          </a:stretch>
+        </p:blipFill>
+        <p:spPr>
+          <a:xfrm>
+            <a:off x="6362700" y="5321300"/>
+            <a:ext cx="228600" cy="228600"/>
+          </a:xfrm>
+          <a:prstGeom prst="rect">
+            <a:avLst/>
+          </a:prstGeom>
+        </p:spPr>
+      </p:pic>
+      <p:sp>
+        <p:nvSpPr>
+          <p:cNvPr id="26" name="TextBox 25"/>
+          <p:cNvSpPr txBox="1"/>
+          <p:nvPr/>
+        </p:nvSpPr>
+        <p:spPr>
+          <a:xfrm>
+            <a:off x="6832600" y="5334000"/>
+            <a:ext cx="1854200" cy="254000"/>
+          </a:xfrm>
+          <a:prstGeom prst="rect">
+            <a:avLst/>
+          </a:prstGeom>
+          <a:noFill/>
+        </p:spPr>
+        <p:txBody>
+          <a:bodyPr wrap="square" lIns="0" rIns="0" tIns="0" bIns="0">
+            <a:spAutoFit/>
+          </a:bodyPr>
+          <a:lstStyle/>
+          <a:p>
+            <a:pPr algn="l">
+              <a:lnSpc>
+                <a:spcPct val="130000"/>
+              </a:lnSpc>
+            </a:pPr>
+            <a:r>
+              <a:rPr sz="1200" b="0">
+                <a:solidFill>
+                  <a:srgbClr val="5B7480"/>
+                </a:solidFill>
+                <a:latin typeface="Inter"/>
+              </a:rPr>
+              <a:t>Institution-Wide</a:t>
+            </a:r>
+          </a:p>
+        </p:txBody>
+      </p:sp>
+      <p:sp>
+        <p:nvSpPr>
+          <p:cNvPr id="27" name="Rounded Rectangle 26"/>
+          <p:cNvSpPr/>
+          <p:nvPr/>
+        </p:nvSpPr>
+        <p:spPr>
+          <a:xfrm>
+            <a:off x="8991600" y="5207000"/>
+            <a:ext cx="457200" cy="457200"/>
+          </a:xfrm>
+          <a:prstGeom prst="roundRect">
+            <a:avLst>
+              <a:gd name="adj" fmla="val 22222"/>
+            </a:avLst>
+          </a:prstGeom>
+          <a:solidFill>
+            <a:srgbClr val="F3F7F8"/>
+          </a:solidFill>
+          <a:ln>
+            <a:noFill/>
+          </a:ln>
+          <a:effectLst/>
+        </p:spPr>
+        <p:style>
+          <a:lnRef idx="1">
+            <a:schemeClr val="accent1"/>
+          </a:lnRef>
+          <a:fillRef idx="3">
+            <a:schemeClr val="accent1"/>
+          </a:fillRef>
+          <a:effectRef idx="2">
+            <a:schemeClr val="accent1"/>
+          </a:effectRef>
+          <a:fontRef idx="minor">
+            <a:schemeClr val="lt1"/>
+          </a:fontRef>
+        </p:style>
+        <p:txBody>
+          <a:bodyPr rtlCol="0" anchor="ctr"/>
+          <a:lstStyle/>
+          <a:p>
+            <a:pPr algn="ctr"/>
+          </a:p>
+        </p:txBody>
+      </p:sp>
+      <p:pic>
+        <p:nvPicPr>
+          <p:cNvPr id="28" name="Picture 27" descr="icon-schuifjes-navy.png"/>
+          <p:cNvPicPr>
+            <a:picLocks noChangeAspect="1"/>
+          </p:cNvPicPr>
+          <p:nvPr/>
+        </p:nvPicPr>
+        <p:blipFill>
+          <a:blip r:embed="rId6"/>
+          <a:stretch>
+            <a:fillRect/>
+          </a:stretch>
+        </p:blipFill>
+        <p:spPr>
+          <a:xfrm>
+            <a:off x="9105900" y="5321300"/>
+            <a:ext cx="228600" cy="228600"/>
+          </a:xfrm>
+          <a:prstGeom prst="rect">
+            <a:avLst/>
+          </a:prstGeom>
+        </p:spPr>
+      </p:pic>
+      <p:sp>
+        <p:nvSpPr>
+          <p:cNvPr id="29" name="TextBox 28"/>
+          <p:cNvSpPr txBox="1"/>
+          <p:nvPr/>
+        </p:nvSpPr>
+        <p:spPr>
+          <a:xfrm>
+            <a:off x="9575800" y="5334000"/>
+            <a:ext cx="1854200" cy="254000"/>
+          </a:xfrm>
+          <a:prstGeom prst="rect">
+            <a:avLst/>
+          </a:prstGeom>
+          <a:noFill/>
+        </p:spPr>
+        <p:txBody>
+          <a:bodyPr wrap="square" lIns="0" rIns="0" tIns="0" bIns="0">
+            <a:spAutoFit/>
+          </a:bodyPr>
+          <a:lstStyle/>
+          <a:p>
+            <a:pPr algn="l">
+              <a:lnSpc>
+                <a:spcPct val="130000"/>
+              </a:lnSpc>
+            </a:pPr>
+            <a:r>
+              <a:rPr sz="1200" b="0">
+                <a:solidFill>
+                  <a:srgbClr val="5B7480"/>
+                </a:solidFill>
+                <a:latin typeface="Inter"/>
+              </a:rPr>
+              <a:t>Self-Configuring</a:t>
+            </a:r>
+          </a:p>
+        </p:txBody>
+      </p:sp>
+      <p:sp>
+        <p:nvSpPr>
+          <p:cNvPr id="30" name="Rectangle 29"/>
+          <p:cNvSpPr/>
+          <p:nvPr/>
+        </p:nvSpPr>
+        <p:spPr>
+          <a:xfrm>
+            <a:off x="762000" y="6045200"/>
+            <a:ext cx="10668000" cy="6350"/>
+          </a:xfrm>
+          <a:prstGeom prst="rect">
+            <a:avLst/>
+          </a:prstGeom>
+          <a:solidFill>
+            <a:srgbClr val="E7EEF0"/>
+          </a:solidFill>
+          <a:ln>
+            <a:noFill/>
+          </a:ln>
+          <a:effectLst/>
+        </p:spPr>
+        <p:style>
+          <a:lnRef idx="1">
+            <a:schemeClr val="accent1"/>
+          </a:lnRef>
+          <a:fillRef idx="3">
+            <a:schemeClr val="accent1"/>
+          </a:fillRef>
+          <a:effectRef idx="2">
+            <a:schemeClr val="accent1"/>
+          </a:effectRef>
+          <a:fontRef idx="minor">
+            <a:schemeClr val="lt1"/>
+          </a:fontRef>
+        </p:style>
+        <p:txBody>
+          <a:bodyPr rtlCol="0" anchor="ctr"/>
+          <a:lstStyle/>
+          <a:p>
+            <a:pPr algn="ctr"/>
+          </a:p>
+        </p:txBody>
+      </p:sp>
+      <p:pic>
+        <p:nvPicPr>
+          <p:cNvPr id="31" name="Picture 30" descr="logo_navy.png"/>
+          <p:cNvPicPr>
+            <a:picLocks noChangeAspect="1"/>
+          </p:cNvPicPr>
+          <p:nvPr/>
+        </p:nvPicPr>
+        <p:blipFill>
+          <a:blip r:embed="rId7"/>
+          <a:stretch>
+            <a:fillRect/>
+          </a:stretch>
+        </p:blipFill>
+        <p:spPr>
+          <a:xfrm>
+            <a:off x="762000" y="6324600"/>
+            <a:ext cx="937957" cy="254000"/>
+          </a:xfrm>
+          <a:prstGeom prst="rect">
+            <a:avLst/>
+          </a:prstGeom>
+        </p:spPr>
+      </p:pic>
+      <p:sp>
+        <p:nvSpPr>
+          <p:cNvPr id="32" name="Rectangle 31"/>
+          <p:cNvSpPr/>
+          <p:nvPr/>
+        </p:nvSpPr>
+        <p:spPr>
+          <a:xfrm>
+            <a:off x="1968500" y="6311900"/>
+            <a:ext cx="6350" cy="279400"/>
+          </a:xfrm>
+          <a:prstGeom prst="rect">
+            <a:avLst/>
+          </a:prstGeom>
+          <a:solidFill>
+            <a:srgbClr val="CDD9DE"/>
+          </a:solidFill>
+          <a:ln>
+            <a:noFill/>
+          </a:ln>
+          <a:effectLst/>
+        </p:spPr>
+        <p:style>
+          <a:lnRef idx="1">
+            <a:schemeClr val="accent1"/>
+          </a:lnRef>
+          <a:fillRef idx="3">
+            <a:schemeClr val="accent1"/>
+          </a:fillRef>
+          <a:effectRef idx="2">
+            <a:schemeClr val="accent1"/>
+          </a:effectRef>
+          <a:fontRef idx="minor">
+            <a:schemeClr val="lt1"/>
+          </a:fontRef>
+        </p:style>
+        <p:txBody>
+          <a:bodyPr rtlCol="0" anchor="ctr"/>
+          <a:lstStyle/>
+          <a:p>
+            <a:pPr algn="ctr"/>
+          </a:p>
+        </p:txBody>
+      </p:sp>
+      <p:pic>
+        <p:nvPicPr>
+          <p:cNvPr id="33" name="Picture 32" descr="uti-logo.png"/>
+          <p:cNvPicPr>
+            <a:picLocks noChangeAspect="1"/>
+          </p:cNvPicPr>
+          <p:nvPr/>
+        </p:nvPicPr>
+        <p:blipFill>
+          <a:blip r:embed="rId8"/>
+          <a:stretch>
+            <a:fillRect/>
+          </a:stretch>
+        </p:blipFill>
+        <p:spPr>
+          <a:xfrm>
+            <a:off x="2222500" y="6273800"/>
+            <a:ext cx="774246" cy="355600"/>
+          </a:xfrm>
+          <a:prstGeom prst="rect">
+            <a:avLst/>
+          </a:prstGeom>
+        </p:spPr>
+      </p:pic>
+      <p:sp>
+        <p:nvSpPr>
+          <p:cNvPr id="34" name="TextBox 33"/>
+          <p:cNvSpPr txBox="1"/>
+          <p:nvPr/>
+        </p:nvSpPr>
+        <p:spPr>
+          <a:xfrm>
+            <a:off x="10922000" y="6375400"/>
+            <a:ext cx="508000" cy="228600"/>
+          </a:xfrm>
+          <a:prstGeom prst="rect">
+            <a:avLst/>
+          </a:prstGeom>
+          <a:noFill/>
+        </p:spPr>
+        <p:txBody>
+          <a:bodyPr wrap="square" lIns="0" rIns="0" tIns="0" bIns="0">
+            <a:spAutoFit/>
+          </a:bodyPr>
+          <a:lstStyle/>
+          <a:p>
+            <a:pPr algn="r">
+              <a:lnSpc>
+                <a:spcPct val="115000"/>
+              </a:lnSpc>
+            </a:pPr>
+            <a:r>
+              <a:rPr sz="1200" b="0">
+                <a:solidFill>
+                  <a:srgbClr val="5B7480"/>
+                </a:solidFill>
+                <a:latin typeface="Inter"/>
+              </a:rPr>
+              <a:t>15</a:t>
+            </a:r>
+          </a:p>
+        </p:txBody>
+      </p:sp>
+    </p:spTree>
+  </p:cSld>
+  <p:clrMapOvr>
+    <a:masterClrMapping/>
+  </p:clrMapOvr>
+</p:sld>
+</file>
+
+<file path=ppt/slides/slide16.xml><?xml version="1.0" encoding="utf-8"?>
+<p:sld xmlns:a="http://schemas.openxmlformats.org/drawingml/2006/main" xmlns:p="http://schemas.openxmlformats.org/presentationml/2006/main" xmlns:r="http://schemas.openxmlformats.org/officeDocument/2006/relationships">
+  <p:cSld>
+    <p:spTree>
+      <p:nvGrpSpPr>
+        <p:cNvPr id="1" name=""/>
+        <p:cNvGrpSpPr/>
+        <p:nvPr/>
+      </p:nvGrpSpPr>
+      <p:grpSpPr/>
+      <p:sp>
+        <p:nvSpPr>
+          <p:cNvPr id="2" name="Rectangle 1"/>
+          <p:cNvSpPr/>
+          <p:nvPr/>
+        </p:nvSpPr>
+        <p:spPr>
+          <a:xfrm>
+            <a:off x="0" y="0"/>
+            <a:ext cx="12192000" cy="6858000"/>
+          </a:xfrm>
+          <a:prstGeom prst="rect">
+            <a:avLst/>
+          </a:prstGeom>
+          <a:solidFill>
+            <a:srgbClr val="002333"/>
+          </a:solidFill>
+          <a:ln>
+            <a:noFill/>
+          </a:ln>
+          <a:effectLst/>
+        </p:spPr>
+        <p:style>
+          <a:lnRef idx="1">
+            <a:schemeClr val="accent1"/>
+          </a:lnRef>
+          <a:fillRef idx="3">
+            <a:schemeClr val="accent1"/>
+          </a:fillRef>
+          <a:effectRef idx="2">
+            <a:schemeClr val="accent1"/>
+          </a:effectRef>
+          <a:fontRef idx="minor">
+            <a:schemeClr val="lt1"/>
+          </a:fontRef>
+        </p:style>
+        <p:txBody>
+          <a:bodyPr rtlCol="0" anchor="ctr"/>
+          <a:lstStyle/>
+          <a:p>
+            <a:pPr algn="ctr"/>
+          </a:p>
+        </p:txBody>
+      </p:sp>
+      <p:sp>
+        <p:nvSpPr>
+          <p:cNvPr id="3" name="TextBox 2"/>
+          <p:cNvSpPr txBox="1"/>
+          <p:nvPr/>
+        </p:nvSpPr>
+        <p:spPr>
+          <a:xfrm>
+            <a:off x="762000" y="558800"/>
+            <a:ext cx="10668000" cy="627380"/>
+          </a:xfrm>
+          <a:prstGeom prst="rect">
+            <a:avLst/>
+          </a:prstGeom>
+          <a:noFill/>
+        </p:spPr>
+        <p:txBody>
+          <a:bodyPr wrap="square" lIns="0" rIns="0" tIns="0" bIns="0">
+            <a:spAutoFit/>
+          </a:bodyPr>
+          <a:lstStyle/>
+          <a:p>
+            <a:pPr algn="l">
+              <a:lnSpc>
+                <a:spcPct val="104000"/>
+              </a:lnSpc>
+            </a:pPr>
+            <a:r>
+              <a:rPr sz="3800" b="1">
+                <a:solidFill>
+                  <a:srgbClr val="FFFFFF"/>
+                </a:solidFill>
+                <a:latin typeface="League Spartan"/>
+              </a:rPr>
+              <a:t>Proposed Next Steps</a:t>
+            </a:r>
+          </a:p>
+        </p:txBody>
+      </p:sp>
+      <p:sp>
+        <p:nvSpPr>
+          <p:cNvPr id="4" name="Rectangle 3"/>
+          <p:cNvSpPr/>
+          <p:nvPr/>
+        </p:nvSpPr>
+        <p:spPr>
+          <a:xfrm>
+            <a:off x="1466850" y="2070100"/>
+            <a:ext cx="12700" cy="3251200"/>
+          </a:xfrm>
+          <a:prstGeom prst="rect">
+            <a:avLst/>
+          </a:prstGeom>
+          <a:solidFill>
+            <a:srgbClr val="1F3D4B"/>
+          </a:solidFill>
+          <a:ln>
+            <a:noFill/>
+          </a:ln>
+          <a:effectLst/>
+        </p:spPr>
+        <p:style>
+          <a:lnRef idx="1">
+            <a:schemeClr val="accent1"/>
+          </a:lnRef>
+          <a:fillRef idx="3">
+            <a:schemeClr val="accent1"/>
+          </a:fillRef>
+          <a:effectRef idx="2">
+            <a:schemeClr val="accent1"/>
+          </a:effectRef>
+          <a:fontRef idx="minor">
+            <a:schemeClr val="lt1"/>
+          </a:fontRef>
+        </p:style>
+        <p:txBody>
+          <a:bodyPr rtlCol="0" anchor="ctr"/>
+          <a:lstStyle/>
+          <a:p>
+            <a:pPr algn="ctr"/>
+          </a:p>
+        </p:txBody>
+      </p:sp>
+      <p:sp>
+        <p:nvSpPr>
           <p:cNvPr id="5" name="Rounded Rectangle 4"/>
           <p:cNvSpPr/>
           <p:nvPr/>
@@ -10644,7 +10967,7 @@
                 </a:solidFill>
                 <a:latin typeface="Inter"/>
               </a:rPr>
-              <a:t>15</a:t>
+              <a:t>16</a:t>
             </a:r>
           </a:p>
         </p:txBody>
@@ -11511,7 +11834,7 @@
                 </a:solidFill>
                 <a:latin typeface="Inter"/>
               </a:rPr>
-              <a:t>Proven Results</a:t>
+              <a:t>Demo</a:t>
             </a:r>
           </a:p>
         </p:txBody>
@@ -11633,7 +11956,7 @@
                 </a:solidFill>
                 <a:latin typeface="Inter"/>
               </a:rPr>
-              <a:t>Our Solution</a:t>
+              <a:t>Proven Results</a:t>
             </a:r>
           </a:p>
         </p:txBody>
@@ -11755,7 +12078,7 @@
                 </a:solidFill>
                 <a:latin typeface="Inter"/>
               </a:rPr>
-              <a:t>Next Steps</a:t>
+              <a:t>Our Solution</a:t>
             </a:r>
           </a:p>
         </p:txBody>
@@ -11768,8 +12091,8 @@
         </p:nvSpPr>
         <p:spPr>
           <a:xfrm>
-            <a:off x="762000" y="6045200"/>
-            <a:ext cx="10668000" cy="6350"/>
+            <a:off x="6985000" y="4622800"/>
+            <a:ext cx="4445000" cy="6350"/>
           </a:xfrm>
           <a:prstGeom prst="rect">
             <a:avLst/>
@@ -11804,9 +12127,131 @@
           </a:p>
         </p:txBody>
       </p:sp>
+      <p:sp>
+        <p:nvSpPr>
+          <p:cNvPr id="30" name="TextBox 29"/>
+          <p:cNvSpPr txBox="1"/>
+          <p:nvPr/>
+        </p:nvSpPr>
+        <p:spPr>
+          <a:xfrm>
+            <a:off x="6985000" y="4997450"/>
+            <a:ext cx="381000" cy="215900"/>
+          </a:xfrm>
+          <a:prstGeom prst="rect">
+            <a:avLst/>
+          </a:prstGeom>
+          <a:noFill/>
+        </p:spPr>
+        <p:txBody>
+          <a:bodyPr wrap="square" lIns="0" rIns="0" tIns="0" bIns="0">
+            <a:spAutoFit/>
+          </a:bodyPr>
+          <a:lstStyle/>
+          <a:p>
+            <a:pPr algn="l">
+              <a:lnSpc>
+                <a:spcPct val="100000"/>
+              </a:lnSpc>
+            </a:pPr>
+            <a:r>
+              <a:rPr sz="1200" b="0">
+                <a:solidFill>
+                  <a:srgbClr val="5B7480"/>
+                </a:solidFill>
+                <a:latin typeface="League Spartan"/>
+              </a:rPr>
+              <a:t>10</a:t>
+            </a:r>
+          </a:p>
+        </p:txBody>
+      </p:sp>
+      <p:sp>
+        <p:nvSpPr>
+          <p:cNvPr id="31" name="TextBox 30"/>
+          <p:cNvSpPr txBox="1"/>
+          <p:nvPr/>
+        </p:nvSpPr>
+        <p:spPr>
+          <a:xfrm>
+            <a:off x="7442200" y="4940300"/>
+            <a:ext cx="3987800" cy="304800"/>
+          </a:xfrm>
+          <a:prstGeom prst="rect">
+            <a:avLst/>
+          </a:prstGeom>
+          <a:noFill/>
+        </p:spPr>
+        <p:txBody>
+          <a:bodyPr wrap="square" lIns="0" rIns="0" tIns="0" bIns="0">
+            <a:spAutoFit/>
+          </a:bodyPr>
+          <a:lstStyle/>
+          <a:p>
+            <a:pPr algn="l">
+              <a:lnSpc>
+                <a:spcPct val="120000"/>
+              </a:lnSpc>
+            </a:pPr>
+            <a:r>
+              <a:rPr sz="1600" b="0">
+                <a:solidFill>
+                  <a:srgbClr val="002333"/>
+                </a:solidFill>
+                <a:latin typeface="Inter"/>
+              </a:rPr>
+              <a:t>Next Steps</a:t>
+            </a:r>
+          </a:p>
+        </p:txBody>
+      </p:sp>
+      <p:sp>
+        <p:nvSpPr>
+          <p:cNvPr id="32" name="Rectangle 31"/>
+          <p:cNvSpPr/>
+          <p:nvPr/>
+        </p:nvSpPr>
+        <p:spPr>
+          <a:xfrm>
+            <a:off x="762000" y="6045200"/>
+            <a:ext cx="10668000" cy="6350"/>
+          </a:xfrm>
+          <a:prstGeom prst="rect">
+            <a:avLst/>
+          </a:prstGeom>
+          <a:solidFill>
+            <a:srgbClr val="E7EEF0"/>
+          </a:solidFill>
+          <a:ln>
+            <a:noFill/>
+          </a:ln>
+          <a:effectLst/>
+        </p:spPr>
+        <p:style>
+          <a:lnRef idx="1">
+            <a:schemeClr val="accent1"/>
+          </a:lnRef>
+          <a:fillRef idx="3">
+            <a:schemeClr val="accent1"/>
+          </a:fillRef>
+          <a:effectRef idx="2">
+            <a:schemeClr val="accent1"/>
+          </a:effectRef>
+          <a:fontRef idx="minor">
+            <a:schemeClr val="lt1"/>
+          </a:fontRef>
+        </p:style>
+        <p:txBody>
+          <a:bodyPr rtlCol="0" anchor="ctr"/>
+          <a:lstStyle/>
+          <a:p>
+            <a:pPr algn="ctr"/>
+          </a:p>
+        </p:txBody>
+      </p:sp>
       <p:pic>
         <p:nvPicPr>
-          <p:cNvPr id="30" name="Picture 29" descr="logo_navy.png"/>
+          <p:cNvPr id="33" name="Picture 32" descr="logo_navy.png"/>
           <p:cNvPicPr>
             <a:picLocks noChangeAspect="1"/>
           </p:cNvPicPr>
@@ -11830,7 +12275,7 @@
       </p:pic>
       <p:sp>
         <p:nvSpPr>
-          <p:cNvPr id="31" name="Rectangle 30"/>
+          <p:cNvPr id="34" name="Rectangle 33"/>
           <p:cNvSpPr/>
           <p:nvPr/>
         </p:nvSpPr>
@@ -11874,7 +12319,7 @@
       </p:sp>
       <p:pic>
         <p:nvPicPr>
-          <p:cNvPr id="32" name="Picture 31" descr="uti-logo.png"/>
+          <p:cNvPr id="35" name="Picture 34" descr="uti-logo.png"/>
           <p:cNvPicPr>
             <a:picLocks noChangeAspect="1"/>
           </p:cNvPicPr>
@@ -11898,7 +12343,7 @@
       </p:pic>
       <p:sp>
         <p:nvSpPr>
-          <p:cNvPr id="33" name="TextBox 32"/>
+          <p:cNvPr id="36" name="TextBox 35"/>
           <p:cNvSpPr txBox="1"/>
           <p:nvPr/>
         </p:nvSpPr>

</xml_diff>

<commit_message>
UTI-deck: vervolgstappen terug naar drie, en groter
Confirm Priority and Budget en Validate in the U.S. zijn eruit op verzoek van
Dante; de overige drie stappen zijn hernummerd naar 01 tot 03. De vrijgekomen
ruimte gaat naar formaat: tegels van 80 naar 112, koppen van TEXT naar SUB, en
rijen van 128 naar 200 hoog.

Geen groene tegel meer op stap 1. Die markeerde de enige stap die nu gevraagd
werd, en in deze opzet begint de slide bij de pilot, dus er valt niets als enige
te markeren.

De controle sloeg aan op 'legal and it validation'; die tekst hoorde bij de
geschrapte stap, dus de verwachting is meegegaan.

Co-Authored-By: Claude Opus 5 <noreply@anthropic.com>
Claude-Session: https://claude.ai/code/session_01NLHJ2Mm4EhXvCdoUv8TcEZ
</commit_message>
<xml_diff>
--- a/projects/uti/deck/UTI-Eduface-deck.pptx
+++ b/projects/uti/deck/UTI-Eduface-deck.pptx
@@ -9661,8 +9661,8 @@
         </p:nvSpPr>
         <p:spPr>
           <a:xfrm>
-            <a:off x="1466850" y="2070100"/>
-            <a:ext cx="12700" cy="3251200"/>
+            <a:off x="1619250" y="2540000"/>
+            <a:ext cx="12700" cy="2540000"/>
           </a:xfrm>
           <a:prstGeom prst="rect">
             <a:avLst/>
@@ -9705,16 +9705,16 @@
         </p:nvSpPr>
         <p:spPr>
           <a:xfrm>
-            <a:off x="1219200" y="1816100"/>
-            <a:ext cx="508000" cy="508000"/>
+            <a:off x="1270000" y="2184400"/>
+            <a:ext cx="711200" cy="711200"/>
           </a:xfrm>
           <a:prstGeom prst="roundRect">
             <a:avLst>
-              <a:gd name="adj" fmla="val 22500"/>
+              <a:gd name="adj" fmla="val 19642"/>
             </a:avLst>
           </a:prstGeom>
           <a:solidFill>
-            <a:srgbClr val="00E075"/>
+            <a:srgbClr val="0A2C3B"/>
           </a:solidFill>
           <a:ln>
             <a:noFill/>
@@ -9745,7 +9745,7 @@
       </p:sp>
       <p:pic>
         <p:nvPicPr>
-          <p:cNvPr id="6" name="Picture 5" descr="icon-mensen-navy.png"/>
+          <p:cNvPr id="6" name="Picture 5" descr="icon-vlag-green.png"/>
           <p:cNvPicPr>
             <a:picLocks noChangeAspect="1"/>
           </p:cNvPicPr>
@@ -9759,8 +9759,8 @@
         </p:blipFill>
         <p:spPr>
           <a:xfrm>
-            <a:off x="1346200" y="1943100"/>
-            <a:ext cx="254000" cy="254000"/>
+            <a:off x="1447800" y="2362200"/>
+            <a:ext cx="355600" cy="355600"/>
           </a:xfrm>
           <a:prstGeom prst="rect">
             <a:avLst/>
@@ -9775,8 +9775,8 @@
         </p:nvSpPr>
         <p:spPr>
           <a:xfrm>
-            <a:off x="762000" y="1955800"/>
-            <a:ext cx="355600" cy="228600"/>
+            <a:off x="762000" y="2400300"/>
+            <a:ext cx="406400" cy="279400"/>
           </a:xfrm>
           <a:prstGeom prst="rect">
             <a:avLst/>
@@ -9795,9 +9795,9 @@
               </a:lnSpc>
             </a:pPr>
             <a:r>
-              <a:rPr sz="1200" b="0">
-                <a:solidFill>
-                  <a:srgbClr val="00E075"/>
+              <a:rPr sz="1600" b="0">
+                <a:solidFill>
+                  <a:srgbClr val="9EABB1"/>
                 </a:solidFill>
                 <a:latin typeface="League Spartan"/>
               </a:rPr>
@@ -9814,8 +9814,8 @@
         </p:nvSpPr>
         <p:spPr>
           <a:xfrm>
-            <a:off x="1981200" y="1765300"/>
-            <a:ext cx="2159000" cy="528320"/>
+            <a:off x="2235200" y="2095500"/>
+            <a:ext cx="2794000" cy="726440"/>
           </a:xfrm>
           <a:prstGeom prst="rect">
             <a:avLst/>
@@ -9830,33 +9830,33 @@
           <a:p>
             <a:pPr algn="l">
               <a:lnSpc>
-                <a:spcPct val="120000"/>
-              </a:lnSpc>
-            </a:pPr>
-            <a:r>
-              <a:rPr sz="1600" b="1">
+                <a:spcPct val="118000"/>
+              </a:lnSpc>
+            </a:pPr>
+            <a:r>
+              <a:rPr sz="2200" b="1">
                 <a:solidFill>
                   <a:srgbClr val="FFFFFF"/>
                 </a:solidFill>
                 <a:latin typeface="League Spartan"/>
               </a:rPr>
-              <a:t>Confirm Priority</a:t>
+              <a:t>Pilot the</a:t>
             </a:r>
           </a:p>
           <a:p>
             <a:pPr algn="l">
               <a:lnSpc>
-                <a:spcPct val="120000"/>
-              </a:lnSpc>
-            </a:pPr>
-            <a:r>
-              <a:rPr sz="1600" b="1">
+                <a:spcPct val="118000"/>
+              </a:lnSpc>
+            </a:pPr>
+            <a:r>
+              <a:rPr sz="2200" b="1">
                 <a:solidFill>
                   <a:srgbClr val="FFFFFF"/>
                 </a:solidFill>
                 <a:latin typeface="League Spartan"/>
               </a:rPr>
-              <a:t>and Budget</a:t>
+              <a:t>Start Group</a:t>
             </a:r>
           </a:p>
         </p:txBody>
@@ -9869,8 +9869,8 @@
         </p:nvSpPr>
         <p:spPr>
           <a:xfrm>
-            <a:off x="4445000" y="1765300"/>
-            <a:ext cx="6985000" cy="528320"/>
+            <a:off x="5334000" y="2120900"/>
+            <a:ext cx="6096000" cy="650240"/>
           </a:xfrm>
           <a:prstGeom prst="rect">
             <a:avLst/>
@@ -9895,7 +9895,7 @@
                 </a:solidFill>
                 <a:latin typeface="Inter"/>
               </a:rPr>
-              <a:t>Gauge with the Executive Board whether this is a priority now.</a:t>
+              <a:t>Launch with a self-scaling license. On-site instructor training support from the Eduface team at pilot start. Target launch December 2026.</a:t>
             </a:r>
           </a:p>
         </p:txBody>
@@ -9908,12 +9908,12 @@
         </p:nvSpPr>
         <p:spPr>
           <a:xfrm>
-            <a:off x="1219200" y="2628900"/>
-            <a:ext cx="508000" cy="508000"/>
+            <a:off x="1270000" y="3454400"/>
+            <a:ext cx="711200" cy="711200"/>
           </a:xfrm>
           <a:prstGeom prst="roundRect">
             <a:avLst>
-              <a:gd name="adj" fmla="val 22500"/>
+              <a:gd name="adj" fmla="val 19642"/>
             </a:avLst>
           </a:prstGeom>
           <a:solidFill>
@@ -9948,7 +9948,7 @@
       </p:sp>
       <p:pic>
         <p:nvPicPr>
-          <p:cNvPr id="11" name="Picture 10" descr="icon-globe-green.png"/>
+          <p:cNvPr id="11" name="Picture 10" descr="icon-route-green.png"/>
           <p:cNvPicPr>
             <a:picLocks noChangeAspect="1"/>
           </p:cNvPicPr>
@@ -9962,8 +9962,8 @@
         </p:blipFill>
         <p:spPr>
           <a:xfrm>
-            <a:off x="1346200" y="2755900"/>
-            <a:ext cx="254000" cy="254000"/>
+            <a:off x="1447800" y="3632200"/>
+            <a:ext cx="355600" cy="355600"/>
           </a:xfrm>
           <a:prstGeom prst="rect">
             <a:avLst/>
@@ -9978,8 +9978,8 @@
         </p:nvSpPr>
         <p:spPr>
           <a:xfrm>
-            <a:off x="762000" y="2768600"/>
-            <a:ext cx="355600" cy="228600"/>
+            <a:off x="762000" y="3670300"/>
+            <a:ext cx="406400" cy="279400"/>
           </a:xfrm>
           <a:prstGeom prst="rect">
             <a:avLst/>
@@ -9998,7 +9998,7 @@
               </a:lnSpc>
             </a:pPr>
             <a:r>
-              <a:rPr sz="1200" b="0">
+              <a:rPr sz="1600" b="0">
                 <a:solidFill>
                   <a:srgbClr val="9EABB1"/>
                 </a:solidFill>
@@ -10017,8 +10017,8 @@
         </p:nvSpPr>
         <p:spPr>
           <a:xfrm>
-            <a:off x="1981200" y="2578100"/>
-            <a:ext cx="2159000" cy="528320"/>
+            <a:off x="2235200" y="3365500"/>
+            <a:ext cx="2794000" cy="726440"/>
           </a:xfrm>
           <a:prstGeom prst="rect">
             <a:avLst/>
@@ -10033,33 +10033,33 @@
           <a:p>
             <a:pPr algn="l">
               <a:lnSpc>
-                <a:spcPct val="120000"/>
-              </a:lnSpc>
-            </a:pPr>
-            <a:r>
-              <a:rPr sz="1600" b="1">
+                <a:spcPct val="118000"/>
+              </a:lnSpc>
+            </a:pPr>
+            <a:r>
+              <a:rPr sz="2200" b="1">
                 <a:solidFill>
                   <a:srgbClr val="FFFFFF"/>
                 </a:solidFill>
                 <a:latin typeface="League Spartan"/>
               </a:rPr>
-              <a:t>Validate</a:t>
+              <a:t>Programmatic</a:t>
             </a:r>
           </a:p>
           <a:p>
             <a:pPr algn="l">
               <a:lnSpc>
-                <a:spcPct val="120000"/>
-              </a:lnSpc>
-            </a:pPr>
-            <a:r>
-              <a:rPr sz="1600" b="1">
+                <a:spcPct val="118000"/>
+              </a:lnSpc>
+            </a:pPr>
+            <a:r>
+              <a:rPr sz="2200" b="1">
                 <a:solidFill>
                   <a:srgbClr val="FFFFFF"/>
                 </a:solidFill>
                 <a:latin typeface="League Spartan"/>
               </a:rPr>
-              <a:t>in the U.S.</a:t>
+              <a:t>Expansion</a:t>
             </a:r>
           </a:p>
         </p:txBody>
@@ -10072,8 +10072,8 @@
         </p:nvSpPr>
         <p:spPr>
           <a:xfrm>
-            <a:off x="4445000" y="2578100"/>
-            <a:ext cx="6985000" cy="528320"/>
+            <a:off x="5334000" y="3390900"/>
+            <a:ext cx="6096000" cy="650240"/>
           </a:xfrm>
           <a:prstGeom prst="rect">
             <a:avLst/>
@@ -10098,7 +10098,7 @@
                 </a:solidFill>
                 <a:latin typeface="Inter"/>
               </a:rPr>
-              <a:t>On-site with instructors, students, and leadership. Legal and IT validation, approximately one month or more.</a:t>
+              <a:t>Roll out to additional program(s) following pilot success.</a:t>
             </a:r>
           </a:p>
         </p:txBody>
@@ -10111,12 +10111,12 @@
         </p:nvSpPr>
         <p:spPr>
           <a:xfrm>
-            <a:off x="1219200" y="3441700"/>
-            <a:ext cx="508000" cy="508000"/>
+            <a:off x="1270000" y="4724400"/>
+            <a:ext cx="711200" cy="711200"/>
           </a:xfrm>
           <a:prstGeom prst="roundRect">
             <a:avLst>
-              <a:gd name="adj" fmla="val 22500"/>
+              <a:gd name="adj" fmla="val 19642"/>
             </a:avLst>
           </a:prstGeom>
           <a:solidFill>
@@ -10151,7 +10151,7 @@
       </p:sp>
       <p:pic>
         <p:nvPicPr>
-          <p:cNvPr id="16" name="Picture 15" descr="icon-vlag-green.png"/>
+          <p:cNvPr id="16" name="Picture 15" descr="icon-kalender-green.png"/>
           <p:cNvPicPr>
             <a:picLocks noChangeAspect="1"/>
           </p:cNvPicPr>
@@ -10165,8 +10165,8 @@
         </p:blipFill>
         <p:spPr>
           <a:xfrm>
-            <a:off x="1346200" y="3568700"/>
-            <a:ext cx="254000" cy="254000"/>
+            <a:off x="1447800" y="4902200"/>
+            <a:ext cx="355600" cy="355600"/>
           </a:xfrm>
           <a:prstGeom prst="rect">
             <a:avLst/>
@@ -10181,8 +10181,8 @@
         </p:nvSpPr>
         <p:spPr>
           <a:xfrm>
-            <a:off x="762000" y="3581400"/>
-            <a:ext cx="355600" cy="228600"/>
+            <a:off x="762000" y="4940300"/>
+            <a:ext cx="406400" cy="279400"/>
           </a:xfrm>
           <a:prstGeom prst="rect">
             <a:avLst/>
@@ -10201,7 +10201,7 @@
               </a:lnSpc>
             </a:pPr>
             <a:r>
-              <a:rPr sz="1200" b="0">
+              <a:rPr sz="1600" b="0">
                 <a:solidFill>
                   <a:srgbClr val="9EABB1"/>
                 </a:solidFill>
@@ -10220,8 +10220,8 @@
         </p:nvSpPr>
         <p:spPr>
           <a:xfrm>
-            <a:off x="1981200" y="3390900"/>
-            <a:ext cx="2159000" cy="528320"/>
+            <a:off x="2235200" y="4635500"/>
+            <a:ext cx="2794000" cy="726440"/>
           </a:xfrm>
           <a:prstGeom prst="rect">
             <a:avLst/>
@@ -10236,33 +10236,33 @@
           <a:p>
             <a:pPr algn="l">
               <a:lnSpc>
-                <a:spcPct val="120000"/>
-              </a:lnSpc>
-            </a:pPr>
-            <a:r>
-              <a:rPr sz="1600" b="1">
+                <a:spcPct val="118000"/>
+              </a:lnSpc>
+            </a:pPr>
+            <a:r>
+              <a:rPr sz="2200" b="1">
                 <a:solidFill>
                   <a:srgbClr val="FFFFFF"/>
                 </a:solidFill>
                 <a:latin typeface="League Spartan"/>
               </a:rPr>
-              <a:t>Pilot the</a:t>
+              <a:t>Full Institutional</a:t>
             </a:r>
           </a:p>
           <a:p>
             <a:pPr algn="l">
               <a:lnSpc>
-                <a:spcPct val="120000"/>
-              </a:lnSpc>
-            </a:pPr>
-            <a:r>
-              <a:rPr sz="1600" b="1">
+                <a:spcPct val="118000"/>
+              </a:lnSpc>
+            </a:pPr>
+            <a:r>
+              <a:rPr sz="2200" b="1">
                 <a:solidFill>
                   <a:srgbClr val="FFFFFF"/>
                 </a:solidFill>
                 <a:latin typeface="League Spartan"/>
               </a:rPr>
-              <a:t>Start Group</a:t>
+              <a:t>Integration</a:t>
             </a:r>
           </a:p>
         </p:txBody>
@@ -10275,8 +10275,8 @@
         </p:nvSpPr>
         <p:spPr>
           <a:xfrm>
-            <a:off x="4445000" y="3390900"/>
-            <a:ext cx="6985000" cy="528320"/>
+            <a:off x="5334000" y="4660900"/>
+            <a:ext cx="6096000" cy="650240"/>
           </a:xfrm>
           <a:prstGeom prst="rect">
             <a:avLst/>
@@ -10301,29 +10301,27 @@
                 </a:solidFill>
                 <a:latin typeface="Inter"/>
               </a:rPr>
-              <a:t>Launch with a self-scaling license. On-site instructor training support from the Eduface team at pilot start. Target launch December 2026.</a:t>
-            </a:r>
-          </a:p>
-        </p:txBody>
-      </p:sp>
-      <p:sp>
-        <p:nvSpPr>
-          <p:cNvPr id="20" name="Rounded Rectangle 19"/>
+              <a:t>Roll out institution-wide from next academic year.</a:t>
+            </a:r>
+          </a:p>
+        </p:txBody>
+      </p:sp>
+      <p:sp>
+        <p:nvSpPr>
+          <p:cNvPr id="20" name="Rectangle 19"/>
           <p:cNvSpPr/>
           <p:nvPr/>
         </p:nvSpPr>
         <p:spPr>
           <a:xfrm>
-            <a:off x="1219200" y="4254500"/>
-            <a:ext cx="508000" cy="508000"/>
-          </a:xfrm>
-          <a:prstGeom prst="roundRect">
-            <a:avLst>
-              <a:gd name="adj" fmla="val 22500"/>
-            </a:avLst>
+            <a:off x="762000" y="6045200"/>
+            <a:ext cx="10668000" cy="6350"/>
+          </a:xfrm>
+          <a:prstGeom prst="rect">
+            <a:avLst/>
           </a:prstGeom>
           <a:solidFill>
-            <a:srgbClr val="0A2C3B"/>
+            <a:srgbClr val="1F3D4B"/>
           </a:solidFill>
           <a:ln>
             <a:noFill/>
@@ -10354,7 +10352,7 @@
       </p:sp>
       <p:pic>
         <p:nvPicPr>
-          <p:cNvPr id="21" name="Picture 20" descr="icon-route-green.png"/>
+          <p:cNvPr id="21" name="Picture 20" descr="logo_white.png"/>
           <p:cNvPicPr>
             <a:picLocks noChangeAspect="1"/>
           </p:cNvPicPr>
@@ -10368,8 +10366,8 @@
         </p:blipFill>
         <p:spPr>
           <a:xfrm>
-            <a:off x="1346200" y="4381500"/>
-            <a:ext cx="254000" cy="254000"/>
+            <a:off x="762000" y="6324600"/>
+            <a:ext cx="934528" cy="254000"/>
           </a:xfrm>
           <a:prstGeom prst="rect">
             <a:avLst/>
@@ -10378,155 +10376,20 @@
       </p:pic>
       <p:sp>
         <p:nvSpPr>
-          <p:cNvPr id="22" name="TextBox 21"/>
-          <p:cNvSpPr txBox="1"/>
-          <p:nvPr/>
-        </p:nvSpPr>
-        <p:spPr>
-          <a:xfrm>
-            <a:off x="762000" y="4394200"/>
-            <a:ext cx="355600" cy="228600"/>
-          </a:xfrm>
-          <a:prstGeom prst="rect">
-            <a:avLst/>
-          </a:prstGeom>
-          <a:noFill/>
-        </p:spPr>
-        <p:txBody>
-          <a:bodyPr wrap="square" lIns="0" rIns="0" tIns="0" bIns="0">
-            <a:spAutoFit/>
-          </a:bodyPr>
-          <a:lstStyle/>
-          <a:p>
-            <a:pPr algn="l">
-              <a:lnSpc>
-                <a:spcPct val="100000"/>
-              </a:lnSpc>
-            </a:pPr>
-            <a:r>
-              <a:rPr sz="1200" b="0">
-                <a:solidFill>
-                  <a:srgbClr val="9EABB1"/>
-                </a:solidFill>
-                <a:latin typeface="League Spartan"/>
-              </a:rPr>
-              <a:t>04</a:t>
-            </a:r>
-          </a:p>
-        </p:txBody>
-      </p:sp>
-      <p:sp>
-        <p:nvSpPr>
-          <p:cNvPr id="23" name="TextBox 22"/>
-          <p:cNvSpPr txBox="1"/>
-          <p:nvPr/>
-        </p:nvSpPr>
-        <p:spPr>
-          <a:xfrm>
-            <a:off x="1981200" y="4203700"/>
-            <a:ext cx="2159000" cy="528320"/>
-          </a:xfrm>
-          <a:prstGeom prst="rect">
-            <a:avLst/>
-          </a:prstGeom>
-          <a:noFill/>
-        </p:spPr>
-        <p:txBody>
-          <a:bodyPr wrap="square" lIns="0" rIns="0" tIns="0" bIns="0">
-            <a:spAutoFit/>
-          </a:bodyPr>
-          <a:lstStyle/>
-          <a:p>
-            <a:pPr algn="l">
-              <a:lnSpc>
-                <a:spcPct val="120000"/>
-              </a:lnSpc>
-            </a:pPr>
-            <a:r>
-              <a:rPr sz="1600" b="1">
-                <a:solidFill>
-                  <a:srgbClr val="FFFFFF"/>
-                </a:solidFill>
-                <a:latin typeface="League Spartan"/>
-              </a:rPr>
-              <a:t>Programmatic</a:t>
-            </a:r>
-          </a:p>
-          <a:p>
-            <a:pPr algn="l">
-              <a:lnSpc>
-                <a:spcPct val="120000"/>
-              </a:lnSpc>
-            </a:pPr>
-            <a:r>
-              <a:rPr sz="1600" b="1">
-                <a:solidFill>
-                  <a:srgbClr val="FFFFFF"/>
-                </a:solidFill>
-                <a:latin typeface="League Spartan"/>
-              </a:rPr>
-              <a:t>Expansion</a:t>
-            </a:r>
-          </a:p>
-        </p:txBody>
-      </p:sp>
-      <p:sp>
-        <p:nvSpPr>
-          <p:cNvPr id="24" name="TextBox 23"/>
-          <p:cNvSpPr txBox="1"/>
-          <p:nvPr/>
-        </p:nvSpPr>
-        <p:spPr>
-          <a:xfrm>
-            <a:off x="4445000" y="4203700"/>
-            <a:ext cx="6985000" cy="528320"/>
-          </a:xfrm>
-          <a:prstGeom prst="rect">
-            <a:avLst/>
-          </a:prstGeom>
-          <a:noFill/>
-        </p:spPr>
-        <p:txBody>
-          <a:bodyPr wrap="square" lIns="0" rIns="0" tIns="0" bIns="0">
-            <a:spAutoFit/>
-          </a:bodyPr>
-          <a:lstStyle/>
-          <a:p>
-            <a:pPr algn="l">
-              <a:lnSpc>
-                <a:spcPct val="145000"/>
-              </a:lnSpc>
-            </a:pPr>
-            <a:r>
-              <a:rPr sz="1600" b="0">
-                <a:solidFill>
-                  <a:srgbClr val="9EABB1"/>
-                </a:solidFill>
-                <a:latin typeface="Inter"/>
-              </a:rPr>
-              <a:t>Roll out to additional programs following pilot success.</a:t>
-            </a:r>
-          </a:p>
-        </p:txBody>
-      </p:sp>
-      <p:sp>
-        <p:nvSpPr>
-          <p:cNvPr id="25" name="Rounded Rectangle 24"/>
+          <p:cNvPr id="22" name="Rectangle 21"/>
           <p:cNvSpPr/>
           <p:nvPr/>
         </p:nvSpPr>
         <p:spPr>
           <a:xfrm>
-            <a:off x="1219200" y="5067300"/>
-            <a:ext cx="508000" cy="508000"/>
-          </a:xfrm>
-          <a:prstGeom prst="roundRect">
-            <a:avLst>
-              <a:gd name="adj" fmla="val 22500"/>
-            </a:avLst>
+            <a:off x="1968500" y="6311900"/>
+            <a:ext cx="6350" cy="279400"/>
+          </a:xfrm>
+          <a:prstGeom prst="rect">
+            <a:avLst/>
           </a:prstGeom>
           <a:solidFill>
-            <a:srgbClr val="0A2C3B"/>
+            <a:srgbClr val="1F3D4B"/>
           </a:solidFill>
           <a:ln>
             <a:noFill/>
@@ -10555,9 +10418,55 @@
           </a:p>
         </p:txBody>
       </p:sp>
+      <p:sp>
+        <p:nvSpPr>
+          <p:cNvPr id="23" name="Rounded Rectangle 22"/>
+          <p:cNvSpPr/>
+          <p:nvPr/>
+        </p:nvSpPr>
+        <p:spPr>
+          <a:xfrm>
+            <a:off x="2133600" y="6184900"/>
+            <a:ext cx="952046" cy="533400"/>
+          </a:xfrm>
+          <a:prstGeom prst="roundRect">
+            <a:avLst>
+              <a:gd name="adj" fmla="val 11904"/>
+            </a:avLst>
+          </a:prstGeom>
+          <a:solidFill>
+            <a:srgbClr val="FFFFFF"/>
+          </a:solidFill>
+          <a:ln>
+            <a:noFill/>
+          </a:ln>
+          <a:effectLst/>
+        </p:spPr>
+        <p:style>
+          <a:lnRef idx="1">
+            <a:schemeClr val="accent1"/>
+          </a:lnRef>
+          <a:fillRef idx="3">
+            <a:schemeClr val="accent1"/>
+          </a:fillRef>
+          <a:effectRef idx="2">
+            <a:schemeClr val="accent1"/>
+          </a:effectRef>
+          <a:fontRef idx="minor">
+            <a:schemeClr val="lt1"/>
+          </a:fontRef>
+        </p:style>
+        <p:txBody>
+          <a:bodyPr rtlCol="0" anchor="ctr"/>
+          <a:lstStyle/>
+          <a:p>
+            <a:pPr algn="ctr"/>
+          </a:p>
+        </p:txBody>
+      </p:sp>
       <p:pic>
         <p:nvPicPr>
-          <p:cNvPr id="26" name="Picture 25" descr="icon-kalender-green.png"/>
+          <p:cNvPr id="24" name="Picture 23" descr="uti-logo.png"/>
           <p:cNvPicPr>
             <a:picLocks noChangeAspect="1"/>
           </p:cNvPicPr>
@@ -10571,8 +10480,8 @@
         </p:blipFill>
         <p:spPr>
           <a:xfrm>
-            <a:off x="1346200" y="5194300"/>
-            <a:ext cx="254000" cy="254000"/>
+            <a:off x="2222500" y="6273800"/>
+            <a:ext cx="774246" cy="355600"/>
           </a:xfrm>
           <a:prstGeom prst="rect">
             <a:avLst/>
@@ -10581,14 +10490,14 @@
       </p:pic>
       <p:sp>
         <p:nvSpPr>
-          <p:cNvPr id="27" name="TextBox 26"/>
+          <p:cNvPr id="25" name="TextBox 24"/>
           <p:cNvSpPr txBox="1"/>
           <p:nvPr/>
         </p:nvSpPr>
         <p:spPr>
           <a:xfrm>
-            <a:off x="762000" y="5207000"/>
-            <a:ext cx="355600" cy="228600"/>
+            <a:off x="5715000" y="6375400"/>
+            <a:ext cx="5080000" cy="243840"/>
           </a:xfrm>
           <a:prstGeom prst="rect">
             <a:avLst/>
@@ -10601,9 +10510,9 @@
           </a:bodyPr>
           <a:lstStyle/>
           <a:p>
-            <a:pPr algn="l">
-              <a:lnSpc>
-                <a:spcPct val="100000"/>
+            <a:pPr algn="r">
+              <a:lnSpc>
+                <a:spcPct val="135000"/>
               </a:lnSpc>
             </a:pPr>
             <a:r>
@@ -10611,323 +10520,8 @@
                 <a:solidFill>
                   <a:srgbClr val="9EABB1"/>
                 </a:solidFill>
-                <a:latin typeface="League Spartan"/>
-              </a:rPr>
-              <a:t>05</a:t>
-            </a:r>
-          </a:p>
-        </p:txBody>
-      </p:sp>
-      <p:sp>
-        <p:nvSpPr>
-          <p:cNvPr id="28" name="TextBox 27"/>
-          <p:cNvSpPr txBox="1"/>
-          <p:nvPr/>
-        </p:nvSpPr>
-        <p:spPr>
-          <a:xfrm>
-            <a:off x="1981200" y="5016500"/>
-            <a:ext cx="2159000" cy="528320"/>
-          </a:xfrm>
-          <a:prstGeom prst="rect">
-            <a:avLst/>
-          </a:prstGeom>
-          <a:noFill/>
-        </p:spPr>
-        <p:txBody>
-          <a:bodyPr wrap="square" lIns="0" rIns="0" tIns="0" bIns="0">
-            <a:spAutoFit/>
-          </a:bodyPr>
-          <a:lstStyle/>
-          <a:p>
-            <a:pPr algn="l">
-              <a:lnSpc>
-                <a:spcPct val="120000"/>
-              </a:lnSpc>
-            </a:pPr>
-            <a:r>
-              <a:rPr sz="1600" b="1">
-                <a:solidFill>
-                  <a:srgbClr val="FFFFFF"/>
-                </a:solidFill>
-                <a:latin typeface="League Spartan"/>
-              </a:rPr>
-              <a:t>Full Institutional</a:t>
-            </a:r>
-          </a:p>
-          <a:p>
-            <a:pPr algn="l">
-              <a:lnSpc>
-                <a:spcPct val="120000"/>
-              </a:lnSpc>
-            </a:pPr>
-            <a:r>
-              <a:rPr sz="1600" b="1">
-                <a:solidFill>
-                  <a:srgbClr val="FFFFFF"/>
-                </a:solidFill>
-                <a:latin typeface="League Spartan"/>
-              </a:rPr>
-              <a:t>Integration</a:t>
-            </a:r>
-          </a:p>
-        </p:txBody>
-      </p:sp>
-      <p:sp>
-        <p:nvSpPr>
-          <p:cNvPr id="29" name="TextBox 28"/>
-          <p:cNvSpPr txBox="1"/>
-          <p:nvPr/>
-        </p:nvSpPr>
-        <p:spPr>
-          <a:xfrm>
-            <a:off x="4445000" y="5016500"/>
-            <a:ext cx="6985000" cy="528320"/>
-          </a:xfrm>
-          <a:prstGeom prst="rect">
-            <a:avLst/>
-          </a:prstGeom>
-          <a:noFill/>
-        </p:spPr>
-        <p:txBody>
-          <a:bodyPr wrap="square" lIns="0" rIns="0" tIns="0" bIns="0">
-            <a:spAutoFit/>
-          </a:bodyPr>
-          <a:lstStyle/>
-          <a:p>
-            <a:pPr algn="l">
-              <a:lnSpc>
-                <a:spcPct val="145000"/>
-              </a:lnSpc>
-            </a:pPr>
-            <a:r>
-              <a:rPr sz="1600" b="0">
-                <a:solidFill>
-                  <a:srgbClr val="9EABB1"/>
-                </a:solidFill>
                 <a:latin typeface="Inter"/>
               </a:rPr>
-              <a:t>Roll out institution-wide from next academic year.</a:t>
-            </a:r>
-          </a:p>
-        </p:txBody>
-      </p:sp>
-      <p:sp>
-        <p:nvSpPr>
-          <p:cNvPr id="30" name="Rectangle 29"/>
-          <p:cNvSpPr/>
-          <p:nvPr/>
-        </p:nvSpPr>
-        <p:spPr>
-          <a:xfrm>
-            <a:off x="762000" y="6045200"/>
-            <a:ext cx="10668000" cy="6350"/>
-          </a:xfrm>
-          <a:prstGeom prst="rect">
-            <a:avLst/>
-          </a:prstGeom>
-          <a:solidFill>
-            <a:srgbClr val="1F3D4B"/>
-          </a:solidFill>
-          <a:ln>
-            <a:noFill/>
-          </a:ln>
-          <a:effectLst/>
-        </p:spPr>
-        <p:style>
-          <a:lnRef idx="1">
-            <a:schemeClr val="accent1"/>
-          </a:lnRef>
-          <a:fillRef idx="3">
-            <a:schemeClr val="accent1"/>
-          </a:fillRef>
-          <a:effectRef idx="2">
-            <a:schemeClr val="accent1"/>
-          </a:effectRef>
-          <a:fontRef idx="minor">
-            <a:schemeClr val="lt1"/>
-          </a:fontRef>
-        </p:style>
-        <p:txBody>
-          <a:bodyPr rtlCol="0" anchor="ctr"/>
-          <a:lstStyle/>
-          <a:p>
-            <a:pPr algn="ctr"/>
-          </a:p>
-        </p:txBody>
-      </p:sp>
-      <p:pic>
-        <p:nvPicPr>
-          <p:cNvPr id="31" name="Picture 30" descr="logo_white.png"/>
-          <p:cNvPicPr>
-            <a:picLocks noChangeAspect="1"/>
-          </p:cNvPicPr>
-          <p:nvPr/>
-        </p:nvPicPr>
-        <p:blipFill>
-          <a:blip r:embed="rId7"/>
-          <a:stretch>
-            <a:fillRect/>
-          </a:stretch>
-        </p:blipFill>
-        <p:spPr>
-          <a:xfrm>
-            <a:off x="762000" y="6324600"/>
-            <a:ext cx="934528" cy="254000"/>
-          </a:xfrm>
-          <a:prstGeom prst="rect">
-            <a:avLst/>
-          </a:prstGeom>
-        </p:spPr>
-      </p:pic>
-      <p:sp>
-        <p:nvSpPr>
-          <p:cNvPr id="32" name="Rectangle 31"/>
-          <p:cNvSpPr/>
-          <p:nvPr/>
-        </p:nvSpPr>
-        <p:spPr>
-          <a:xfrm>
-            <a:off x="1968500" y="6311900"/>
-            <a:ext cx="6350" cy="279400"/>
-          </a:xfrm>
-          <a:prstGeom prst="rect">
-            <a:avLst/>
-          </a:prstGeom>
-          <a:solidFill>
-            <a:srgbClr val="1F3D4B"/>
-          </a:solidFill>
-          <a:ln>
-            <a:noFill/>
-          </a:ln>
-          <a:effectLst/>
-        </p:spPr>
-        <p:style>
-          <a:lnRef idx="1">
-            <a:schemeClr val="accent1"/>
-          </a:lnRef>
-          <a:fillRef idx="3">
-            <a:schemeClr val="accent1"/>
-          </a:fillRef>
-          <a:effectRef idx="2">
-            <a:schemeClr val="accent1"/>
-          </a:effectRef>
-          <a:fontRef idx="minor">
-            <a:schemeClr val="lt1"/>
-          </a:fontRef>
-        </p:style>
-        <p:txBody>
-          <a:bodyPr rtlCol="0" anchor="ctr"/>
-          <a:lstStyle/>
-          <a:p>
-            <a:pPr algn="ctr"/>
-          </a:p>
-        </p:txBody>
-      </p:sp>
-      <p:sp>
-        <p:nvSpPr>
-          <p:cNvPr id="33" name="Rounded Rectangle 32"/>
-          <p:cNvSpPr/>
-          <p:nvPr/>
-        </p:nvSpPr>
-        <p:spPr>
-          <a:xfrm>
-            <a:off x="2133600" y="6184900"/>
-            <a:ext cx="952046" cy="533400"/>
-          </a:xfrm>
-          <a:prstGeom prst="roundRect">
-            <a:avLst>
-              <a:gd name="adj" fmla="val 11904"/>
-            </a:avLst>
-          </a:prstGeom>
-          <a:solidFill>
-            <a:srgbClr val="FFFFFF"/>
-          </a:solidFill>
-          <a:ln>
-            <a:noFill/>
-          </a:ln>
-          <a:effectLst/>
-        </p:spPr>
-        <p:style>
-          <a:lnRef idx="1">
-            <a:schemeClr val="accent1"/>
-          </a:lnRef>
-          <a:fillRef idx="3">
-            <a:schemeClr val="accent1"/>
-          </a:fillRef>
-          <a:effectRef idx="2">
-            <a:schemeClr val="accent1"/>
-          </a:effectRef>
-          <a:fontRef idx="minor">
-            <a:schemeClr val="lt1"/>
-          </a:fontRef>
-        </p:style>
-        <p:txBody>
-          <a:bodyPr rtlCol="0" anchor="ctr"/>
-          <a:lstStyle/>
-          <a:p>
-            <a:pPr algn="ctr"/>
-          </a:p>
-        </p:txBody>
-      </p:sp>
-      <p:pic>
-        <p:nvPicPr>
-          <p:cNvPr id="34" name="Picture 33" descr="uti-logo.png"/>
-          <p:cNvPicPr>
-            <a:picLocks noChangeAspect="1"/>
-          </p:cNvPicPr>
-          <p:nvPr/>
-        </p:nvPicPr>
-        <p:blipFill>
-          <a:blip r:embed="rId8"/>
-          <a:stretch>
-            <a:fillRect/>
-          </a:stretch>
-        </p:blipFill>
-        <p:spPr>
-          <a:xfrm>
-            <a:off x="2222500" y="6273800"/>
-            <a:ext cx="774246" cy="355600"/>
-          </a:xfrm>
-          <a:prstGeom prst="rect">
-            <a:avLst/>
-          </a:prstGeom>
-        </p:spPr>
-      </p:pic>
-      <p:sp>
-        <p:nvSpPr>
-          <p:cNvPr id="35" name="TextBox 34"/>
-          <p:cNvSpPr txBox="1"/>
-          <p:nvPr/>
-        </p:nvSpPr>
-        <p:spPr>
-          <a:xfrm>
-            <a:off x="5715000" y="6375400"/>
-            <a:ext cx="5080000" cy="243840"/>
-          </a:xfrm>
-          <a:prstGeom prst="rect">
-            <a:avLst/>
-          </a:prstGeom>
-          <a:noFill/>
-        </p:spPr>
-        <p:txBody>
-          <a:bodyPr wrap="square" lIns="0" rIns="0" tIns="0" bIns="0">
-            <a:spAutoFit/>
-          </a:bodyPr>
-          <a:lstStyle/>
-          <a:p>
-            <a:pPr algn="r">
-              <a:lnSpc>
-                <a:spcPct val="135000"/>
-              </a:lnSpc>
-            </a:pPr>
-            <a:r>
-              <a:rPr sz="1200" b="0">
-                <a:solidFill>
-                  <a:srgbClr val="9EABB1"/>
-                </a:solidFill>
-                <a:latin typeface="Inter"/>
-              </a:rPr>
               <a:t>Concept, for discussion.</a:t>
             </a:r>
           </a:p>
@@ -10935,7 +10529,7 @@
       </p:sp>
       <p:sp>
         <p:nvSpPr>
-          <p:cNvPr id="36" name="TextBox 35"/>
+          <p:cNvPr id="26" name="TextBox 25"/>
           <p:cNvSpPr txBox="1"/>
           <p:nvPr/>
         </p:nvSpPr>

</xml_diff>